<commit_message>
Remove stray chart-legend swatches on new Pattern J/K slides
The Timeline (J) and Process-Flow (K) slides were duplicated from the Single-Chart
slide; two tiny legend color swatches at y≈7.10" were mistakenly retained by the
skeleton filter (within 0.15" of the footer band) and left as stray outline boxes
at the bottom. Removed all 4 (2 per slide).

Co-Authored-By: Claude Opus 4.8 (1M context) <noreply@anthropic.com>
</commit_message>
<xml_diff>
--- a/backbone_slides.pptx
+++ b/backbone_slides.pptx
@@ -7448,94 +7448,6 @@
       </p:sp>
       <p:sp>
         <p:nvSpPr>
-          <p:cNvPr id="31" name="Rectangle 30"/>
-          <p:cNvSpPr/>
-          <p:nvPr/>
-        </p:nvSpPr>
-        <p:spPr>
-          <a:xfrm>
-            <a:off x="7772400" y="6492240"/>
-            <a:ext cx="182880" cy="164592"/>
-          </a:xfrm>
-          <a:prstGeom prst="rect">
-            <a:avLst/>
-          </a:prstGeom>
-          <a:noFill/>
-          <a:ln w="12700">
-            <a:solidFill>
-              <a:srgbClr val="00754A"/>
-            </a:solidFill>
-          </a:ln>
-        </p:spPr>
-        <p:style>
-          <a:lnRef idx="1">
-            <a:schemeClr val="accent1"/>
-          </a:lnRef>
-          <a:fillRef idx="3">
-            <a:schemeClr val="accent1"/>
-          </a:fillRef>
-          <a:effectRef idx="0">
-            <a:schemeClr val="accent1"/>
-          </a:effectRef>
-          <a:fontRef idx="minor">
-            <a:schemeClr val="lt1"/>
-          </a:fontRef>
-        </p:style>
-        <p:txBody>
-          <a:bodyPr rtlCol="0" anchor="ctr"/>
-          <a:lstStyle/>
-          <a:p>
-            <a:pPr algn="ctr"/>
-            <a:endParaRPr/>
-          </a:p>
-        </p:txBody>
-      </p:sp>
-      <p:sp>
-        <p:nvSpPr>
-          <p:cNvPr id="33" name="Rectangle 32"/>
-          <p:cNvSpPr/>
-          <p:nvPr/>
-        </p:nvSpPr>
-        <p:spPr>
-          <a:xfrm>
-            <a:off x="9601200" y="6492240"/>
-            <a:ext cx="182880" cy="164592"/>
-          </a:xfrm>
-          <a:prstGeom prst="rect">
-            <a:avLst/>
-          </a:prstGeom>
-          <a:noFill/>
-          <a:ln w="12700">
-            <a:solidFill>
-              <a:srgbClr val="006241"/>
-            </a:solidFill>
-          </a:ln>
-        </p:spPr>
-        <p:style>
-          <a:lnRef idx="1">
-            <a:schemeClr val="accent1"/>
-          </a:lnRef>
-          <a:fillRef idx="3">
-            <a:schemeClr val="accent1"/>
-          </a:fillRef>
-          <a:effectRef idx="0">
-            <a:schemeClr val="accent1"/>
-          </a:effectRef>
-          <a:fontRef idx="minor">
-            <a:schemeClr val="lt1"/>
-          </a:fontRef>
-        </p:style>
-        <p:txBody>
-          <a:bodyPr rtlCol="0" anchor="ctr"/>
-          <a:lstStyle/>
-          <a:p>
-            <a:pPr algn="ctr"/>
-            <a:endParaRPr/>
-          </a:p>
-        </p:txBody>
-      </p:sp>
-      <p:sp>
-        <p:nvSpPr>
           <p:cNvPr id="35" name="TextBox 34"/>
           <p:cNvSpPr txBox="1"/>
           <p:nvPr/>
@@ -8410,94 +8322,6 @@
           </a:solidFill>
           <a:ln>
             <a:noFill/>
-          </a:ln>
-        </p:spPr>
-        <p:style>
-          <a:lnRef idx="1">
-            <a:schemeClr val="accent1"/>
-          </a:lnRef>
-          <a:fillRef idx="3">
-            <a:schemeClr val="accent1"/>
-          </a:fillRef>
-          <a:effectRef idx="0">
-            <a:schemeClr val="accent1"/>
-          </a:effectRef>
-          <a:fontRef idx="minor">
-            <a:schemeClr val="lt1"/>
-          </a:fontRef>
-        </p:style>
-        <p:txBody>
-          <a:bodyPr rtlCol="0" anchor="ctr"/>
-          <a:lstStyle/>
-          <a:p>
-            <a:pPr algn="ctr"/>
-            <a:endParaRPr/>
-          </a:p>
-        </p:txBody>
-      </p:sp>
-      <p:sp>
-        <p:nvSpPr>
-          <p:cNvPr id="31" name="Rectangle 30"/>
-          <p:cNvSpPr/>
-          <p:nvPr/>
-        </p:nvSpPr>
-        <p:spPr>
-          <a:xfrm>
-            <a:off x="7772400" y="6492240"/>
-            <a:ext cx="182880" cy="164592"/>
-          </a:xfrm>
-          <a:prstGeom prst="rect">
-            <a:avLst/>
-          </a:prstGeom>
-          <a:noFill/>
-          <a:ln w="12700">
-            <a:solidFill>
-              <a:srgbClr val="00754A"/>
-            </a:solidFill>
-          </a:ln>
-        </p:spPr>
-        <p:style>
-          <a:lnRef idx="1">
-            <a:schemeClr val="accent1"/>
-          </a:lnRef>
-          <a:fillRef idx="3">
-            <a:schemeClr val="accent1"/>
-          </a:fillRef>
-          <a:effectRef idx="0">
-            <a:schemeClr val="accent1"/>
-          </a:effectRef>
-          <a:fontRef idx="minor">
-            <a:schemeClr val="lt1"/>
-          </a:fontRef>
-        </p:style>
-        <p:txBody>
-          <a:bodyPr rtlCol="0" anchor="ctr"/>
-          <a:lstStyle/>
-          <a:p>
-            <a:pPr algn="ctr"/>
-            <a:endParaRPr/>
-          </a:p>
-        </p:txBody>
-      </p:sp>
-      <p:sp>
-        <p:nvSpPr>
-          <p:cNvPr id="33" name="Rectangle 32"/>
-          <p:cNvSpPr/>
-          <p:nvPr/>
-        </p:nvSpPr>
-        <p:spPr>
-          <a:xfrm>
-            <a:off x="9601200" y="6492240"/>
-            <a:ext cx="182880" cy="164592"/>
-          </a:xfrm>
-          <a:prstGeom prst="rect">
-            <a:avLst/>
-          </a:prstGeom>
-          <a:noFill/>
-          <a:ln w="12700">
-            <a:solidFill>
-              <a:srgbClr val="006241"/>
-            </a:solidFill>
           </a:ln>
         </p:spPr>
         <p:style>

</xml_diff>

<commit_message>
Inset Timeline (Pattern J) milestones so end labels fit on-slide
Move the 5 milestone centers inward (1.7"–11.6") and match the rule line, so the
first/last year labels no longer overflow the left/right slide edges. Labels now
sit within the body card (left ≈0.50", right ≈12.80").

Co-Authored-By: Claude Opus 4.8 (1M context) <noreply@anthropic.com>
</commit_message>
<xml_diff>
--- a/backbone_slides.pptx
+++ b/backbone_slides.pptx
@@ -7524,8 +7524,8 @@
         </p:nvSpPr>
         <p:spPr>
           <a:xfrm>
-            <a:off x="914400" y="3310128"/>
-            <a:ext cx="10332720" cy="32004"/>
+            <a:off x="1554480" y="3310128"/>
+            <a:ext cx="9052560" cy="32004"/>
           </a:xfrm>
           <a:prstGeom prst="rect">
             <a:avLst/>
@@ -7567,7 +7567,7 @@
         </p:nvSpPr>
         <p:spPr>
           <a:xfrm>
-            <a:off x="813816" y="3259836"/>
+            <a:off x="1453895" y="3259836"/>
             <a:ext cx="201168" cy="201168"/>
           </a:xfrm>
           <a:prstGeom prst="ellipse">
@@ -7610,7 +7610,7 @@
         </p:nvSpPr>
         <p:spPr>
           <a:xfrm>
-            <a:off x="-91440" y="2697480"/>
+            <a:off x="548639" y="2697480"/>
             <a:ext cx="2011680" cy="365760"/>
           </a:xfrm>
           <a:prstGeom prst="rect">
@@ -7645,7 +7645,7 @@
         </p:nvSpPr>
         <p:spPr>
           <a:xfrm>
-            <a:off x="-182879" y="3639312"/>
+            <a:off x="457200" y="3639312"/>
             <a:ext cx="2194560" cy="822960"/>
           </a:xfrm>
           <a:prstGeom prst="rect">
@@ -7692,7 +7692,7 @@
         </p:nvSpPr>
         <p:spPr>
           <a:xfrm>
-            <a:off x="3396996" y="3259836"/>
+            <a:off x="3717035" y="3259836"/>
             <a:ext cx="201168" cy="201168"/>
           </a:xfrm>
           <a:prstGeom prst="ellipse">
@@ -7735,7 +7735,7 @@
         </p:nvSpPr>
         <p:spPr>
           <a:xfrm>
-            <a:off x="2491740" y="2697480"/>
+            <a:off x="2811779" y="2697480"/>
             <a:ext cx="2011680" cy="365760"/>
           </a:xfrm>
           <a:prstGeom prst="rect">
@@ -7770,7 +7770,7 @@
         </p:nvSpPr>
         <p:spPr>
           <a:xfrm>
-            <a:off x="2400300" y="3639312"/>
+            <a:off x="2720339" y="3639312"/>
             <a:ext cx="2194560" cy="822960"/>
           </a:xfrm>
           <a:prstGeom prst="rect">
@@ -7942,7 +7942,7 @@
         </p:nvSpPr>
         <p:spPr>
           <a:xfrm>
-            <a:off x="8563356" y="3259836"/>
+            <a:off x="8243316" y="3259836"/>
             <a:ext cx="201168" cy="201168"/>
           </a:xfrm>
           <a:prstGeom prst="ellipse">
@@ -7985,7 +7985,7 @@
         </p:nvSpPr>
         <p:spPr>
           <a:xfrm>
-            <a:off x="7658100" y="2697480"/>
+            <a:off x="7338060" y="2697480"/>
             <a:ext cx="2011680" cy="365760"/>
           </a:xfrm>
           <a:prstGeom prst="rect">
@@ -8020,7 +8020,7 @@
         </p:nvSpPr>
         <p:spPr>
           <a:xfrm>
-            <a:off x="7566660" y="3639312"/>
+            <a:off x="7246620" y="3639312"/>
             <a:ext cx="2194560" cy="822960"/>
           </a:xfrm>
           <a:prstGeom prst="rect">
@@ -8067,7 +8067,7 @@
         </p:nvSpPr>
         <p:spPr>
           <a:xfrm>
-            <a:off x="11146536" y="3259836"/>
+            <a:off x="10506456" y="3259836"/>
             <a:ext cx="201168" cy="201168"/>
           </a:xfrm>
           <a:prstGeom prst="ellipse">
@@ -8110,7 +8110,7 @@
         </p:nvSpPr>
         <p:spPr>
           <a:xfrm>
-            <a:off x="10241280" y="2697480"/>
+            <a:off x="9601200" y="2697480"/>
             <a:ext cx="2011680" cy="365760"/>
           </a:xfrm>
           <a:prstGeom prst="rect">
@@ -8145,7 +8145,7 @@
         </p:nvSpPr>
         <p:spPr>
           <a:xfrm>
-            <a:off x="10149840" y="3639312"/>
+            <a:off x="9509760" y="3639312"/>
             <a:ext cx="2194560" cy="822960"/>
           </a:xfrm>
           <a:prstGeom prst="rect">

</xml_diff>

<commit_message>
Resize backbone template text to the podium type scale
Bring the actual template text in line with the new design.md scale so building
from the backbone no longer reads small. 196 runs resized on content slides
(3-11, 13, 14); cover/divider/closing (1/2/12) left as-is. spc updated to match
each new size. Role-aware map: headline 30->32, body labels 14-26, chart/axis
->15-18, KPI numbers ->40-44, chapter ->13, source ->12; footer page number 11pt
is the only sub-12 element (chrome).

Co-Authored-By: Claude Opus 4.8 (1M context) <noreply@anthropic.com>
</commit_message>
<xml_diff>
--- a/backbone_slides.pptx
+++ b/backbone_slides.pptx
@@ -3615,7 +3615,7 @@
           <a:p>
             <a:pPr algn="l"/>
             <a:r>
-              <a:rPr sz="1100" b="1" i="0" spc="-11">
+              <a:rPr sz="1300" b="1" i="0" spc="-13">
                 <a:solidFill>
                   <a:srgbClr val="8E8E93"/>
                 </a:solidFill>
@@ -3679,7 +3679,7 @@
               </a:lnSpc>
             </a:pPr>
             <a:r>
-              <a:rPr sz="3000" b="1" i="0" spc="-30">
+              <a:rPr sz="3200" b="1" i="0" spc="-32">
                 <a:solidFill>
                   <a:srgbClr val="006241"/>
                 </a:solidFill>
@@ -3894,7 +3894,7 @@
           <a:p>
             <a:pPr algn="ctr"/>
             <a:r>
-              <a:rPr sz="1200" b="1" i="0" spc="-12">
+              <a:rPr sz="1400" b="1" i="0" spc="-14">
                 <a:solidFill>
                   <a:srgbClr val="1F1F1F"/>
                 </a:solidFill>
@@ -3964,7 +3964,7 @@
           <a:p>
             <a:pPr algn="ctr"/>
             <a:r>
-              <a:rPr sz="1800" b="1" i="0" spc="-18">
+              <a:rPr sz="2200" b="1" i="0" spc="-22">
                 <a:solidFill>
                   <a:srgbClr val="161616"/>
                 </a:solidFill>
@@ -4003,7 +4003,7 @@
               </a:lnSpc>
             </a:pPr>
             <a:r>
-              <a:rPr sz="1300" b="0" i="0" spc="-13">
+              <a:rPr sz="1600" b="0" i="0" spc="-16">
                 <a:solidFill>
                   <a:srgbClr val="1F1F1F"/>
                 </a:solidFill>
@@ -4173,7 +4173,7 @@
           <a:p>
             <a:pPr algn="ctr"/>
             <a:r>
-              <a:rPr sz="1200" b="1" i="0" spc="-12">
+              <a:rPr sz="1400" b="1" i="0" spc="-14">
                 <a:solidFill>
                   <a:srgbClr val="1F1F1F"/>
                 </a:solidFill>
@@ -4243,7 +4243,7 @@
           <a:p>
             <a:pPr algn="ctr"/>
             <a:r>
-              <a:rPr sz="1800" b="1" i="0" spc="-18">
+              <a:rPr sz="2200" b="1" i="0" spc="-22">
                 <a:solidFill>
                   <a:srgbClr val="161616"/>
                 </a:solidFill>
@@ -4282,7 +4282,7 @@
               </a:lnSpc>
             </a:pPr>
             <a:r>
-              <a:rPr sz="1300" b="0" i="0" spc="-13">
+              <a:rPr sz="1600" b="0" i="0" spc="-16">
                 <a:solidFill>
                   <a:srgbClr val="1F1F1F"/>
                 </a:solidFill>
@@ -4452,7 +4452,7 @@
           <a:p>
             <a:pPr algn="ctr"/>
             <a:r>
-              <a:rPr sz="1200" b="1" i="0" spc="-12">
+              <a:rPr sz="1400" b="1" i="0" spc="-14">
                 <a:solidFill>
                   <a:srgbClr val="1F1F1F"/>
                 </a:solidFill>
@@ -4522,7 +4522,7 @@
           <a:p>
             <a:pPr algn="ctr"/>
             <a:r>
-              <a:rPr sz="1800" b="1" i="0" spc="-18">
+              <a:rPr sz="2200" b="1" i="0" spc="-22">
                 <a:solidFill>
                   <a:srgbClr val="161616"/>
                 </a:solidFill>
@@ -4561,7 +4561,7 @@
               </a:lnSpc>
             </a:pPr>
             <a:r>
-              <a:rPr sz="1300" b="0" i="0" spc="-13">
+              <a:rPr sz="1600" b="0" i="0" spc="-16">
                 <a:solidFill>
                   <a:srgbClr val="1F1F1F"/>
                 </a:solidFill>
@@ -4643,7 +4643,7 @@
           <a:p>
             <a:pPr algn="ctr"/>
             <a:r>
-              <a:rPr sz="1700" b="1" i="0" spc="-17">
+              <a:rPr sz="2000" b="1" i="0" spc="-20">
                 <a:solidFill>
                   <a:srgbClr val="1F1F1F"/>
                 </a:solidFill>
@@ -4678,7 +4678,7 @@
           <a:p>
             <a:pPr algn="l"/>
             <a:r>
-              <a:rPr sz="900" b="0" i="0" spc="-9">
+              <a:rPr sz="1100" b="0" i="0" spc="-11">
                 <a:solidFill>
                   <a:srgbClr val="8E8E93"/>
                 </a:solidFill>
@@ -4773,7 +4773,7 @@
           <a:p>
             <a:pPr algn="l"/>
             <a:r>
-              <a:rPr sz="1100" b="1" i="0" spc="-11">
+              <a:rPr sz="1300" b="1" i="0" spc="-13">
                 <a:solidFill>
                   <a:srgbClr val="8E8E93"/>
                 </a:solidFill>
@@ -4837,7 +4837,7 @@
               </a:lnSpc>
             </a:pPr>
             <a:r>
-              <a:rPr sz="3000" b="1" i="0" spc="-30">
+              <a:rPr sz="3200" b="1" i="0" spc="-32">
                 <a:solidFill>
                   <a:srgbClr val="006241"/>
                 </a:solidFill>
@@ -5006,7 +5006,7 @@
           <a:p>
             <a:pPr algn="l"/>
             <a:r>
-              <a:rPr sz="2000" b="1" i="0" spc="-20">
+              <a:rPr sz="2400" b="1" i="0" spc="-24">
                 <a:solidFill>
                   <a:srgbClr val="161616"/>
                 </a:solidFill>
@@ -5041,7 +5041,7 @@
           <a:p>
             <a:pPr algn="l"/>
             <a:r>
-              <a:rPr sz="1200" b="0" i="0" spc="-12">
+              <a:rPr sz="1400" b="0" i="0" spc="-14">
                 <a:solidFill>
                   <a:srgbClr val="7A7A7A"/>
                 </a:solidFill>
@@ -5122,7 +5122,7 @@
           <a:p>
             <a:pPr algn="ctr"/>
             <a:r>
-              <a:rPr sz="1400" b="1" i="0" spc="-14">
+              <a:rPr sz="1700" b="1" i="0" spc="-17">
                 <a:solidFill>
                   <a:srgbClr val="1F1F1F"/>
                 </a:solidFill>
@@ -5157,7 +5157,7 @@
           <a:p>
             <a:pPr algn="l"/>
             <a:r>
-              <a:rPr sz="1400" b="0" i="0" spc="-14">
+              <a:rPr sz="1700" b="0" i="0" spc="-17">
                 <a:solidFill>
                   <a:srgbClr val="7A7A7A"/>
                 </a:solidFill>
@@ -5544,7 +5544,7 @@
           <a:p>
             <a:pPr algn="ctr"/>
             <a:r>
-              <a:rPr sz="1200" b="0" i="0" spc="-12">
+              <a:rPr sz="1400" b="0" i="0" spc="-14">
                 <a:solidFill>
                   <a:srgbClr val="7A7A7A"/>
                 </a:solidFill>
@@ -5579,7 +5579,7 @@
           <a:p>
             <a:pPr algn="ctr"/>
             <a:r>
-              <a:rPr sz="1200" b="1" i="0" spc="-12">
+              <a:rPr sz="1400" b="1" i="0" spc="-14">
                 <a:solidFill>
                   <a:srgbClr val="006241"/>
                 </a:solidFill>
@@ -5614,7 +5614,7 @@
           <a:p>
             <a:pPr algn="ctr"/>
             <a:r>
-              <a:rPr sz="1200" b="0" i="0" spc="-12">
+              <a:rPr sz="1400" b="0" i="0" spc="-14">
                 <a:solidFill>
                   <a:srgbClr val="7A7A7A"/>
                 </a:solidFill>
@@ -5649,7 +5649,7 @@
           <a:p>
             <a:pPr algn="ctr"/>
             <a:r>
-              <a:rPr sz="1200" b="1" i="0" spc="-12">
+              <a:rPr sz="1400" b="1" i="0" spc="-14">
                 <a:solidFill>
                   <a:srgbClr val="006241"/>
                 </a:solidFill>
@@ -5684,7 +5684,7 @@
           <a:p>
             <a:pPr algn="ctr"/>
             <a:r>
-              <a:rPr sz="1200" b="0" i="0" spc="-12">
+              <a:rPr sz="1400" b="0" i="0" spc="-14">
                 <a:solidFill>
                   <a:srgbClr val="7A7A7A"/>
                 </a:solidFill>
@@ -5719,7 +5719,7 @@
           <a:p>
             <a:pPr algn="ctr"/>
             <a:r>
-              <a:rPr sz="1600" b="1" i="0" spc="-16">
+              <a:rPr sz="2000" b="1" i="0" spc="-20">
                 <a:solidFill>
                   <a:srgbClr val="00754A"/>
                 </a:solidFill>
@@ -5800,7 +5800,7 @@
           <a:p>
             <a:pPr algn="ctr"/>
             <a:r>
-              <a:rPr sz="1400" b="1" i="0" spc="-14">
+              <a:rPr sz="1700" b="1" i="0" spc="-17">
                 <a:solidFill>
                   <a:srgbClr val="1F1F1F"/>
                 </a:solidFill>
@@ -5923,7 +5923,7 @@
           <a:p>
             <a:pPr algn="l"/>
             <a:r>
-              <a:rPr sz="2000" b="1" i="0" spc="-20">
+              <a:rPr sz="2400" b="1" i="0" spc="-24">
                 <a:solidFill>
                   <a:srgbClr val="161616"/>
                 </a:solidFill>
@@ -5958,7 +5958,7 @@
           <a:p>
             <a:pPr algn="l"/>
             <a:r>
-              <a:rPr sz="1200" b="0" i="0" spc="-12">
+              <a:rPr sz="1400" b="0" i="0" spc="-14">
                 <a:solidFill>
                   <a:srgbClr val="7A7A7A"/>
                 </a:solidFill>
@@ -6039,7 +6039,7 @@
           <a:p>
             <a:pPr algn="ctr"/>
             <a:r>
-              <a:rPr sz="1400" b="1" i="0" spc="-14">
+              <a:rPr sz="1700" b="1" i="0" spc="-17">
                 <a:solidFill>
                   <a:srgbClr val="1F1F1F"/>
                 </a:solidFill>
@@ -6074,7 +6074,7 @@
           <a:p>
             <a:pPr algn="l"/>
             <a:r>
-              <a:rPr sz="1400" b="0" i="0" spc="-14">
+              <a:rPr sz="1700" b="0" i="0" spc="-17">
                 <a:solidFill>
                   <a:srgbClr val="7A7A7A"/>
                 </a:solidFill>
@@ -6461,7 +6461,7 @@
           <a:p>
             <a:pPr algn="ctr"/>
             <a:r>
-              <a:rPr sz="1200" b="0" i="0" spc="-12">
+              <a:rPr sz="1400" b="0" i="0" spc="-14">
                 <a:solidFill>
                   <a:srgbClr val="7A7A7A"/>
                 </a:solidFill>
@@ -6496,7 +6496,7 @@
           <a:p>
             <a:pPr algn="ctr"/>
             <a:r>
-              <a:rPr sz="1200" b="1" i="0" spc="-12">
+              <a:rPr sz="1400" b="1" i="0" spc="-14">
                 <a:solidFill>
                   <a:srgbClr val="006241"/>
                 </a:solidFill>
@@ -6531,7 +6531,7 @@
           <a:p>
             <a:pPr algn="ctr"/>
             <a:r>
-              <a:rPr sz="1200" b="0" i="0" spc="-12">
+              <a:rPr sz="1400" b="0" i="0" spc="-14">
                 <a:solidFill>
                   <a:srgbClr val="7A7A7A"/>
                 </a:solidFill>
@@ -6566,7 +6566,7 @@
           <a:p>
             <a:pPr algn="ctr"/>
             <a:r>
-              <a:rPr sz="1200" b="1" i="0" spc="-12">
+              <a:rPr sz="1400" b="1" i="0" spc="-14">
                 <a:solidFill>
                   <a:srgbClr val="006241"/>
                 </a:solidFill>
@@ -6601,7 +6601,7 @@
           <a:p>
             <a:pPr algn="ctr"/>
             <a:r>
-              <a:rPr sz="1200" b="0" i="0" spc="-12">
+              <a:rPr sz="1400" b="0" i="0" spc="-14">
                 <a:solidFill>
                   <a:srgbClr val="7A7A7A"/>
                 </a:solidFill>
@@ -6636,7 +6636,7 @@
           <a:p>
             <a:pPr algn="ctr"/>
             <a:r>
-              <a:rPr sz="1600" b="1" i="0" spc="-16">
+              <a:rPr sz="2000" b="1" i="0" spc="-20">
                 <a:solidFill>
                   <a:srgbClr val="006241"/>
                 </a:solidFill>
@@ -6717,7 +6717,7 @@
           <a:p>
             <a:pPr algn="ctr"/>
             <a:r>
-              <a:rPr sz="1400" b="1" i="0" spc="-14">
+              <a:rPr sz="1700" b="1" i="0" spc="-17">
                 <a:solidFill>
                   <a:srgbClr val="1F1F1F"/>
                 </a:solidFill>
@@ -6752,7 +6752,7 @@
           <a:p>
             <a:pPr algn="ctr"/>
             <a:r>
-              <a:rPr sz="1200" b="0" i="0" spc="-12">
+              <a:rPr sz="1400" b="0" i="0" spc="-14">
                 <a:solidFill>
                   <a:srgbClr val="7A7A7A"/>
                 </a:solidFill>
@@ -6833,7 +6833,7 @@
           <a:p>
             <a:pPr algn="l"/>
             <a:r>
-              <a:rPr sz="1400" b="1" i="0" spc="-14">
+              <a:rPr sz="1700" b="1" i="0" spc="-17">
                 <a:solidFill>
                   <a:srgbClr val="1F1F1F"/>
                 </a:solidFill>
@@ -6868,7 +6868,7 @@
           <a:p>
             <a:pPr algn="l"/>
             <a:r>
-              <a:rPr sz="900" b="0" i="0" spc="-9">
+              <a:rPr sz="1100" b="0" i="0" spc="-11">
                 <a:solidFill>
                   <a:srgbClr val="8E8E93"/>
                 </a:solidFill>
@@ -6903,7 +6903,7 @@
           <a:p>
             <a:pPr algn="r"/>
             <a:r>
-              <a:rPr sz="800" b="0" i="0" spc="-8">
+              <a:rPr sz="1200" b="0" i="0" spc="-12">
                 <a:solidFill>
                   <a:srgbClr val="8E8E93"/>
                 </a:solidFill>
@@ -7325,7 +7325,7 @@
           <a:p>
             <a:pPr algn="l"/>
             <a:r>
-              <a:rPr sz="1100" b="1" i="0" spc="-11">
+              <a:rPr sz="1300" b="1" i="0" spc="-13">
                 <a:solidFill>
                   <a:srgbClr val="8E8E93"/>
                 </a:solidFill>
@@ -7389,7 +7389,7 @@
               </a:lnSpc>
             </a:pPr>
             <a:r>
-              <a:rPr sz="3000" b="1" i="0" spc="-30">
+              <a:rPr sz="3200" b="1" i="0" spc="-32">
                 <a:solidFill>
                   <a:srgbClr val="006241"/>
                 </a:solidFill>
@@ -7470,7 +7470,7 @@
           <a:p>
             <a:pPr algn="l"/>
             <a:r>
-              <a:rPr sz="900" b="0" i="0" spc="-9">
+              <a:rPr sz="1100" b="0" i="0" spc="-11">
                 <a:solidFill>
                   <a:srgbClr val="8E8E93"/>
                 </a:solidFill>
@@ -7505,7 +7505,7 @@
           <a:p>
             <a:pPr algn="r"/>
             <a:r>
-              <a:rPr sz="800" b="0" i="0" spc="-8">
+              <a:rPr sz="1200" b="0" i="0" spc="-12">
                 <a:solidFill>
                   <a:srgbClr val="8E8E93"/>
                 </a:solidFill>
@@ -7626,7 +7626,7 @@
           <a:p>
             <a:pPr algn="ctr"/>
             <a:r>
-              <a:rPr sz="1800" b="1" spc="-18">
+              <a:rPr sz="2200" b="1" spc="-22">
                 <a:solidFill>
                   <a:srgbClr val="006241"/>
                 </a:solidFill>
@@ -7661,7 +7661,7 @@
           <a:p>
             <a:pPr algn="ctr"/>
             <a:r>
-              <a:rPr sz="1200" b="0" spc="-12">
+              <a:rPr sz="1400" b="0" spc="-14">
                 <a:solidFill>
                   <a:srgbClr val="1F1F1F"/>
                 </a:solidFill>
@@ -7673,7 +7673,7 @@
           <a:p>
             <a:pPr algn="ctr"/>
             <a:r>
-              <a:rPr sz="1200" b="0" spc="-12">
+              <a:rPr sz="1400" b="0" spc="-14">
                 <a:solidFill>
                   <a:srgbClr val="1F1F1F"/>
                 </a:solidFill>
@@ -7751,7 +7751,7 @@
           <a:p>
             <a:pPr algn="ctr"/>
             <a:r>
-              <a:rPr sz="1800" b="1" spc="-18">
+              <a:rPr sz="2200" b="1" spc="-22">
                 <a:solidFill>
                   <a:srgbClr val="006241"/>
                 </a:solidFill>
@@ -7786,7 +7786,7 @@
           <a:p>
             <a:pPr algn="ctr"/>
             <a:r>
-              <a:rPr sz="1200" b="0" spc="-12">
+              <a:rPr sz="1400" b="0" spc="-14">
                 <a:solidFill>
                   <a:srgbClr val="1F1F1F"/>
                 </a:solidFill>
@@ -7798,7 +7798,7 @@
           <a:p>
             <a:pPr algn="ctr"/>
             <a:r>
-              <a:rPr sz="1200" b="0" spc="-12">
+              <a:rPr sz="1400" b="0" spc="-14">
                 <a:solidFill>
                   <a:srgbClr val="1F1F1F"/>
                 </a:solidFill>
@@ -7876,7 +7876,7 @@
           <a:p>
             <a:pPr algn="ctr"/>
             <a:r>
-              <a:rPr sz="1800" b="1" spc="-18">
+              <a:rPr sz="2200" b="1" spc="-22">
                 <a:solidFill>
                   <a:srgbClr val="006241"/>
                 </a:solidFill>
@@ -7911,7 +7911,7 @@
           <a:p>
             <a:pPr algn="ctr"/>
             <a:r>
-              <a:rPr sz="1200" b="0" spc="-12">
+              <a:rPr sz="1400" b="0" spc="-14">
                 <a:solidFill>
                   <a:srgbClr val="1F1F1F"/>
                 </a:solidFill>
@@ -7923,7 +7923,7 @@
           <a:p>
             <a:pPr algn="ctr"/>
             <a:r>
-              <a:rPr sz="1200" b="0" spc="-12">
+              <a:rPr sz="1400" b="0" spc="-14">
                 <a:solidFill>
                   <a:srgbClr val="1F1F1F"/>
                 </a:solidFill>
@@ -8001,7 +8001,7 @@
           <a:p>
             <a:pPr algn="ctr"/>
             <a:r>
-              <a:rPr sz="1800" b="1" spc="-18">
+              <a:rPr sz="2200" b="1" spc="-22">
                 <a:solidFill>
                   <a:srgbClr val="006241"/>
                 </a:solidFill>
@@ -8036,7 +8036,7 @@
           <a:p>
             <a:pPr algn="ctr"/>
             <a:r>
-              <a:rPr sz="1200" b="0" spc="-12">
+              <a:rPr sz="1400" b="0" spc="-14">
                 <a:solidFill>
                   <a:srgbClr val="1F1F1F"/>
                 </a:solidFill>
@@ -8048,7 +8048,7 @@
           <a:p>
             <a:pPr algn="ctr"/>
             <a:r>
-              <a:rPr sz="1200" b="0" spc="-12">
+              <a:rPr sz="1400" b="0" spc="-14">
                 <a:solidFill>
                   <a:srgbClr val="1F1F1F"/>
                 </a:solidFill>
@@ -8126,7 +8126,7 @@
           <a:p>
             <a:pPr algn="ctr"/>
             <a:r>
-              <a:rPr sz="1800" b="1" spc="-18">
+              <a:rPr sz="2200" b="1" spc="-22">
                 <a:solidFill>
                   <a:srgbClr val="006241"/>
                 </a:solidFill>
@@ -8161,7 +8161,7 @@
           <a:p>
             <a:pPr algn="ctr"/>
             <a:r>
-              <a:rPr sz="1200" b="0" spc="-12">
+              <a:rPr sz="1400" b="0" spc="-14">
                 <a:solidFill>
                   <a:srgbClr val="1F1F1F"/>
                 </a:solidFill>
@@ -8173,7 +8173,7 @@
           <a:p>
             <a:pPr algn="ctr"/>
             <a:r>
-              <a:rPr sz="1200" b="0" spc="-12">
+              <a:rPr sz="1400" b="0" spc="-14">
                 <a:solidFill>
                   <a:srgbClr val="1F1F1F"/>
                 </a:solidFill>
@@ -8226,7 +8226,7 @@
           <a:p>
             <a:pPr algn="l"/>
             <a:r>
-              <a:rPr sz="1100" b="1" i="0" spc="-11">
+              <a:rPr sz="1300" b="1" i="0" spc="-13">
                 <a:solidFill>
                   <a:srgbClr val="8E8E93"/>
                 </a:solidFill>
@@ -8290,7 +8290,7 @@
               </a:lnSpc>
             </a:pPr>
             <a:r>
-              <a:rPr sz="3000" b="1" i="0" spc="-30">
+              <a:rPr sz="3200" b="1" i="0" spc="-32">
                 <a:solidFill>
                   <a:srgbClr val="006241"/>
                 </a:solidFill>
@@ -8371,7 +8371,7 @@
           <a:p>
             <a:pPr algn="l"/>
             <a:r>
-              <a:rPr sz="900" b="0" i="0" spc="-9">
+              <a:rPr sz="1100" b="0" i="0" spc="-11">
                 <a:solidFill>
                   <a:srgbClr val="8E8E93"/>
                 </a:solidFill>
@@ -8406,7 +8406,7 @@
           <a:p>
             <a:pPr algn="r"/>
             <a:r>
-              <a:rPr sz="800" b="0" i="0" spc="-8">
+              <a:rPr sz="1200" b="0" i="0" spc="-12">
                 <a:solidFill>
                   <a:srgbClr val="8E8E93"/>
                 </a:solidFill>
@@ -8484,7 +8484,7 @@
           <a:p>
             <a:pPr algn="ctr"/>
             <a:r>
-              <a:rPr sz="1500" b="1" spc="-15">
+              <a:rPr sz="1800" b="1" spc="-18">
                 <a:solidFill>
                   <a:srgbClr val="1F1F1F"/>
                 </a:solidFill>
@@ -8519,7 +8519,7 @@
           <a:p>
             <a:pPr algn="ctr"/>
             <a:r>
-              <a:rPr sz="1300" b="0" spc="-13">
+              <a:rPr sz="1600" b="0" spc="-16">
                 <a:solidFill>
                   <a:srgbClr val="6B6B6B"/>
                 </a:solidFill>
@@ -8597,7 +8597,7 @@
           <a:p>
             <a:pPr algn="ctr"/>
             <a:r>
-              <a:rPr sz="1500" b="1" spc="-15">
+              <a:rPr sz="1800" b="1" spc="-18">
                 <a:solidFill>
                   <a:srgbClr val="1F1F1F"/>
                 </a:solidFill>
@@ -8632,7 +8632,7 @@
           <a:p>
             <a:pPr algn="ctr"/>
             <a:r>
-              <a:rPr sz="1300" b="0" spc="-13">
+              <a:rPr sz="1600" b="0" spc="-16">
                 <a:solidFill>
                   <a:srgbClr val="6B6B6B"/>
                 </a:solidFill>
@@ -8710,7 +8710,7 @@
           <a:p>
             <a:pPr algn="ctr"/>
             <a:r>
-              <a:rPr sz="1500" b="1" spc="-15">
+              <a:rPr sz="1800" b="1" spc="-18">
                 <a:solidFill>
                   <a:srgbClr val="1F1F1F"/>
                 </a:solidFill>
@@ -8745,7 +8745,7 @@
           <a:p>
             <a:pPr algn="ctr"/>
             <a:r>
-              <a:rPr sz="1300" b="0" spc="-13">
+              <a:rPr sz="1600" b="0" spc="-16">
                 <a:solidFill>
                   <a:srgbClr val="6B6B6B"/>
                 </a:solidFill>
@@ -8823,7 +8823,7 @@
           <a:p>
             <a:pPr algn="ctr"/>
             <a:r>
-              <a:rPr sz="1500" b="1" spc="-15">
+              <a:rPr sz="1800" b="1" spc="-18">
                 <a:solidFill>
                   <a:srgbClr val="1F1F1F"/>
                 </a:solidFill>
@@ -8858,7 +8858,7 @@
           <a:p>
             <a:pPr algn="ctr"/>
             <a:r>
-              <a:rPr sz="1300" b="0" spc="-13">
+              <a:rPr sz="1600" b="0" spc="-16">
                 <a:solidFill>
                   <a:srgbClr val="6B6B6B"/>
                 </a:solidFill>
@@ -9108,7 +9108,7 @@
           <a:p>
             <a:pPr algn="ctr"/>
             <a:r>
-              <a:rPr sz="1100" b="0" spc="-11">
+              <a:rPr sz="1500" b="0" spc="-15">
                 <a:solidFill>
                   <a:srgbClr val="6B6B6B"/>
                 </a:solidFill>
@@ -9120,7 +9120,7 @@
           <a:p>
             <a:pPr algn="ctr"/>
             <a:r>
-              <a:rPr sz="1100" b="0" spc="-11">
+              <a:rPr sz="1500" b="0" spc="-15">
                 <a:solidFill>
                   <a:srgbClr val="6B6B6B"/>
                 </a:solidFill>
@@ -9572,7 +9572,7 @@
           <a:p>
             <a:pPr algn="l"/>
             <a:r>
-              <a:rPr sz="1100" b="1" i="0" spc="-11">
+              <a:rPr sz="1300" b="1" i="0" spc="-13">
                 <a:solidFill>
                   <a:srgbClr val="8E8E93"/>
                 </a:solidFill>
@@ -9636,7 +9636,7 @@
               </a:lnSpc>
             </a:pPr>
             <a:r>
-              <a:rPr sz="3000" b="1" i="0" spc="-30">
+              <a:rPr sz="3200" b="1" i="0" spc="-32">
                 <a:solidFill>
                   <a:srgbClr val="006241"/>
                 </a:solidFill>
@@ -9717,7 +9717,7 @@
           <a:p>
             <a:pPr algn="l"/>
             <a:r>
-              <a:rPr sz="1400" b="1" i="0" spc="-14">
+              <a:rPr sz="1700" b="1" i="0" spc="-17">
                 <a:solidFill>
                   <a:srgbClr val="161616"/>
                 </a:solidFill>
@@ -9840,7 +9840,7 @@
           <a:p>
             <a:pPr algn="r"/>
             <a:r>
-              <a:rPr sz="1200" b="0" i="0" spc="-12">
+              <a:rPr sz="1400" b="0" i="0" spc="-14">
                 <a:solidFill>
                   <a:srgbClr val="7A7A7A"/>
                 </a:solidFill>
@@ -9919,7 +9919,7 @@
           <a:p>
             <a:pPr algn="r"/>
             <a:r>
-              <a:rPr sz="1200" b="0" i="0" spc="-12">
+              <a:rPr sz="1400" b="0" i="0" spc="-14">
                 <a:solidFill>
                   <a:srgbClr val="7A7A7A"/>
                 </a:solidFill>
@@ -9998,7 +9998,7 @@
           <a:p>
             <a:pPr algn="r"/>
             <a:r>
-              <a:rPr sz="1200" b="0" i="0" spc="-12">
+              <a:rPr sz="1400" b="0" i="0" spc="-14">
                 <a:solidFill>
                   <a:srgbClr val="7A7A7A"/>
                 </a:solidFill>
@@ -10077,7 +10077,7 @@
           <a:p>
             <a:pPr algn="r"/>
             <a:r>
-              <a:rPr sz="1200" b="0" i="0" spc="-12">
+              <a:rPr sz="1400" b="0" i="0" spc="-14">
                 <a:solidFill>
                   <a:srgbClr val="7A7A7A"/>
                 </a:solidFill>
@@ -10154,7 +10154,7 @@
           <a:p>
             <a:pPr algn="r"/>
             <a:r>
-              <a:rPr sz="1200" b="0" i="0" spc="-12">
+              <a:rPr sz="1400" b="0" i="0" spc="-14">
                 <a:solidFill>
                   <a:srgbClr val="7A7A7A"/>
                 </a:solidFill>
@@ -10277,7 +10277,7 @@
           <a:p>
             <a:pPr algn="ctr"/>
             <a:r>
-              <a:rPr sz="1300" b="0" i="0" spc="-13">
+              <a:rPr sz="1600" b="0" i="0" spc="-16">
                 <a:solidFill>
                   <a:srgbClr val="7A7A7A"/>
                 </a:solidFill>
@@ -10400,7 +10400,7 @@
           <a:p>
             <a:pPr algn="ctr"/>
             <a:r>
-              <a:rPr sz="1300" b="0" i="0" spc="-13">
+              <a:rPr sz="1600" b="0" i="0" spc="-16">
                 <a:solidFill>
                   <a:srgbClr val="7A7A7A"/>
                 </a:solidFill>
@@ -10523,7 +10523,7 @@
           <a:p>
             <a:pPr algn="ctr"/>
             <a:r>
-              <a:rPr sz="1300" b="0" i="0" spc="-13">
+              <a:rPr sz="1600" b="0" i="0" spc="-16">
                 <a:solidFill>
                   <a:srgbClr val="7A7A7A"/>
                 </a:solidFill>
@@ -10646,7 +10646,7 @@
           <a:p>
             <a:pPr algn="ctr"/>
             <a:r>
-              <a:rPr sz="1300" b="0" i="0" spc="-13">
+              <a:rPr sz="1600" b="0" i="0" spc="-16">
                 <a:solidFill>
                   <a:srgbClr val="7A7A7A"/>
                 </a:solidFill>
@@ -10725,7 +10725,7 @@
           <a:p>
             <a:pPr algn="l"/>
             <a:r>
-              <a:rPr sz="1200" b="1" i="0" spc="-12">
+              <a:rPr sz="1400" b="1" i="0" spc="-14">
                 <a:solidFill>
                   <a:srgbClr val="161616"/>
                 </a:solidFill>
@@ -10804,7 +10804,7 @@
           <a:p>
             <a:pPr algn="l"/>
             <a:r>
-              <a:rPr sz="1200" b="1" i="0" spc="-12">
+              <a:rPr sz="1400" b="1" i="0" spc="-14">
                 <a:solidFill>
                   <a:srgbClr val="161616"/>
                 </a:solidFill>
@@ -10839,7 +10839,7 @@
           <a:p>
             <a:pPr algn="l"/>
             <a:r>
-              <a:rPr sz="900" b="0" i="0" spc="-9">
+              <a:rPr sz="1100" b="0" i="0" spc="-11">
                 <a:solidFill>
                   <a:srgbClr val="8E8E93"/>
                 </a:solidFill>
@@ -10874,7 +10874,7 @@
           <a:p>
             <a:pPr algn="r"/>
             <a:r>
-              <a:rPr sz="800" b="0" i="0" spc="-8">
+              <a:rPr sz="1200" b="0" i="0" spc="-12">
                 <a:solidFill>
                   <a:srgbClr val="8E8E93"/>
                 </a:solidFill>
@@ -10942,7 +10942,7 @@
           <a:p>
             <a:pPr algn="l"/>
             <a:r>
-              <a:rPr sz="1100" b="1" i="0" spc="-11">
+              <a:rPr sz="1300" b="1" i="0" spc="-13">
                 <a:solidFill>
                   <a:srgbClr val="8E8E93"/>
                 </a:solidFill>
@@ -11006,7 +11006,7 @@
               </a:lnSpc>
             </a:pPr>
             <a:r>
-              <a:rPr sz="3000" b="1" i="0" spc="-30">
+              <a:rPr sz="3200" b="1" i="0" spc="-32">
                 <a:solidFill>
                   <a:srgbClr val="006241"/>
                 </a:solidFill>
@@ -11175,7 +11175,7 @@
           <a:p>
             <a:pPr algn="l"/>
             <a:r>
-              <a:rPr sz="3200" b="1" i="0" spc="-32">
+              <a:rPr sz="4000" b="1" i="0" spc="-40">
                 <a:solidFill>
                   <a:srgbClr val="006241"/>
                 </a:solidFill>
@@ -11210,7 +11210,7 @@
           <a:p>
             <a:pPr algn="l"/>
             <a:r>
-              <a:rPr sz="1200" b="0" i="0" spc="-12">
+              <a:rPr sz="1400" b="0" i="0" spc="-14">
                 <a:solidFill>
                   <a:srgbClr val="7A7A7A"/>
                 </a:solidFill>
@@ -11291,7 +11291,7 @@
           <a:p>
             <a:pPr algn="ctr"/>
             <a:r>
-              <a:rPr sz="1000" b="1" i="0" spc="-10">
+              <a:rPr sz="1400" b="1" i="0" spc="-14">
                 <a:solidFill>
                   <a:srgbClr val="1F1F1F"/>
                 </a:solidFill>
@@ -11414,7 +11414,7 @@
           <a:p>
             <a:pPr algn="l"/>
             <a:r>
-              <a:rPr sz="3200" b="1" i="0" spc="-32">
+              <a:rPr sz="4000" b="1" i="0" spc="-40">
                 <a:solidFill>
                   <a:srgbClr val="006241"/>
                 </a:solidFill>
@@ -11449,7 +11449,7 @@
           <a:p>
             <a:pPr algn="l"/>
             <a:r>
-              <a:rPr sz="1200" b="0" i="0" spc="-12">
+              <a:rPr sz="1400" b="0" i="0" spc="-14">
                 <a:solidFill>
                   <a:srgbClr val="7A7A7A"/>
                 </a:solidFill>
@@ -11530,7 +11530,7 @@
           <a:p>
             <a:pPr algn="ctr"/>
             <a:r>
-              <a:rPr sz="1000" b="1" i="0" spc="-10">
+              <a:rPr sz="1400" b="1" i="0" spc="-14">
                 <a:solidFill>
                   <a:srgbClr val="1F1F1F"/>
                 </a:solidFill>
@@ -11653,7 +11653,7 @@
           <a:p>
             <a:pPr algn="l"/>
             <a:r>
-              <a:rPr sz="3200" b="1" i="0" spc="-32">
+              <a:rPr sz="4000" b="1" i="0" spc="-40">
                 <a:solidFill>
                   <a:srgbClr val="006241"/>
                 </a:solidFill>
@@ -11688,7 +11688,7 @@
           <a:p>
             <a:pPr algn="l"/>
             <a:r>
-              <a:rPr sz="1200" b="0" i="0" spc="-12">
+              <a:rPr sz="1400" b="0" i="0" spc="-14">
                 <a:solidFill>
                   <a:srgbClr val="7A7A7A"/>
                 </a:solidFill>
@@ -11769,7 +11769,7 @@
           <a:p>
             <a:pPr algn="ctr"/>
             <a:r>
-              <a:rPr sz="1000" b="1" i="0" spc="-10">
+              <a:rPr sz="1400" b="1" i="0" spc="-14">
                 <a:solidFill>
                   <a:srgbClr val="1F1F1F"/>
                 </a:solidFill>
@@ -11892,7 +11892,7 @@
           <a:p>
             <a:pPr algn="l"/>
             <a:r>
-              <a:rPr sz="3200" b="1" i="0" spc="-32">
+              <a:rPr sz="4000" b="1" i="0" spc="-40">
                 <a:solidFill>
                   <a:srgbClr val="006241"/>
                 </a:solidFill>
@@ -11927,7 +11927,7 @@
           <a:p>
             <a:pPr algn="l"/>
             <a:r>
-              <a:rPr sz="1200" b="0" i="0" spc="-12">
+              <a:rPr sz="1400" b="0" i="0" spc="-14">
                 <a:solidFill>
                   <a:srgbClr val="7A7A7A"/>
                 </a:solidFill>
@@ -12008,7 +12008,7 @@
           <a:p>
             <a:pPr algn="ctr"/>
             <a:r>
-              <a:rPr sz="1000" b="1" i="0" spc="-10">
+              <a:rPr sz="1400" b="1" i="0" spc="-14">
                 <a:solidFill>
                   <a:srgbClr val="1F1F1F"/>
                 </a:solidFill>
@@ -12089,7 +12089,7 @@
           <a:p>
             <a:pPr algn="l"/>
             <a:r>
-              <a:rPr sz="1300" b="1" i="0" spc="-13">
+              <a:rPr sz="1600" b="1" i="0" spc="-16">
                 <a:solidFill>
                   <a:srgbClr val="161616"/>
                 </a:solidFill>
@@ -12864,7 +12864,7 @@
           <a:p>
             <a:pPr algn="ctr"/>
             <a:r>
-              <a:rPr sz="1100" b="0" i="0" spc="-11">
+              <a:rPr sz="1500" b="0" i="0" spc="-15">
                 <a:solidFill>
                   <a:srgbClr val="7A7A7A"/>
                 </a:solidFill>
@@ -12899,7 +12899,7 @@
           <a:p>
             <a:pPr algn="ctr"/>
             <a:r>
-              <a:rPr sz="1100" b="0" i="0" spc="-11">
+              <a:rPr sz="1500" b="0" i="0" spc="-15">
                 <a:solidFill>
                   <a:srgbClr val="7A7A7A"/>
                 </a:solidFill>
@@ -12934,7 +12934,7 @@
           <a:p>
             <a:pPr algn="ctr"/>
             <a:r>
-              <a:rPr sz="1100" b="0" i="0" spc="-11">
+              <a:rPr sz="1500" b="0" i="0" spc="-15">
                 <a:solidFill>
                   <a:srgbClr val="7A7A7A"/>
                 </a:solidFill>
@@ -12969,7 +12969,7 @@
           <a:p>
             <a:pPr algn="ctr"/>
             <a:r>
-              <a:rPr sz="1100" b="0" i="0" spc="-11">
+              <a:rPr sz="1500" b="0" i="0" spc="-15">
                 <a:solidFill>
                   <a:srgbClr val="7A7A7A"/>
                 </a:solidFill>
@@ -13004,7 +13004,7 @@
           <a:p>
             <a:pPr algn="ctr"/>
             <a:r>
-              <a:rPr sz="1100" b="0" i="0" spc="-11">
+              <a:rPr sz="1500" b="0" i="0" spc="-15">
                 <a:solidFill>
                   <a:srgbClr val="7A7A7A"/>
                 </a:solidFill>
@@ -13039,7 +13039,7 @@
           <a:p>
             <a:pPr algn="l"/>
             <a:r>
-              <a:rPr sz="900" b="0" i="0" spc="-9">
+              <a:rPr sz="1100" b="0" i="0" spc="-11">
                 <a:solidFill>
                   <a:srgbClr val="8E8E93"/>
                 </a:solidFill>
@@ -13074,7 +13074,7 @@
           <a:p>
             <a:pPr algn="r"/>
             <a:r>
-              <a:rPr sz="800" b="0" i="0" spc="-8">
+              <a:rPr sz="1200" b="0" i="0" spc="-12">
                 <a:solidFill>
                   <a:srgbClr val="8E8E93"/>
                 </a:solidFill>
@@ -13142,7 +13142,7 @@
           <a:p>
             <a:pPr algn="l"/>
             <a:r>
-              <a:rPr sz="1100" b="1" i="0" spc="-11">
+              <a:rPr sz="1300" b="1" i="0" spc="-13">
                 <a:solidFill>
                   <a:srgbClr val="8E8E93"/>
                 </a:solidFill>
@@ -13206,7 +13206,7 @@
               </a:lnSpc>
             </a:pPr>
             <a:r>
-              <a:rPr sz="3000" b="1" i="0" spc="-30">
+              <a:rPr sz="3200" b="1" i="0" spc="-32">
                 <a:solidFill>
                   <a:srgbClr val="006241"/>
                 </a:solidFill>
@@ -13287,7 +13287,7 @@
           <a:p>
             <a:pPr algn="l"/>
             <a:r>
-              <a:rPr sz="2200" b="1" i="0" spc="-22">
+              <a:rPr sz="2600" b="1" i="0" spc="-26">
                 <a:solidFill>
                   <a:srgbClr val="161616"/>
                 </a:solidFill>
@@ -13322,7 +13322,7 @@
           <a:p>
             <a:pPr algn="l"/>
             <a:r>
-              <a:rPr sz="1100" b="1" i="0" spc="-11">
+              <a:rPr sz="1500" b="1" i="0" spc="-15">
                 <a:solidFill>
                   <a:srgbClr val="00754A"/>
                 </a:solidFill>
@@ -13357,7 +13357,7 @@
           <a:p>
             <a:pPr algn="l"/>
             <a:r>
-              <a:rPr sz="1500" b="0" i="0" spc="-15">
+              <a:rPr sz="1800" b="0" i="0" spc="-18">
                 <a:solidFill>
                   <a:srgbClr val="1F1F1F"/>
                 </a:solidFill>
@@ -13392,7 +13392,7 @@
           <a:p>
             <a:pPr algn="l"/>
             <a:r>
-              <a:rPr sz="1100" b="1" i="0" spc="-11">
+              <a:rPr sz="1500" b="1" i="0" spc="-15">
                 <a:solidFill>
                   <a:srgbClr val="00754A"/>
                 </a:solidFill>
@@ -13427,7 +13427,7 @@
           <a:p>
             <a:pPr algn="l"/>
             <a:r>
-              <a:rPr sz="1500" b="0" i="0" spc="-15">
+              <a:rPr sz="1800" b="0" i="0" spc="-18">
                 <a:solidFill>
                   <a:srgbClr val="1F1F1F"/>
                 </a:solidFill>
@@ -13462,7 +13462,7 @@
           <a:p>
             <a:pPr algn="l"/>
             <a:r>
-              <a:rPr sz="1100" b="1" i="0" spc="-11">
+              <a:rPr sz="1500" b="1" i="0" spc="-15">
                 <a:solidFill>
                   <a:srgbClr val="00754A"/>
                 </a:solidFill>
@@ -13497,7 +13497,7 @@
           <a:p>
             <a:pPr algn="l"/>
             <a:r>
-              <a:rPr sz="1500" b="0" i="0" spc="-15">
+              <a:rPr sz="1800" b="0" i="0" spc="-18">
                 <a:solidFill>
                   <a:srgbClr val="1F1F1F"/>
                 </a:solidFill>
@@ -13578,7 +13578,7 @@
           <a:p>
             <a:pPr algn="l"/>
             <a:r>
-              <a:rPr sz="1000" b="1" i="0" spc="-10">
+              <a:rPr sz="1400" b="1" i="0" spc="-14">
                 <a:solidFill>
                   <a:srgbClr val="CBA258"/>
                 </a:solidFill>
@@ -13613,7 +13613,7 @@
           <a:p>
             <a:pPr algn="l"/>
             <a:r>
-              <a:rPr sz="1400" b="1" i="0" spc="-14">
+              <a:rPr sz="1700" b="1" i="0" spc="-17">
                 <a:solidFill>
                   <a:srgbClr val="1F1F1F"/>
                 </a:solidFill>
@@ -13694,7 +13694,7 @@
           <a:p>
             <a:pPr algn="l"/>
             <a:r>
-              <a:rPr sz="1300" b="1" i="0" spc="-13">
+              <a:rPr sz="1600" b="1" i="0" spc="-16">
                 <a:solidFill>
                   <a:srgbClr val="161616"/>
                 </a:solidFill>
@@ -13817,7 +13817,7 @@
           <a:p>
             <a:pPr algn="ctr"/>
             <a:r>
-              <a:rPr sz="3600" b="1" i="0" spc="-36">
+              <a:rPr sz="4400" b="1" i="0" spc="-44">
                 <a:solidFill>
                   <a:srgbClr val="006241"/>
                 </a:solidFill>
@@ -13852,7 +13852,7 @@
           <a:p>
             <a:pPr algn="ctr"/>
             <a:r>
-              <a:rPr sz="1100" b="0" i="0" spc="-11">
+              <a:rPr sz="1500" b="0" i="0" spc="-15">
                 <a:solidFill>
                   <a:srgbClr val="7A7A7A"/>
                 </a:solidFill>
@@ -13887,7 +13887,7 @@
           <a:p>
             <a:pPr algn="l"/>
             <a:r>
-              <a:rPr sz="900" b="0" i="0" spc="-9">
+              <a:rPr sz="1100" b="0" i="0" spc="-11">
                 <a:solidFill>
                   <a:srgbClr val="8E8E93"/>
                 </a:solidFill>
@@ -13922,7 +13922,7 @@
           <a:p>
             <a:pPr algn="r"/>
             <a:r>
-              <a:rPr sz="800" b="0" i="0" spc="-8">
+              <a:rPr sz="1200" b="0" i="0" spc="-12">
                 <a:solidFill>
                   <a:srgbClr val="8E8E93"/>
                 </a:solidFill>
@@ -13990,7 +13990,7 @@
           <a:p>
             <a:pPr algn="l"/>
             <a:r>
-              <a:rPr sz="1100" b="1" i="0" spc="-11">
+              <a:rPr sz="1300" b="1" i="0" spc="-13">
                 <a:solidFill>
                   <a:srgbClr val="8E8E93"/>
                 </a:solidFill>
@@ -14054,7 +14054,7 @@
               </a:lnSpc>
             </a:pPr>
             <a:r>
-              <a:rPr sz="3000" b="1" i="0" spc="-30">
+              <a:rPr sz="3200" b="1" i="0" spc="-32">
                 <a:solidFill>
                   <a:srgbClr val="006241"/>
                 </a:solidFill>
@@ -14223,7 +14223,7 @@
           <a:p>
             <a:pPr algn="l"/>
             <a:r>
-              <a:rPr sz="1100" b="1" i="0" spc="-11">
+              <a:rPr sz="1500" b="1" i="0" spc="-15">
                 <a:solidFill>
                   <a:srgbClr val="00754A"/>
                 </a:solidFill>
@@ -14293,7 +14293,7 @@
           <a:p>
             <a:pPr algn="ctr"/>
             <a:r>
-              <a:rPr sz="1200" b="0" i="0" spc="-12">
+              <a:rPr sz="1400" b="0" i="0" spc="-14">
                 <a:solidFill>
                   <a:srgbClr val="7A7A7A"/>
                 </a:solidFill>
@@ -14416,7 +14416,7 @@
           <a:p>
             <a:pPr algn="l"/>
             <a:r>
-              <a:rPr sz="1100" b="1" i="0" spc="-11">
+              <a:rPr sz="1500" b="1" i="0" spc="-15">
                 <a:solidFill>
                   <a:srgbClr val="00754A"/>
                 </a:solidFill>
@@ -14486,7 +14486,7 @@
           <a:p>
             <a:pPr algn="ctr"/>
             <a:r>
-              <a:rPr sz="1200" b="0" i="0" spc="-12">
+              <a:rPr sz="1400" b="0" i="0" spc="-14">
                 <a:solidFill>
                   <a:srgbClr val="7A7A7A"/>
                 </a:solidFill>
@@ -14609,7 +14609,7 @@
           <a:p>
             <a:pPr algn="l"/>
             <a:r>
-              <a:rPr sz="1100" b="1" i="0" spc="-11">
+              <a:rPr sz="1500" b="1" i="0" spc="-15">
                 <a:solidFill>
                   <a:srgbClr val="00754A"/>
                 </a:solidFill>
@@ -14679,7 +14679,7 @@
           <a:p>
             <a:pPr algn="ctr"/>
             <a:r>
-              <a:rPr sz="1200" b="0" i="0" spc="-12">
+              <a:rPr sz="1400" b="0" i="0" spc="-14">
                 <a:solidFill>
                   <a:srgbClr val="7A7A7A"/>
                 </a:solidFill>
@@ -14760,7 +14760,7 @@
           <a:p>
             <a:pPr algn="l"/>
             <a:r>
-              <a:rPr sz="1300" b="1" i="0" spc="-13">
+              <a:rPr sz="1600" b="1" i="0" spc="-16">
                 <a:solidFill>
                   <a:srgbClr val="161616"/>
                 </a:solidFill>
@@ -14839,7 +14839,7 @@
           <a:p>
             <a:pPr algn="ctr"/>
             <a:r>
-              <a:rPr sz="1200" b="1" i="0" spc="-12">
+              <a:rPr sz="1400" b="1" i="0" spc="-14">
                 <a:solidFill>
                   <a:srgbClr val="00754A"/>
                 </a:solidFill>
@@ -14874,7 +14874,7 @@
           <a:p>
             <a:pPr algn="ctr"/>
             <a:r>
-              <a:rPr sz="1200" b="0" i="0" spc="-12">
+              <a:rPr sz="1400" b="0" i="0" spc="-14">
                 <a:solidFill>
                   <a:srgbClr val="7A7A7A"/>
                 </a:solidFill>
@@ -14953,7 +14953,7 @@
           <a:p>
             <a:pPr algn="ctr"/>
             <a:r>
-              <a:rPr sz="1200" b="1" i="0" spc="-12">
+              <a:rPr sz="1400" b="1" i="0" spc="-14">
                 <a:solidFill>
                   <a:srgbClr val="00754A"/>
                 </a:solidFill>
@@ -14988,7 +14988,7 @@
           <a:p>
             <a:pPr algn="ctr"/>
             <a:r>
-              <a:rPr sz="1200" b="0" i="0" spc="-12">
+              <a:rPr sz="1400" b="0" i="0" spc="-14">
                 <a:solidFill>
                   <a:srgbClr val="7A7A7A"/>
                 </a:solidFill>
@@ -15067,7 +15067,7 @@
           <a:p>
             <a:pPr algn="ctr"/>
             <a:r>
-              <a:rPr sz="1200" b="1" i="0" spc="-12">
+              <a:rPr sz="1400" b="1" i="0" spc="-14">
                 <a:solidFill>
                   <a:srgbClr val="00754A"/>
                 </a:solidFill>
@@ -15102,7 +15102,7 @@
           <a:p>
             <a:pPr algn="ctr"/>
             <a:r>
-              <a:rPr sz="1200" b="0" i="0" spc="-12">
+              <a:rPr sz="1400" b="0" i="0" spc="-14">
                 <a:solidFill>
                   <a:srgbClr val="7A7A7A"/>
                 </a:solidFill>
@@ -15181,7 +15181,7 @@
           <a:p>
             <a:pPr algn="ctr"/>
             <a:r>
-              <a:rPr sz="1200" b="1" i="0" spc="-12">
+              <a:rPr sz="1400" b="1" i="0" spc="-14">
                 <a:solidFill>
                   <a:srgbClr val="00754A"/>
                 </a:solidFill>
@@ -15216,7 +15216,7 @@
           <a:p>
             <a:pPr algn="ctr"/>
             <a:r>
-              <a:rPr sz="1200" b="0" i="0" spc="-12">
+              <a:rPr sz="1400" b="0" i="0" spc="-14">
                 <a:solidFill>
                   <a:srgbClr val="7A7A7A"/>
                 </a:solidFill>
@@ -15251,7 +15251,7 @@
           <a:p>
             <a:pPr algn="l"/>
             <a:r>
-              <a:rPr sz="900" b="0" i="0" spc="-9">
+              <a:rPr sz="1100" b="0" i="0" spc="-11">
                 <a:solidFill>
                   <a:srgbClr val="8E8E93"/>
                 </a:solidFill>
@@ -15286,7 +15286,7 @@
           <a:p>
             <a:pPr algn="r"/>
             <a:r>
-              <a:rPr sz="800" b="0" i="0" spc="-8">
+              <a:rPr sz="1200" b="0" i="0" spc="-12">
                 <a:solidFill>
                   <a:srgbClr val="8E8E93"/>
                 </a:solidFill>
@@ -15354,7 +15354,7 @@
           <a:p>
             <a:pPr algn="l"/>
             <a:r>
-              <a:rPr sz="1100" b="1" i="0" spc="-11">
+              <a:rPr sz="1300" b="1" i="0" spc="-13">
                 <a:solidFill>
                   <a:srgbClr val="8E8E93"/>
                 </a:solidFill>
@@ -15418,7 +15418,7 @@
               </a:lnSpc>
             </a:pPr>
             <a:r>
-              <a:rPr sz="3000" b="1" i="0" spc="-30">
+              <a:rPr sz="3200" b="1" i="0" spc="-32">
                 <a:solidFill>
                   <a:srgbClr val="006241"/>
                 </a:solidFill>
@@ -15499,7 +15499,7 @@
           <a:p>
             <a:pPr algn="l"/>
             <a:r>
-              <a:rPr sz="1400" b="1" i="0" spc="-14">
+              <a:rPr sz="1700" b="1" i="0" spc="-17">
                 <a:solidFill>
                   <a:srgbClr val="161616"/>
                 </a:solidFill>
@@ -15576,7 +15576,7 @@
           <a:p>
             <a:pPr algn="l"/>
             <a:r>
-              <a:rPr sz="1200" b="1" i="0" spc="-12">
+              <a:rPr sz="1400" b="1" i="0" spc="-14">
                 <a:solidFill>
                   <a:srgbClr val="161616"/>
                 </a:solidFill>
@@ -15611,7 +15611,7 @@
           <a:p>
             <a:pPr algn="ctr"/>
             <a:r>
-              <a:rPr sz="1200" b="1" i="0" spc="-12">
+              <a:rPr sz="1400" b="1" i="0" spc="-14">
                 <a:solidFill>
                   <a:srgbClr val="00754A"/>
                 </a:solidFill>
@@ -15646,7 +15646,7 @@
           <a:p>
             <a:pPr algn="ctr"/>
             <a:r>
-              <a:rPr sz="1200" b="1" i="0" spc="-12">
+              <a:rPr sz="1400" b="1" i="0" spc="-14">
                 <a:solidFill>
                   <a:srgbClr val="006241"/>
                 </a:solidFill>
@@ -15725,7 +15725,7 @@
           <a:p>
             <a:pPr algn="l"/>
             <a:r>
-              <a:rPr sz="1200" b="1" i="0" spc="-12">
+              <a:rPr sz="1400" b="1" i="0" spc="-14">
                 <a:solidFill>
                   <a:srgbClr val="161616"/>
                 </a:solidFill>
@@ -15760,7 +15760,7 @@
           <a:p>
             <a:pPr algn="ctr"/>
             <a:r>
-              <a:rPr sz="1300" b="0" i="0" spc="-13">
+              <a:rPr sz="1600" b="0" i="0" spc="-16">
                 <a:solidFill>
                   <a:srgbClr val="161616"/>
                 </a:solidFill>
@@ -15795,7 +15795,7 @@
           <a:p>
             <a:pPr algn="ctr"/>
             <a:r>
-              <a:rPr sz="1300" b="0" i="0" spc="-13">
+              <a:rPr sz="1600" b="0" i="0" spc="-16">
                 <a:solidFill>
                   <a:srgbClr val="161616"/>
                 </a:solidFill>
@@ -15872,7 +15872,7 @@
           <a:p>
             <a:pPr algn="l"/>
             <a:r>
-              <a:rPr sz="1200" b="1" i="0" spc="-12">
+              <a:rPr sz="1400" b="1" i="0" spc="-14">
                 <a:solidFill>
                   <a:srgbClr val="161616"/>
                 </a:solidFill>
@@ -15907,7 +15907,7 @@
           <a:p>
             <a:pPr algn="ctr"/>
             <a:r>
-              <a:rPr sz="1300" b="1" i="0" spc="-13">
+              <a:rPr sz="1600" b="1" i="0" spc="-16">
                 <a:solidFill>
                   <a:srgbClr val="00754A"/>
                 </a:solidFill>
@@ -15942,7 +15942,7 @@
           <a:p>
             <a:pPr algn="ctr"/>
             <a:r>
-              <a:rPr sz="1300" b="0" i="0" spc="-13">
+              <a:rPr sz="1600" b="0" i="0" spc="-16">
                 <a:solidFill>
                   <a:srgbClr val="161616"/>
                 </a:solidFill>
@@ -16023,7 +16023,7 @@
           <a:p>
             <a:pPr algn="ctr"/>
             <a:r>
-              <a:rPr sz="900" b="1" i="0" spc="-9">
+              <a:rPr sz="1100" b="1" i="0" spc="-11">
                 <a:solidFill>
                   <a:srgbClr val="1F1F1F"/>
                 </a:solidFill>
@@ -16102,7 +16102,7 @@
           <a:p>
             <a:pPr algn="l"/>
             <a:r>
-              <a:rPr sz="1200" b="1" i="0" spc="-12">
+              <a:rPr sz="1400" b="1" i="0" spc="-14">
                 <a:solidFill>
                   <a:srgbClr val="161616"/>
                 </a:solidFill>
@@ -16137,7 +16137,7 @@
           <a:p>
             <a:pPr algn="ctr"/>
             <a:r>
-              <a:rPr sz="1300" b="0" i="0" spc="-13">
+              <a:rPr sz="1600" b="0" i="0" spc="-16">
                 <a:solidFill>
                   <a:srgbClr val="161616"/>
                 </a:solidFill>
@@ -16172,7 +16172,7 @@
           <a:p>
             <a:pPr algn="ctr"/>
             <a:r>
-              <a:rPr sz="1300" b="0" i="0" spc="-13">
+              <a:rPr sz="1600" b="0" i="0" spc="-16">
                 <a:solidFill>
                   <a:srgbClr val="161616"/>
                 </a:solidFill>
@@ -16249,7 +16249,7 @@
           <a:p>
             <a:pPr algn="l"/>
             <a:r>
-              <a:rPr sz="1200" b="1" i="0" spc="-12">
+              <a:rPr sz="1400" b="1" i="0" spc="-14">
                 <a:solidFill>
                   <a:srgbClr val="161616"/>
                 </a:solidFill>
@@ -16284,7 +16284,7 @@
           <a:p>
             <a:pPr algn="ctr"/>
             <a:r>
-              <a:rPr sz="1300" b="1" i="0" spc="-13">
+              <a:rPr sz="1600" b="1" i="0" spc="-16">
                 <a:solidFill>
                   <a:srgbClr val="00754A"/>
                 </a:solidFill>
@@ -16319,7 +16319,7 @@
           <a:p>
             <a:pPr algn="ctr"/>
             <a:r>
-              <a:rPr sz="1300" b="0" i="0" spc="-13">
+              <a:rPr sz="1600" b="0" i="0" spc="-16">
                 <a:solidFill>
                   <a:srgbClr val="161616"/>
                 </a:solidFill>
@@ -16400,7 +16400,7 @@
           <a:p>
             <a:pPr algn="ctr"/>
             <a:r>
-              <a:rPr sz="900" b="1" i="0" spc="-9">
+              <a:rPr sz="1100" b="1" i="0" spc="-11">
                 <a:solidFill>
                   <a:srgbClr val="1F1F1F"/>
                 </a:solidFill>
@@ -16479,7 +16479,7 @@
           <a:p>
             <a:pPr algn="l"/>
             <a:r>
-              <a:rPr sz="1200" b="1" i="0" spc="-12">
+              <a:rPr sz="1400" b="1" i="0" spc="-14">
                 <a:solidFill>
                   <a:srgbClr val="161616"/>
                 </a:solidFill>
@@ -16514,7 +16514,7 @@
           <a:p>
             <a:pPr algn="ctr"/>
             <a:r>
-              <a:rPr sz="1300" b="1" i="0" spc="-13">
+              <a:rPr sz="1600" b="1" i="0" spc="-16">
                 <a:solidFill>
                   <a:srgbClr val="00754A"/>
                 </a:solidFill>
@@ -16549,7 +16549,7 @@
           <a:p>
             <a:pPr algn="ctr"/>
             <a:r>
-              <a:rPr sz="1300" b="0" i="0" spc="-13">
+              <a:rPr sz="1600" b="0" i="0" spc="-16">
                 <a:solidFill>
                   <a:srgbClr val="161616"/>
                 </a:solidFill>
@@ -16630,7 +16630,7 @@
           <a:p>
             <a:pPr algn="ctr"/>
             <a:r>
-              <a:rPr sz="900" b="1" i="0" spc="-9">
+              <a:rPr sz="1100" b="1" i="0" spc="-11">
                 <a:solidFill>
                   <a:srgbClr val="1F1F1F"/>
                 </a:solidFill>
@@ -16707,7 +16707,7 @@
           <a:p>
             <a:pPr algn="l"/>
             <a:r>
-              <a:rPr sz="1200" b="1" i="0" spc="-12">
+              <a:rPr sz="1400" b="1" i="0" spc="-14">
                 <a:solidFill>
                   <a:srgbClr val="161616"/>
                 </a:solidFill>
@@ -16742,7 +16742,7 @@
           <a:p>
             <a:pPr algn="ctr"/>
             <a:r>
-              <a:rPr sz="1300" b="1" i="0" spc="-13">
+              <a:rPr sz="1600" b="1" i="0" spc="-16">
                 <a:solidFill>
                   <a:srgbClr val="00754A"/>
                 </a:solidFill>
@@ -16777,7 +16777,7 @@
           <a:p>
             <a:pPr algn="ctr"/>
             <a:r>
-              <a:rPr sz="1300" b="0" i="0" spc="-13">
+              <a:rPr sz="1600" b="0" i="0" spc="-16">
                 <a:solidFill>
                   <a:srgbClr val="161616"/>
                 </a:solidFill>
@@ -16858,7 +16858,7 @@
           <a:p>
             <a:pPr algn="ctr"/>
             <a:r>
-              <a:rPr sz="900" b="1" i="0" spc="-9">
+              <a:rPr sz="1100" b="1" i="0" spc="-11">
                 <a:solidFill>
                   <a:srgbClr val="1F1F1F"/>
                 </a:solidFill>
@@ -16937,7 +16937,7 @@
           <a:p>
             <a:pPr algn="l"/>
             <a:r>
-              <a:rPr sz="1200" b="1" i="0" spc="-12">
+              <a:rPr sz="1400" b="1" i="0" spc="-14">
                 <a:solidFill>
                   <a:srgbClr val="161616"/>
                 </a:solidFill>
@@ -16972,7 +16972,7 @@
           <a:p>
             <a:pPr algn="ctr"/>
             <a:r>
-              <a:rPr sz="1300" b="0" i="0" spc="-13">
+              <a:rPr sz="1600" b="0" i="0" spc="-16">
                 <a:solidFill>
                   <a:srgbClr val="161616"/>
                 </a:solidFill>
@@ -17007,7 +17007,7 @@
           <a:p>
             <a:pPr algn="ctr"/>
             <a:r>
-              <a:rPr sz="1300" b="0" i="0" spc="-13">
+              <a:rPr sz="1600" b="0" i="0" spc="-16">
                 <a:solidFill>
                   <a:srgbClr val="161616"/>
                 </a:solidFill>
@@ -17042,7 +17042,7 @@
           <a:p>
             <a:pPr algn="l"/>
             <a:r>
-              <a:rPr sz="900" b="0" i="0" spc="-9">
+              <a:rPr sz="1100" b="0" i="0" spc="-11">
                 <a:solidFill>
                   <a:srgbClr val="8E8E93"/>
                 </a:solidFill>
@@ -17077,7 +17077,7 @@
           <a:p>
             <a:pPr algn="r"/>
             <a:r>
-              <a:rPr sz="800" b="0" i="0" spc="-8">
+              <a:rPr sz="1200" b="0" i="0" spc="-12">
                 <a:solidFill>
                   <a:srgbClr val="8E8E93"/>
                 </a:solidFill>
@@ -17145,7 +17145,7 @@
           <a:p>
             <a:pPr algn="l"/>
             <a:r>
-              <a:rPr sz="1100" b="1" i="0" spc="-11">
+              <a:rPr sz="1300" b="1" i="0" spc="-13">
                 <a:solidFill>
                   <a:srgbClr val="8E8E93"/>
                 </a:solidFill>
@@ -17209,7 +17209,7 @@
               </a:lnSpc>
             </a:pPr>
             <a:r>
-              <a:rPr sz="3000" b="1" i="0" spc="-30">
+              <a:rPr sz="3200" b="1" i="0" spc="-32">
                 <a:solidFill>
                   <a:srgbClr val="006241"/>
                 </a:solidFill>
@@ -17336,7 +17336,7 @@
           <a:p>
             <a:pPr algn="l"/>
             <a:r>
-              <a:rPr sz="1100" b="1" i="0" spc="-11">
+              <a:rPr sz="1500" b="1" i="0" spc="-15">
                 <a:solidFill>
                   <a:srgbClr val="CBA258"/>
                 </a:solidFill>
@@ -17371,7 +17371,7 @@
           <a:p>
             <a:pPr algn="l"/>
             <a:r>
-              <a:rPr sz="2200" b="1" i="0" spc="-22">
+              <a:rPr sz="2600" b="1" i="0" spc="-26">
                 <a:solidFill>
                   <a:srgbClr val="1F1F1F"/>
                 </a:solidFill>
@@ -17450,7 +17450,7 @@
           <a:p>
             <a:pPr algn="l"/>
             <a:r>
-              <a:rPr sz="1200" b="1" i="0" spc="-12">
+              <a:rPr sz="1400" b="1" i="0" spc="-14">
                 <a:solidFill>
                   <a:srgbClr val="161616"/>
                 </a:solidFill>
@@ -17573,7 +17573,7 @@
           <a:p>
             <a:pPr algn="ctr"/>
             <a:r>
-              <a:rPr sz="1100" b="0" i="0" spc="-11">
+              <a:rPr sz="1500" b="0" i="0" spc="-15">
                 <a:solidFill>
                   <a:srgbClr val="7A7A7A"/>
                 </a:solidFill>
@@ -17696,7 +17696,7 @@
           <a:p>
             <a:pPr algn="ctr"/>
             <a:r>
-              <a:rPr sz="1100" b="0" i="0" spc="-11">
+              <a:rPr sz="1500" b="0" i="0" spc="-15">
                 <a:solidFill>
                   <a:srgbClr val="7A7A7A"/>
                 </a:solidFill>
@@ -17819,7 +17819,7 @@
           <a:p>
             <a:pPr algn="ctr"/>
             <a:r>
-              <a:rPr sz="1100" b="0" i="0" spc="-11">
+              <a:rPr sz="1500" b="0" i="0" spc="-15">
                 <a:solidFill>
                   <a:srgbClr val="7A7A7A"/>
                 </a:solidFill>
@@ -17942,7 +17942,7 @@
           <a:p>
             <a:pPr algn="ctr"/>
             <a:r>
-              <a:rPr sz="1100" b="0" i="0" spc="-11">
+              <a:rPr sz="1500" b="0" i="0" spc="-15">
                 <a:solidFill>
                   <a:srgbClr val="7A7A7A"/>
                 </a:solidFill>
@@ -18023,7 +18023,7 @@
           <a:p>
             <a:pPr algn="l"/>
             <a:r>
-              <a:rPr sz="1100" b="1" i="0" spc="-11">
+              <a:rPr sz="1500" b="1" i="0" spc="-15">
                 <a:solidFill>
                   <a:srgbClr val="006241"/>
                 </a:solidFill>
@@ -18058,7 +18058,7 @@
           <a:p>
             <a:pPr algn="l"/>
             <a:r>
-              <a:rPr sz="1600" b="1" i="0" spc="-16">
+              <a:rPr sz="2000" b="1" i="0" spc="-20">
                 <a:solidFill>
                   <a:srgbClr val="161616"/>
                 </a:solidFill>
@@ -18093,7 +18093,7 @@
           <a:p>
             <a:pPr algn="l"/>
             <a:r>
-              <a:rPr sz="900" b="0" i="0" spc="-9">
+              <a:rPr sz="1100" b="0" i="0" spc="-11">
                 <a:solidFill>
                   <a:srgbClr val="8E8E93"/>
                 </a:solidFill>
@@ -18128,7 +18128,7 @@
           <a:p>
             <a:pPr algn="r"/>
             <a:r>
-              <a:rPr sz="800" b="0" i="0" spc="-8">
+              <a:rPr sz="1200" b="0" i="0" spc="-12">
                 <a:solidFill>
                   <a:srgbClr val="8E8E93"/>
                 </a:solidFill>
@@ -18196,7 +18196,7 @@
           <a:p>
             <a:pPr algn="l"/>
             <a:r>
-              <a:rPr sz="1100" b="1" i="0" spc="-11">
+              <a:rPr sz="1300" b="1" i="0" spc="-13">
                 <a:solidFill>
                   <a:srgbClr val="8E8E93"/>
                 </a:solidFill>
@@ -18419,7 +18419,7 @@
           <a:p>
             <a:pPr algn="ctr"/>
             <a:r>
-              <a:rPr sz="1500" b="0" i="1" spc="-15">
+              <a:rPr sz="1800" b="0" i="1" spc="-18">
                 <a:solidFill>
                   <a:srgbClr val="7A7A7A"/>
                 </a:solidFill>
@@ -18454,7 +18454,7 @@
           <a:p>
             <a:pPr algn="l"/>
             <a:r>
-              <a:rPr sz="900" b="0" i="0" spc="-9">
+              <a:rPr sz="1100" b="0" i="0" spc="-11">
                 <a:solidFill>
                   <a:srgbClr val="8E8E93"/>
                 </a:solidFill>

</xml_diff>

<commit_message>
Add Pattern L — Text Block (single editable text frame)
The most-used layout — a text-only slide — was missing. Add it as ONE text frame
with multiple bullet paragraphs (Enter per line), not one box per sentence, so it
stays editable; larger type than standard body.

- backbone: new slide 15 — one text box, 7 paragraphs, native ● Green-Accent
  bullets with hanging indent, sizes 24/28/32pt, inline bold-green emphasis runs.
- design.md §5: Pattern L spec (one frame, larger sizes, references the §0 Body
  Text Structure Rule it canonically demonstrates).
- slide-content-prompt.md: Pattern L row + rule "text/bullets in ONE text frame,
  never one box per line; this text-only layout is the default"; pattern range A–L.

Co-Authored-By: Claude Opus 4.8 (1M context) <noreply@anthropic.com>
</commit_message>
<xml_diff>
--- a/backbone_slides.pptx
+++ b/backbone_slides.pptx
@@ -19,6 +19,7 @@
     <p:sldId id="267" r:id="rId13"/>
     <p:sldId id="268" r:id="rId19"/>
     <p:sldId id="269" r:id="rId20"/>
+    <p:sldId id="270" r:id="rId21"/>
   </p:sldIdLst>
   <p:sldSz cx="12192000" cy="6858000"/>
   <p:notesSz cx="6858000" cy="9144000"/>
@@ -9127,6 +9128,439 @@
                 <a:latin typeface="Pretendard"/>
               </a:rPr>
               <a:t>– reason / criterion</a:t>
+            </a:r>
+          </a:p>
+        </p:txBody>
+      </p:sp>
+    </p:spTree>
+  </p:cSld>
+  <p:clrMapOvr>
+    <a:masterClrMapping/>
+  </p:clrMapOvr>
+</p:sld>
+</file>
+
+<file path=ppt/slides/slide15.xml><?xml version="1.0" encoding="utf-8"?>
+<p:sld xmlns:a="http://schemas.openxmlformats.org/drawingml/2006/main" xmlns:p="http://schemas.openxmlformats.org/presentationml/2006/main" xmlns:r="http://schemas.openxmlformats.org/officeDocument/2006/relationships">
+  <p:cSld>
+    <p:spTree>
+      <p:nvGrpSpPr>
+        <p:cNvPr id="1" name=""/>
+        <p:cNvGrpSpPr/>
+        <p:nvPr/>
+      </p:nvGrpSpPr>
+      <p:grpSpPr/>
+      <p:sp>
+        <p:nvSpPr>
+          <p:cNvPr id="2" name="TextBox 1"/>
+          <p:cNvSpPr txBox="1"/>
+          <p:nvPr/>
+        </p:nvSpPr>
+        <p:spPr>
+          <a:xfrm>
+            <a:off x="138257" y="123444"/>
+            <a:ext cx="5486400" cy="256032"/>
+          </a:xfrm>
+          <a:prstGeom prst="rect">
+            <a:avLst/>
+          </a:prstGeom>
+          <a:noFill/>
+        </p:spPr>
+        <p:txBody>
+          <a:bodyPr wrap="square" lIns="0" tIns="0" rIns="0" bIns="0" anchor="t">
+            <a:spAutoFit/>
+          </a:bodyPr>
+          <a:lstStyle/>
+          <a:p>
+            <a:pPr algn="l"/>
+            <a:r>
+              <a:rPr sz="1300" b="1" i="0" spc="-13">
+                <a:solidFill>
+                  <a:srgbClr val="8E8E93"/>
+                </a:solidFill>
+                <a:latin typeface="Pretendard"/>
+              </a:rPr>
+              <a:t>PATTERN L</a:t>
+            </a:r>
+          </a:p>
+        </p:txBody>
+      </p:sp>
+      <p:pic>
+        <p:nvPicPr>
+          <p:cNvPr id="3" name="Picture 2" descr="logo.png"/>
+          <p:cNvPicPr>
+            <a:picLocks noChangeAspect="1"/>
+          </p:cNvPicPr>
+          <p:nvPr/>
+        </p:nvPicPr>
+        <p:blipFill>
+          <a:blip r:embed="rId2"/>
+          <a:srcRect l="3240" t="21391" r="16358" b="11330"/>
+          <a:stretch>
+            <a:fillRect/>
+          </a:stretch>
+        </p:blipFill>
+        <p:spPr>
+          <a:xfrm>
+            <a:off x="10748356" y="11978"/>
+            <a:ext cx="1443644" cy="798573"/>
+          </a:xfrm>
+          <a:prstGeom prst="rect">
+            <a:avLst/>
+          </a:prstGeom>
+        </p:spPr>
+      </p:pic>
+      <p:sp>
+        <p:nvSpPr>
+          <p:cNvPr id="4" name="TextBox 3"/>
+          <p:cNvSpPr txBox="1"/>
+          <p:nvPr/>
+        </p:nvSpPr>
+        <p:spPr>
+          <a:xfrm>
+            <a:off x="251460" y="436260"/>
+            <a:ext cx="10972800" cy="457200"/>
+          </a:xfrm>
+          <a:prstGeom prst="rect">
+            <a:avLst/>
+          </a:prstGeom>
+          <a:noFill/>
+        </p:spPr>
+        <p:txBody>
+          <a:bodyPr wrap="square" lIns="0" tIns="0" rIns="0" bIns="0" anchor="t">
+            <a:spAutoFit/>
+          </a:bodyPr>
+          <a:lstStyle/>
+          <a:p>
+            <a:pPr algn="l">
+              <a:lnSpc>
+                <a:spcPct val="120000"/>
+              </a:lnSpc>
+            </a:pPr>
+            <a:r>
+              <a:rPr sz="3200" b="1" i="0" spc="-32">
+                <a:solidFill>
+                  <a:srgbClr val="006241"/>
+                </a:solidFill>
+                <a:latin typeface="Pretendard"/>
+              </a:rPr>
+              <a:t>Text Block — one editable text frame</a:t>
+            </a:r>
+          </a:p>
+        </p:txBody>
+      </p:sp>
+      <p:sp>
+        <p:nvSpPr>
+          <p:cNvPr id="6" name="Rounded Rectangle 5"/>
+          <p:cNvSpPr/>
+          <p:nvPr/>
+        </p:nvSpPr>
+        <p:spPr>
+          <a:xfrm>
+            <a:off x="251642" y="1290309"/>
+            <a:ext cx="11699382" cy="5227350"/>
+          </a:xfrm>
+          <a:prstGeom prst="roundRect">
+            <a:avLst>
+              <a:gd name="adj" fmla="val 2099"/>
+            </a:avLst>
+          </a:prstGeom>
+          <a:solidFill>
+            <a:srgbClr val="FFFFFF"/>
+          </a:solidFill>
+          <a:ln>
+            <a:noFill/>
+          </a:ln>
+        </p:spPr>
+        <p:style>
+          <a:lnRef idx="1">
+            <a:schemeClr val="accent1"/>
+          </a:lnRef>
+          <a:fillRef idx="3">
+            <a:schemeClr val="accent1"/>
+          </a:fillRef>
+          <a:effectRef idx="0">
+            <a:schemeClr val="accent1"/>
+          </a:effectRef>
+          <a:fontRef idx="minor">
+            <a:schemeClr val="lt1"/>
+          </a:fontRef>
+        </p:style>
+        <p:txBody>
+          <a:bodyPr rtlCol="0" anchor="ctr"/>
+          <a:lstStyle/>
+          <a:p>
+            <a:pPr algn="ctr"/>
+            <a:endParaRPr/>
+          </a:p>
+        </p:txBody>
+      </p:sp>
+      <p:sp>
+        <p:nvSpPr>
+          <p:cNvPr id="35" name="TextBox 34"/>
+          <p:cNvSpPr txBox="1"/>
+          <p:nvPr/>
+        </p:nvSpPr>
+        <p:spPr>
+          <a:xfrm>
+            <a:off x="138257" y="6620256"/>
+            <a:ext cx="548640" cy="228600"/>
+          </a:xfrm>
+          <a:prstGeom prst="rect">
+            <a:avLst/>
+          </a:prstGeom>
+          <a:noFill/>
+        </p:spPr>
+        <p:txBody>
+          <a:bodyPr wrap="square" lIns="0" tIns="0" rIns="0" bIns="0" anchor="t">
+            <a:spAutoFit/>
+          </a:bodyPr>
+          <a:lstStyle/>
+          <a:p>
+            <a:pPr algn="l"/>
+            <a:r>
+              <a:rPr sz="1100" b="0" i="0" spc="-11">
+                <a:solidFill>
+                  <a:srgbClr val="8E8E93"/>
+                </a:solidFill>
+                <a:latin typeface="Pretendard"/>
+              </a:rPr>
+              <a:t>15</a:t>
+            </a:r>
+          </a:p>
+        </p:txBody>
+      </p:sp>
+      <p:sp>
+        <p:nvSpPr>
+          <p:cNvPr id="36" name="TextBox 35"/>
+          <p:cNvSpPr txBox="1"/>
+          <p:nvPr/>
+        </p:nvSpPr>
+        <p:spPr>
+          <a:xfrm>
+            <a:off x="6567403" y="6617421"/>
+            <a:ext cx="5486400" cy="228600"/>
+          </a:xfrm>
+          <a:prstGeom prst="rect">
+            <a:avLst/>
+          </a:prstGeom>
+          <a:noFill/>
+        </p:spPr>
+        <p:txBody>
+          <a:bodyPr wrap="square" lIns="0" tIns="0" rIns="0" bIns="0" anchor="t">
+            <a:spAutoFit/>
+          </a:bodyPr>
+          <a:lstStyle/>
+          <a:p>
+            <a:pPr algn="r"/>
+            <a:r>
+              <a:rPr sz="1200" b="0" i="0" spc="-12">
+                <a:solidFill>
+                  <a:srgbClr val="8E8E93"/>
+                </a:solidFill>
+                <a:latin typeface="Pretendard"/>
+              </a:rPr>
+              <a:t>Source: study cohort  ·  n = NN</a:t>
+            </a:r>
+          </a:p>
+        </p:txBody>
+      </p:sp>
+      <p:sp>
+        <p:nvSpPr>
+          <p:cNvPr id="37" name="TextBox 36"/>
+          <p:cNvSpPr txBox="1"/>
+          <p:nvPr/>
+        </p:nvSpPr>
+        <p:spPr>
+          <a:xfrm>
+            <a:off x="640080" y="1554480"/>
+            <a:ext cx="10881360" cy="4709160"/>
+          </a:xfrm>
+          <a:prstGeom prst="rect">
+            <a:avLst/>
+          </a:prstGeom>
+          <a:noFill/>
+        </p:spPr>
+        <p:txBody>
+          <a:bodyPr wrap="square">
+            <a:noAutofit/>
+          </a:bodyPr>
+          <a:lstStyle/>
+          <a:p>
+            <a:pPr marL="342900" indent="-342900">
+              <a:lnSpc>
+                <a:spcPct val="118000"/>
+              </a:lnSpc>
+              <a:spcBef>
+                <a:spcPts val="1400"/>
+              </a:spcBef>
+              <a:buClr>
+                <a:srgbClr val="00754A"/>
+              </a:buClr>
+              <a:buSzPct val="68000"/>
+              <a:buFont typeface="Arial"/>
+              <a:buChar char="●"/>
+            </a:pPr>
+            <a:r>
+              <a:rPr sz="2800" b="0" spc="-28">
+                <a:solidFill>
+                  <a:srgbClr val="1F1F1F"/>
+                </a:solidFill>
+                <a:latin typeface="Pretendard"/>
+              </a:rPr>
+              <a:t>Primary point — the single message of this slide</a:t>
+            </a:r>
+          </a:p>
+          <a:p>
+            <a:pPr marL="342900" indent="-342900">
+              <a:lnSpc>
+                <a:spcPct val="118000"/>
+              </a:lnSpc>
+              <a:spcBef>
+                <a:spcPts val="1400"/>
+              </a:spcBef>
+              <a:buClr>
+                <a:srgbClr val="00754A"/>
+              </a:buClr>
+              <a:buSzPct val="68000"/>
+              <a:buFont typeface="Arial"/>
+              <a:buChar char="●"/>
+            </a:pPr>
+            <a:r>
+              <a:rPr sz="2800" b="0" spc="-28">
+                <a:solidFill>
+                  <a:srgbClr val="1F1F1F"/>
+                </a:solidFill>
+                <a:latin typeface="Pretendard"/>
+              </a:rPr>
+              <a:t>Supporting line with a </a:t>
+            </a:r>
+            <a:r>
+              <a:rPr sz="2800" b="1" spc="-28">
+                <a:solidFill>
+                  <a:srgbClr val="00754A"/>
+                </a:solidFill>
+                <a:latin typeface="Pretendard"/>
+              </a:rPr>
+              <a:t>key phrase</a:t>
+            </a:r>
+            <a:r>
+              <a:rPr sz="2800" b="0" spc="-28">
+                <a:solidFill>
+                  <a:srgbClr val="1F1F1F"/>
+                </a:solidFill>
+                <a:latin typeface="Pretendard"/>
+              </a:rPr>
+              <a:t> emphasised</a:t>
+            </a:r>
+          </a:p>
+          <a:p>
+            <a:pPr>
+              <a:lnSpc>
+                <a:spcPct val="55000"/>
+              </a:lnSpc>
+              <a:buNone/>
+            </a:pPr>
+          </a:p>
+          <a:p>
+            <a:pPr marL="342900" indent="-342900">
+              <a:lnSpc>
+                <a:spcPct val="118000"/>
+              </a:lnSpc>
+              <a:spcBef>
+                <a:spcPts val="1400"/>
+              </a:spcBef>
+              <a:buClr>
+                <a:srgbClr val="00754A"/>
+              </a:buClr>
+              <a:buSzPct val="68000"/>
+              <a:buFont typeface="Arial"/>
+              <a:buChar char="●"/>
+            </a:pPr>
+            <a:r>
+              <a:rPr sz="3200" b="0" spc="-32">
+                <a:solidFill>
+                  <a:srgbClr val="1F1F1F"/>
+                </a:solidFill>
+                <a:latin typeface="Pretendard"/>
+              </a:rPr>
+              <a:t>A larger line when one statement needs weight</a:t>
+            </a:r>
+          </a:p>
+          <a:p>
+            <a:pPr marL="342900" indent="-342900">
+              <a:lnSpc>
+                <a:spcPct val="118000"/>
+              </a:lnSpc>
+              <a:spcBef>
+                <a:spcPts val="1400"/>
+              </a:spcBef>
+              <a:buClr>
+                <a:srgbClr val="00754A"/>
+              </a:buClr>
+              <a:buSzPct val="68000"/>
+              <a:buFont typeface="Arial"/>
+              <a:buChar char="●"/>
+            </a:pPr>
+            <a:r>
+              <a:rPr sz="2400" b="0" spc="-24">
+                <a:solidFill>
+                  <a:srgbClr val="6B6B6B"/>
+                </a:solidFill>
+                <a:latin typeface="Pretendard"/>
+              </a:rPr>
+              <a:t>secondary detail, one step down</a:t>
+            </a:r>
+          </a:p>
+          <a:p>
+            <a:pPr>
+              <a:lnSpc>
+                <a:spcPct val="55000"/>
+              </a:lnSpc>
+              <a:buNone/>
+            </a:pPr>
+          </a:p>
+          <a:p>
+            <a:pPr marL="342900" indent="-342900">
+              <a:lnSpc>
+                <a:spcPct val="118000"/>
+              </a:lnSpc>
+              <a:spcBef>
+                <a:spcPts val="1400"/>
+              </a:spcBef>
+              <a:buClr>
+                <a:srgbClr val="00754A"/>
+              </a:buClr>
+              <a:buSzPct val="68000"/>
+              <a:buFont typeface="Arial"/>
+              <a:buChar char="●"/>
+            </a:pPr>
+            <a:r>
+              <a:rPr sz="2800" b="0" spc="-28">
+                <a:solidFill>
+                  <a:srgbClr val="1F1F1F"/>
+                </a:solidFill>
+                <a:latin typeface="Pretendard"/>
+              </a:rPr>
+              <a:t>Closing point — </a:t>
+            </a:r>
+            <a:r>
+              <a:rPr sz="2800" b="1" spc="-28">
+                <a:solidFill>
+                  <a:srgbClr val="00754A"/>
+                </a:solidFill>
+                <a:latin typeface="Pretendard"/>
+              </a:rPr>
+              <a:t>the conclusion</a:t>
+            </a:r>
+            <a:r>
+              <a:rPr sz="2800" b="0" spc="-28">
+                <a:solidFill>
+                  <a:srgbClr val="1F1F1F"/>
+                </a:solidFill>
+                <a:latin typeface="Pretendard"/>
+              </a:rPr>
+              <a:t> in bold</a:t>
             </a:r>
           </a:p>
         </p:txBody>

</xml_diff>

<commit_message>
Pattern C: left column claim+bullets in one editable text frame
Same fix as Pattern L, applied to Two-Column. The left column was 7 separate boxes
(claim + three ● markers + three bullet texts); merged into ONE text frame — claim
as a no-bullet level-0 paragraph (26pt bold), supporting points as ● Green-Accent
bullet paragraphs (18pt). Right column / Key-Takeaway strip unchanged. design.md
Pattern C notes the one-frame rule.

Co-Authored-By: Claude Opus 4.8 (1M context) <noreply@anthropic.com>
</commit_message>
<xml_diff>
--- a/backbone_slides.pptx
+++ b/backbone_slides.pptx
@@ -17,9 +17,9 @@
     <p:sldId id="265" r:id="rId11"/>
     <p:sldId id="266" r:id="rId12"/>
     <p:sldId id="267" r:id="rId13"/>
-    <p:sldId id="268" r:id="rId19"/>
-    <p:sldId id="269" r:id="rId20"/>
-    <p:sldId id="270" r:id="rId21"/>
+    <p:sldId id="268" r:id="rId14"/>
+    <p:sldId id="269" r:id="rId15"/>
+    <p:sldId id="270" r:id="rId16"/>
   </p:sldIdLst>
   <p:sldSz cx="12192000" cy="6858000"/>
   <p:notesSz cx="6858000" cy="9144000"/>
@@ -345,7 +345,7 @@
           <a:p>
             <a:fld id="{5BCAD085-E8A6-8845-BD4E-CB4CCA059FC4}" type="datetimeFigureOut">
               <a:rPr lang="en-US" smtClean="0"/>
-              <a:t>6/7/2026</a:t>
+              <a:t>6/9/2026</a:t>
             </a:fld>
             <a:endParaRPr lang="en-US"/>
           </a:p>
@@ -513,7 +513,7 @@
           <a:p>
             <a:fld id="{5BCAD085-E8A6-8845-BD4E-CB4CCA059FC4}" type="datetimeFigureOut">
               <a:rPr lang="en-US" smtClean="0"/>
-              <a:t>6/7/2026</a:t>
+              <a:t>6/9/2026</a:t>
             </a:fld>
             <a:endParaRPr lang="en-US"/>
           </a:p>
@@ -691,7 +691,7 @@
           <a:p>
             <a:fld id="{5BCAD085-E8A6-8845-BD4E-CB4CCA059FC4}" type="datetimeFigureOut">
               <a:rPr lang="en-US" smtClean="0"/>
-              <a:t>6/7/2026</a:t>
+              <a:t>6/9/2026</a:t>
             </a:fld>
             <a:endParaRPr lang="en-US"/>
           </a:p>
@@ -859,7 +859,7 @@
           <a:p>
             <a:fld id="{5BCAD085-E8A6-8845-BD4E-CB4CCA059FC4}" type="datetimeFigureOut">
               <a:rPr lang="en-US" smtClean="0"/>
-              <a:t>6/7/2026</a:t>
+              <a:t>6/9/2026</a:t>
             </a:fld>
             <a:endParaRPr lang="en-US"/>
           </a:p>
@@ -1104,7 +1104,7 @@
           <a:p>
             <a:fld id="{5BCAD085-E8A6-8845-BD4E-CB4CCA059FC4}" type="datetimeFigureOut">
               <a:rPr lang="en-US" smtClean="0"/>
-              <a:t>6/7/2026</a:t>
+              <a:t>6/9/2026</a:t>
             </a:fld>
             <a:endParaRPr lang="en-US"/>
           </a:p>
@@ -1389,7 +1389,7 @@
           <a:p>
             <a:fld id="{5BCAD085-E8A6-8845-BD4E-CB4CCA059FC4}" type="datetimeFigureOut">
               <a:rPr lang="en-US" smtClean="0"/>
-              <a:t>6/7/2026</a:t>
+              <a:t>6/9/2026</a:t>
             </a:fld>
             <a:endParaRPr lang="en-US"/>
           </a:p>
@@ -1808,7 +1808,7 @@
           <a:p>
             <a:fld id="{5BCAD085-E8A6-8845-BD4E-CB4CCA059FC4}" type="datetimeFigureOut">
               <a:rPr lang="en-US" smtClean="0"/>
-              <a:t>6/7/2026</a:t>
+              <a:t>6/9/2026</a:t>
             </a:fld>
             <a:endParaRPr lang="en-US"/>
           </a:p>
@@ -1925,7 +1925,7 @@
           <a:p>
             <a:fld id="{5BCAD085-E8A6-8845-BD4E-CB4CCA059FC4}" type="datetimeFigureOut">
               <a:rPr lang="en-US" smtClean="0"/>
-              <a:t>6/7/2026</a:t>
+              <a:t>6/9/2026</a:t>
             </a:fld>
             <a:endParaRPr lang="en-US"/>
           </a:p>
@@ -2020,7 +2020,7 @@
           <a:p>
             <a:fld id="{5BCAD085-E8A6-8845-BD4E-CB4CCA059FC4}" type="datetimeFigureOut">
               <a:rPr lang="en-US" smtClean="0"/>
-              <a:t>6/7/2026</a:t>
+              <a:t>6/9/2026</a:t>
             </a:fld>
             <a:endParaRPr lang="en-US"/>
           </a:p>
@@ -2295,7 +2295,7 @@
           <a:p>
             <a:fld id="{5BCAD085-E8A6-8845-BD4E-CB4CCA059FC4}" type="datetimeFigureOut">
               <a:rPr lang="en-US" smtClean="0"/>
-              <a:t>6/7/2026</a:t>
+              <a:t>6/9/2026</a:t>
             </a:fld>
             <a:endParaRPr lang="en-US"/>
           </a:p>
@@ -2547,7 +2547,7 @@
           <a:p>
             <a:fld id="{5BCAD085-E8A6-8845-BD4E-CB4CCA059FC4}" type="datetimeFigureOut">
               <a:rPr lang="en-US" smtClean="0"/>
-              <a:t>6/7/2026</a:t>
+              <a:t>6/9/2026</a:t>
             </a:fld>
             <a:endParaRPr lang="en-US"/>
           </a:p>
@@ -2758,7 +2758,7 @@
           <a:p>
             <a:fld id="{5BCAD085-E8A6-8845-BD4E-CB4CCA059FC4}" type="datetimeFigureOut">
               <a:rPr lang="en-US" smtClean="0"/>
-              <a:t>6/7/2026</a:t>
+              <a:t>6/9/2026</a:t>
             </a:fld>
             <a:endParaRPr lang="en-US"/>
           </a:p>
@@ -7293,7 +7293,7 @@
 </file>
 
 <file path=ppt/slides/slide13.xml><?xml version="1.0" encoding="utf-8"?>
-<p:sld xmlns:a="http://schemas.openxmlformats.org/drawingml/2006/main" xmlns:p="http://schemas.openxmlformats.org/presentationml/2006/main" xmlns:r="http://schemas.openxmlformats.org/officeDocument/2006/relationships">
+<p:sld xmlns:a="http://schemas.openxmlformats.org/drawingml/2006/main" xmlns:r="http://schemas.openxmlformats.org/officeDocument/2006/relationships" xmlns:p="http://schemas.openxmlformats.org/presentationml/2006/main">
   <p:cSld>
     <p:spTree>
       <p:nvGrpSpPr>
@@ -7301,7 +7301,14 @@
         <p:cNvGrpSpPr/>
         <p:nvPr/>
       </p:nvGrpSpPr>
-      <p:grpSpPr/>
+      <p:grpSpPr>
+        <a:xfrm>
+          <a:off x="0" y="0"/>
+          <a:ext cx="0" cy="0"/>
+          <a:chOff x="0" y="0"/>
+          <a:chExt cx="0" cy="0"/>
+        </a:xfrm>
+      </p:grpSpPr>
       <p:sp>
         <p:nvSpPr>
           <p:cNvPr id="2" name="TextBox 1"/>
@@ -7557,6 +7564,7 @@
           <a:lstStyle/>
           <a:p>
             <a:pPr algn="ctr"/>
+            <a:endParaRPr/>
           </a:p>
         </p:txBody>
       </p:sp>
@@ -7600,6 +7608,7 @@
           <a:lstStyle/>
           <a:p>
             <a:pPr algn="ctr"/>
+            <a:endParaRPr/>
           </a:p>
         </p:txBody>
       </p:sp>
@@ -7725,6 +7734,7 @@
           <a:lstStyle/>
           <a:p>
             <a:pPr algn="ctr"/>
+            <a:endParaRPr/>
           </a:p>
         </p:txBody>
       </p:sp>
@@ -7850,6 +7860,7 @@
           <a:lstStyle/>
           <a:p>
             <a:pPr algn="ctr"/>
+            <a:endParaRPr/>
           </a:p>
         </p:txBody>
       </p:sp>
@@ -7975,6 +7986,7 @@
           <a:lstStyle/>
           <a:p>
             <a:pPr algn="ctr"/>
+            <a:endParaRPr/>
           </a:p>
         </p:txBody>
       </p:sp>
@@ -8100,6 +8112,7 @@
           <a:lstStyle/>
           <a:p>
             <a:pPr algn="ctr"/>
+            <a:endParaRPr/>
           </a:p>
         </p:txBody>
       </p:sp>
@@ -8194,7 +8207,7 @@
 </file>
 
 <file path=ppt/slides/slide14.xml><?xml version="1.0" encoding="utf-8"?>
-<p:sld xmlns:a="http://schemas.openxmlformats.org/drawingml/2006/main" xmlns:p="http://schemas.openxmlformats.org/presentationml/2006/main" xmlns:r="http://schemas.openxmlformats.org/officeDocument/2006/relationships">
+<p:sld xmlns:a="http://schemas.openxmlformats.org/drawingml/2006/main" xmlns:r="http://schemas.openxmlformats.org/officeDocument/2006/relationships" xmlns:p="http://schemas.openxmlformats.org/presentationml/2006/main">
   <p:cSld>
     <p:spTree>
       <p:nvGrpSpPr>
@@ -8202,7 +8215,14 @@
         <p:cNvGrpSpPr/>
         <p:nvPr/>
       </p:nvGrpSpPr>
-      <p:grpSpPr/>
+      <p:grpSpPr>
+        <a:xfrm>
+          <a:off x="0" y="0"/>
+          <a:ext cx="0" cy="0"/>
+          <a:chOff x="0" y="0"/>
+          <a:chExt cx="0" cy="0"/>
+        </a:xfrm>
+      </p:grpSpPr>
       <p:sp>
         <p:nvSpPr>
           <p:cNvPr id="2" name="TextBox 1"/>
@@ -8458,6 +8478,7 @@
           <a:lstStyle/>
           <a:p>
             <a:pPr algn="ctr"/>
+            <a:endParaRPr/>
           </a:p>
         </p:txBody>
       </p:sp>
@@ -8571,6 +8592,7 @@
           <a:lstStyle/>
           <a:p>
             <a:pPr algn="ctr"/>
+            <a:endParaRPr/>
           </a:p>
         </p:txBody>
       </p:sp>
@@ -8684,6 +8706,7 @@
           <a:lstStyle/>
           <a:p>
             <a:pPr algn="ctr"/>
+            <a:endParaRPr/>
           </a:p>
         </p:txBody>
       </p:sp>
@@ -8797,6 +8820,7 @@
           <a:lstStyle/>
           <a:p>
             <a:pPr algn="ctr"/>
+            <a:endParaRPr/>
           </a:p>
         </p:txBody>
       </p:sp>
@@ -8910,6 +8934,7 @@
           <a:lstStyle/>
           <a:p>
             <a:pPr algn="ctr"/>
+            <a:endParaRPr/>
           </a:p>
         </p:txBody>
       </p:sp>
@@ -8953,6 +8978,7 @@
           <a:lstStyle/>
           <a:p>
             <a:pPr algn="ctr"/>
+            <a:endParaRPr/>
           </a:p>
         </p:txBody>
       </p:sp>
@@ -8996,6 +9022,7 @@
           <a:lstStyle/>
           <a:p>
             <a:pPr algn="ctr"/>
+            <a:endParaRPr/>
           </a:p>
         </p:txBody>
       </p:sp>
@@ -9039,6 +9066,7 @@
           <a:lstStyle/>
           <a:p>
             <a:pPr algn="ctr"/>
+            <a:endParaRPr/>
           </a:p>
         </p:txBody>
       </p:sp>
@@ -9082,6 +9110,7 @@
           <a:lstStyle/>
           <a:p>
             <a:pPr algn="ctr"/>
+            <a:endParaRPr/>
           </a:p>
         </p:txBody>
       </p:sp>
@@ -9141,7 +9170,7 @@
 </file>
 
 <file path=ppt/slides/slide15.xml><?xml version="1.0" encoding="utf-8"?>
-<p:sld xmlns:a="http://schemas.openxmlformats.org/drawingml/2006/main" xmlns:p="http://schemas.openxmlformats.org/presentationml/2006/main" xmlns:r="http://schemas.openxmlformats.org/officeDocument/2006/relationships">
+<p:sld xmlns:a="http://schemas.openxmlformats.org/drawingml/2006/main" xmlns:r="http://schemas.openxmlformats.org/officeDocument/2006/relationships" xmlns:p="http://schemas.openxmlformats.org/presentationml/2006/main">
   <p:cSld>
     <p:spTree>
       <p:nvGrpSpPr>
@@ -9149,7 +9178,14 @@
         <p:cNvGrpSpPr/>
         <p:nvPr/>
       </p:nvGrpSpPr>
-      <p:grpSpPr/>
+      <p:grpSpPr>
+        <a:xfrm>
+          <a:off x="0" y="0"/>
+          <a:ext cx="0" cy="0"/>
+          <a:chOff x="0" y="0"/>
+          <a:chExt cx="0" cy="0"/>
+        </a:xfrm>
+      </p:grpSpPr>
       <p:sp>
         <p:nvSpPr>
           <p:cNvPr id="2" name="TextBox 1"/>
@@ -9461,6 +9497,12 @@
               </a:lnSpc>
               <a:buNone/>
             </a:pPr>
+            <a:endParaRPr sz="2800" b="0" spc="-28">
+              <a:solidFill>
+                <a:srgbClr val="1F1F1F"/>
+              </a:solidFill>
+              <a:latin typeface="Pretendard"/>
+            </a:endParaRPr>
           </a:p>
           <a:p>
             <a:pPr marL="342900" indent="-342900">
@@ -9519,6 +9561,12 @@
               </a:lnSpc>
               <a:buNone/>
             </a:pPr>
+            <a:endParaRPr sz="2400" b="0" spc="-24">
+              <a:solidFill>
+                <a:srgbClr val="6B6B6B"/>
+              </a:solidFill>
+              <a:latin typeface="Pretendard"/>
+            </a:endParaRPr>
           </a:p>
           <a:p>
             <a:pPr marL="342900" indent="-342900">
@@ -13699,251 +13747,6 @@
       </p:sp>
       <p:sp>
         <p:nvSpPr>
-          <p:cNvPr id="7" name="TextBox 6"/>
-          <p:cNvSpPr txBox="1"/>
-          <p:nvPr/>
-        </p:nvSpPr>
-        <p:spPr>
-          <a:xfrm>
-            <a:off x="617220" y="1645920"/>
-            <a:ext cx="5867732" cy="548640"/>
-          </a:xfrm>
-          <a:prstGeom prst="rect">
-            <a:avLst/>
-          </a:prstGeom>
-          <a:noFill/>
-        </p:spPr>
-        <p:txBody>
-          <a:bodyPr wrap="square" lIns="0" tIns="0" rIns="0" bIns="0" anchor="t">
-            <a:spAutoFit/>
-          </a:bodyPr>
-          <a:lstStyle/>
-          <a:p>
-            <a:pPr algn="l"/>
-            <a:r>
-              <a:rPr sz="2600" b="1" i="0" spc="-26">
-                <a:solidFill>
-                  <a:srgbClr val="161616"/>
-                </a:solidFill>
-                <a:latin typeface="Pretendard"/>
-              </a:rPr>
-              <a:t>Headline claim — the punchline</a:t>
-            </a:r>
-          </a:p>
-        </p:txBody>
-      </p:sp>
-      <p:sp>
-        <p:nvSpPr>
-          <p:cNvPr id="8" name="TextBox 7"/>
-          <p:cNvSpPr txBox="1"/>
-          <p:nvPr/>
-        </p:nvSpPr>
-        <p:spPr>
-          <a:xfrm>
-            <a:off x="617220" y="2331720"/>
-            <a:ext cx="274320" cy="274320"/>
-          </a:xfrm>
-          <a:prstGeom prst="rect">
-            <a:avLst/>
-          </a:prstGeom>
-          <a:noFill/>
-        </p:spPr>
-        <p:txBody>
-          <a:bodyPr wrap="square" lIns="0" tIns="0" rIns="0" bIns="0" anchor="t">
-            <a:spAutoFit/>
-          </a:bodyPr>
-          <a:lstStyle/>
-          <a:p>
-            <a:pPr algn="l"/>
-            <a:r>
-              <a:rPr sz="1500" b="1" i="0" spc="-15">
-                <a:solidFill>
-                  <a:srgbClr val="00754A"/>
-                </a:solidFill>
-                <a:latin typeface="Pretendard"/>
-              </a:rPr>
-              <a:t>●</a:t>
-            </a:r>
-          </a:p>
-        </p:txBody>
-      </p:sp>
-      <p:sp>
-        <p:nvSpPr>
-          <p:cNvPr id="9" name="TextBox 8"/>
-          <p:cNvSpPr txBox="1"/>
-          <p:nvPr/>
-        </p:nvSpPr>
-        <p:spPr>
-          <a:xfrm>
-            <a:off x="937259" y="2331720"/>
-            <a:ext cx="5547692" cy="365760"/>
-          </a:xfrm>
-          <a:prstGeom prst="rect">
-            <a:avLst/>
-          </a:prstGeom>
-          <a:noFill/>
-        </p:spPr>
-        <p:txBody>
-          <a:bodyPr wrap="square" lIns="0" tIns="0" rIns="0" bIns="0" anchor="t">
-            <a:spAutoFit/>
-          </a:bodyPr>
-          <a:lstStyle/>
-          <a:p>
-            <a:pPr algn="l"/>
-            <a:r>
-              <a:rPr sz="1800" b="0" i="0" spc="-18">
-                <a:solidFill>
-                  <a:srgbClr val="1F1F1F"/>
-                </a:solidFill>
-                <a:latin typeface="Pretendard"/>
-              </a:rPr>
-              <a:t>First supporting point with concise wording.</a:t>
-            </a:r>
-          </a:p>
-        </p:txBody>
-      </p:sp>
-      <p:sp>
-        <p:nvSpPr>
-          <p:cNvPr id="10" name="TextBox 9"/>
-          <p:cNvSpPr txBox="1"/>
-          <p:nvPr/>
-        </p:nvSpPr>
-        <p:spPr>
-          <a:xfrm>
-            <a:off x="617220" y="2834639"/>
-            <a:ext cx="274320" cy="274320"/>
-          </a:xfrm>
-          <a:prstGeom prst="rect">
-            <a:avLst/>
-          </a:prstGeom>
-          <a:noFill/>
-        </p:spPr>
-        <p:txBody>
-          <a:bodyPr wrap="square" lIns="0" tIns="0" rIns="0" bIns="0" anchor="t">
-            <a:spAutoFit/>
-          </a:bodyPr>
-          <a:lstStyle/>
-          <a:p>
-            <a:pPr algn="l"/>
-            <a:r>
-              <a:rPr sz="1500" b="1" i="0" spc="-15">
-                <a:solidFill>
-                  <a:srgbClr val="00754A"/>
-                </a:solidFill>
-                <a:latin typeface="Pretendard"/>
-              </a:rPr>
-              <a:t>●</a:t>
-            </a:r>
-          </a:p>
-        </p:txBody>
-      </p:sp>
-      <p:sp>
-        <p:nvSpPr>
-          <p:cNvPr id="11" name="TextBox 10"/>
-          <p:cNvSpPr txBox="1"/>
-          <p:nvPr/>
-        </p:nvSpPr>
-        <p:spPr>
-          <a:xfrm>
-            <a:off x="937259" y="2834639"/>
-            <a:ext cx="5547692" cy="365760"/>
-          </a:xfrm>
-          <a:prstGeom prst="rect">
-            <a:avLst/>
-          </a:prstGeom>
-          <a:noFill/>
-        </p:spPr>
-        <p:txBody>
-          <a:bodyPr wrap="square" lIns="0" tIns="0" rIns="0" bIns="0" anchor="t">
-            <a:spAutoFit/>
-          </a:bodyPr>
-          <a:lstStyle/>
-          <a:p>
-            <a:pPr algn="l"/>
-            <a:r>
-              <a:rPr sz="1800" b="0" i="0" spc="-18">
-                <a:solidFill>
-                  <a:srgbClr val="1F1F1F"/>
-                </a:solidFill>
-                <a:latin typeface="Pretendard"/>
-              </a:rPr>
-              <a:t>Second supporting point with concrete numbers.</a:t>
-            </a:r>
-          </a:p>
-        </p:txBody>
-      </p:sp>
-      <p:sp>
-        <p:nvSpPr>
-          <p:cNvPr id="12" name="TextBox 11"/>
-          <p:cNvSpPr txBox="1"/>
-          <p:nvPr/>
-        </p:nvSpPr>
-        <p:spPr>
-          <a:xfrm>
-            <a:off x="617220" y="3337559"/>
-            <a:ext cx="274320" cy="274320"/>
-          </a:xfrm>
-          <a:prstGeom prst="rect">
-            <a:avLst/>
-          </a:prstGeom>
-          <a:noFill/>
-        </p:spPr>
-        <p:txBody>
-          <a:bodyPr wrap="square" lIns="0" tIns="0" rIns="0" bIns="0" anchor="t">
-            <a:spAutoFit/>
-          </a:bodyPr>
-          <a:lstStyle/>
-          <a:p>
-            <a:pPr algn="l"/>
-            <a:r>
-              <a:rPr sz="1500" b="1" i="0" spc="-15">
-                <a:solidFill>
-                  <a:srgbClr val="00754A"/>
-                </a:solidFill>
-                <a:latin typeface="Pretendard"/>
-              </a:rPr>
-              <a:t>●</a:t>
-            </a:r>
-          </a:p>
-        </p:txBody>
-      </p:sp>
-      <p:sp>
-        <p:nvSpPr>
-          <p:cNvPr id="13" name="TextBox 12"/>
-          <p:cNvSpPr txBox="1"/>
-          <p:nvPr/>
-        </p:nvSpPr>
-        <p:spPr>
-          <a:xfrm>
-            <a:off x="937259" y="3337559"/>
-            <a:ext cx="5547692" cy="365760"/>
-          </a:xfrm>
-          <a:prstGeom prst="rect">
-            <a:avLst/>
-          </a:prstGeom>
-          <a:noFill/>
-        </p:spPr>
-        <p:txBody>
-          <a:bodyPr wrap="square" lIns="0" tIns="0" rIns="0" bIns="0" anchor="t">
-            <a:spAutoFit/>
-          </a:bodyPr>
-          <a:lstStyle/>
-          <a:p>
-            <a:pPr algn="l"/>
-            <a:r>
-              <a:rPr sz="1800" b="0" i="0" spc="-18">
-                <a:solidFill>
-                  <a:srgbClr val="1F1F1F"/>
-                </a:solidFill>
-                <a:latin typeface="Pretendard"/>
-              </a:rPr>
-              <a:t>Third supporting point with clinical relevance.</a:t>
-            </a:r>
-          </a:p>
-        </p:txBody>
-      </p:sp>
-      <p:sp>
-        <p:nvSpPr>
           <p:cNvPr id="14" name="Rounded Rectangle 13"/>
           <p:cNvSpPr/>
           <p:nvPr/>
@@ -14363,6 +14166,242 @@
                 <a:latin typeface="Pretendard"/>
               </a:rPr>
               <a:t>Source: study cohort  ·  n = NN</a:t>
+            </a:r>
+          </a:p>
+        </p:txBody>
+      </p:sp>
+      <p:sp>
+        <p:nvSpPr>
+          <p:cNvPr id="25" name="TextBox 24"/>
+          <p:cNvSpPr txBox="1"/>
+          <p:nvPr/>
+        </p:nvSpPr>
+        <p:spPr>
+          <a:xfrm>
+            <a:off x="621792" y="1645920"/>
+            <a:ext cx="5870448" cy="3246120"/>
+          </a:xfrm>
+          <a:prstGeom prst="rect">
+            <a:avLst/>
+          </a:prstGeom>
+          <a:noFill/>
+        </p:spPr>
+        <p:txBody>
+          <a:bodyPr wrap="square">
+            <a:noAutofit/>
+          </a:bodyPr>
+          <a:lstStyle/>
+          <a:p>
+            <a:pPr>
+              <a:lnSpc>
+                <a:spcPct val="110000"/>
+              </a:lnSpc>
+              <a:spcBef>
+                <a:spcPts val="0"/>
+              </a:spcBef>
+              <a:buNone/>
+            </a:pPr>
+            <a:r>
+              <a:rPr sz="2600" b="1" spc="-26">
+                <a:solidFill>
+                  <a:srgbClr val="1F1F1F"/>
+                </a:solidFill>
+                <a:latin typeface="Pretendard"/>
+              </a:rPr>
+              <a:t>Headline claim — the punchline</a:t>
+            </a:r>
+          </a:p>
+          <a:p>
+            <a:pPr marL="320040" indent="-320040">
+              <a:lnSpc>
+                <a:spcPct val="112000"/>
+              </a:lnSpc>
+              <a:spcBef>
+                <a:spcPts val="1200"/>
+              </a:spcBef>
+              <a:buClr>
+                <a:srgbClr val="00754A"/>
+              </a:buClr>
+              <a:buSzPct val="68000"/>
+              <a:buFont typeface="Arial"/>
+              <a:buChar char="●"/>
+            </a:pPr>
+            <a:r>
+              <a:rPr sz="1800" b="0" spc="-18">
+                <a:solidFill>
+                  <a:srgbClr val="1F1F1F"/>
+                </a:solidFill>
+                <a:latin typeface="Pretendard"/>
+              </a:rPr>
+              <a:t>First supporting point with concise wording.</a:t>
+            </a:r>
+          </a:p>
+          <a:p>
+            <a:pPr marL="320040" indent="-320040">
+              <a:lnSpc>
+                <a:spcPct val="112000"/>
+              </a:lnSpc>
+              <a:spcBef>
+                <a:spcPts val="1200"/>
+              </a:spcBef>
+              <a:buClr>
+                <a:srgbClr val="00754A"/>
+              </a:buClr>
+              <a:buSzPct val="68000"/>
+              <a:buFont typeface="Arial"/>
+              <a:buChar char="●"/>
+            </a:pPr>
+            <a:r>
+              <a:rPr sz="1800" b="0" spc="-18">
+                <a:solidFill>
+                  <a:srgbClr val="1F1F1F"/>
+                </a:solidFill>
+                <a:latin typeface="Pretendard"/>
+              </a:rPr>
+              <a:t>Second supporting point with concrete numbers.</a:t>
+            </a:r>
+          </a:p>
+          <a:p>
+            <a:pPr marL="320040" indent="-320040">
+              <a:lnSpc>
+                <a:spcPct val="112000"/>
+              </a:lnSpc>
+              <a:spcBef>
+                <a:spcPts val="1200"/>
+              </a:spcBef>
+              <a:buClr>
+                <a:srgbClr val="00754A"/>
+              </a:buClr>
+              <a:buSzPct val="68000"/>
+              <a:buFont typeface="Arial"/>
+              <a:buChar char="●"/>
+            </a:pPr>
+            <a:r>
+              <a:rPr sz="1800" b="0" spc="-18">
+                <a:solidFill>
+                  <a:srgbClr val="1F1F1F"/>
+                </a:solidFill>
+                <a:latin typeface="Pretendard"/>
+              </a:rPr>
+              <a:t>Third supporting point with clinical relevance.</a:t>
+            </a:r>
+          </a:p>
+        </p:txBody>
+      </p:sp>
+      <p:sp>
+        <p:nvSpPr>
+          <p:cNvPr id="5" name="TextBox 4"/>
+          <p:cNvSpPr txBox="1"/>
+          <p:nvPr/>
+        </p:nvSpPr>
+        <p:spPr>
+          <a:xfrm>
+            <a:off x="621792" y="1645920"/>
+            <a:ext cx="5870448" cy="3246120"/>
+          </a:xfrm>
+          <a:prstGeom prst="rect">
+            <a:avLst/>
+          </a:prstGeom>
+          <a:noFill/>
+        </p:spPr>
+        <p:txBody>
+          <a:bodyPr wrap="square">
+            <a:noAutofit/>
+          </a:bodyPr>
+          <a:lstStyle/>
+          <a:p>
+            <a:pPr>
+              <a:lnSpc>
+                <a:spcPct val="110000"/>
+              </a:lnSpc>
+              <a:spcBef>
+                <a:spcPts val="0"/>
+              </a:spcBef>
+              <a:buNone/>
+            </a:pPr>
+            <a:r>
+              <a:rPr sz="2600" b="1" spc="-26" dirty="0">
+                <a:solidFill>
+                  <a:srgbClr val="1F1F1F"/>
+                </a:solidFill>
+                <a:latin typeface="Pretendard"/>
+              </a:rPr>
+              <a:t>Headline claim — the punchline</a:t>
+            </a:r>
+          </a:p>
+          <a:p>
+            <a:pPr marL="320040" indent="-320040">
+              <a:lnSpc>
+                <a:spcPct val="112000"/>
+              </a:lnSpc>
+              <a:spcBef>
+                <a:spcPts val="1200"/>
+              </a:spcBef>
+              <a:buClr>
+                <a:srgbClr val="00754A"/>
+              </a:buClr>
+              <a:buSzPct val="68000"/>
+              <a:buFont typeface="Arial"/>
+              <a:buChar char="●"/>
+            </a:pPr>
+            <a:r>
+              <a:rPr sz="1800" b="0" spc="-18" dirty="0">
+                <a:solidFill>
+                  <a:srgbClr val="1F1F1F"/>
+                </a:solidFill>
+                <a:latin typeface="Pretendard"/>
+              </a:rPr>
+              <a:t>First supporting point with concise wording.</a:t>
+            </a:r>
+          </a:p>
+          <a:p>
+            <a:pPr marL="320040" indent="-320040">
+              <a:lnSpc>
+                <a:spcPct val="112000"/>
+              </a:lnSpc>
+              <a:spcBef>
+                <a:spcPts val="1200"/>
+              </a:spcBef>
+              <a:buClr>
+                <a:srgbClr val="00754A"/>
+              </a:buClr>
+              <a:buSzPct val="68000"/>
+              <a:buFont typeface="Arial"/>
+              <a:buChar char="●"/>
+            </a:pPr>
+            <a:r>
+              <a:rPr sz="1800" b="0" spc="-18" dirty="0">
+                <a:solidFill>
+                  <a:srgbClr val="1F1F1F"/>
+                </a:solidFill>
+                <a:latin typeface="Pretendard"/>
+              </a:rPr>
+              <a:t>Second supporting point with concrete numbers.</a:t>
+            </a:r>
+          </a:p>
+          <a:p>
+            <a:pPr marL="320040" indent="-320040">
+              <a:lnSpc>
+                <a:spcPct val="112000"/>
+              </a:lnSpc>
+              <a:spcBef>
+                <a:spcPts val="1200"/>
+              </a:spcBef>
+              <a:buClr>
+                <a:srgbClr val="00754A"/>
+              </a:buClr>
+              <a:buSzPct val="68000"/>
+              <a:buFont typeface="Arial"/>
+              <a:buChar char="●"/>
+            </a:pPr>
+            <a:r>
+              <a:rPr sz="1800" b="0" spc="-18" dirty="0">
+                <a:solidFill>
+                  <a:srgbClr val="1F1F1F"/>
+                </a:solidFill>
+                <a:latin typeface="Pretendard"/>
+              </a:rPr>
+              <a:t>Third supporting point with clinical relevance.</a:t>
             </a:r>
           </a:p>
         </p:txBody>

</xml_diff>

<commit_message>
Move Thank-you slide to the end; update README to current system
- backbone: move the closing (Thank-you) slide after Patterns J/K/L so it is the
  final slide (now 15); renumber footers to match positions.
- README: bring it up to date — four locked zones (subtitle removed), minimal/
  flat/light direction, House Green as chart-accent (not a background), podium
  type scale with 12pt floor, patterns A–L (added J/K/L), new logo standard
  (crop), one-text-frame rule, and slide-content-prompt.md in the file list.

Co-Authored-By: Claude Opus 4.8 (1M context) <noreply@anthropic.com>
</commit_message>
<xml_diff>
--- a/backbone_slides.pptx
+++ b/backbone_slides.pptx
@@ -16,10 +16,10 @@
     <p:sldId id="264" r:id="rId10"/>
     <p:sldId id="265" r:id="rId11"/>
     <p:sldId id="266" r:id="rId12"/>
-    <p:sldId id="267" r:id="rId13"/>
     <p:sldId id="268" r:id="rId14"/>
     <p:sldId id="269" r:id="rId15"/>
     <p:sldId id="270" r:id="rId16"/>
+    <p:sldId id="267" r:id="rId13"/>
   </p:sldIdLst>
   <p:sldSz cx="12192000" cy="6858000"/>
   <p:notesSz cx="6858000" cy="9144000"/>
@@ -6926,14 +6926,6 @@
 <file path=ppt/slides/slide12.xml><?xml version="1.0" encoding="utf-8"?>
 <p:sld xmlns:a="http://schemas.openxmlformats.org/drawingml/2006/main" xmlns:r="http://schemas.openxmlformats.org/officeDocument/2006/relationships" xmlns:p="http://schemas.openxmlformats.org/presentationml/2006/main">
   <p:cSld>
-    <p:bg>
-      <p:bgPr>
-        <a:solidFill>
-          <a:srgbClr val="F2F0EB"/>
-        </a:solidFill>
-        <a:effectLst/>
-      </p:bgPr>
-    </p:bg>
     <p:spTree>
       <p:nvGrpSpPr>
         <p:cNvPr id="1" name=""/>
@@ -6950,95 +6942,42 @@
       </p:grpSpPr>
       <p:sp>
         <p:nvSpPr>
-          <p:cNvPr id="2" name="Rectangle 1"/>
-          <p:cNvSpPr/>
-          <p:nvPr/>
-        </p:nvSpPr>
-        <p:spPr>
-          <a:xfrm>
-            <a:off x="0" y="0"/>
-            <a:ext cx="64008" cy="6858000"/>
-          </a:xfrm>
-          <a:prstGeom prst="rect">
-            <a:avLst/>
-          </a:prstGeom>
-          <a:solidFill>
-            <a:srgbClr val="00754A"/>
-          </a:solidFill>
-          <a:ln>
-            <a:noFill/>
-          </a:ln>
-        </p:spPr>
-        <p:style>
-          <a:lnRef idx="1">
-            <a:schemeClr val="accent1"/>
-          </a:lnRef>
-          <a:fillRef idx="3">
-            <a:schemeClr val="accent1"/>
-          </a:fillRef>
-          <a:effectRef idx="0">
-            <a:schemeClr val="accent1"/>
-          </a:effectRef>
-          <a:fontRef idx="minor">
-            <a:schemeClr val="lt1"/>
-          </a:fontRef>
-        </p:style>
-        <p:txBody>
-          <a:bodyPr rtlCol="0" anchor="ctr"/>
-          <a:lstStyle/>
-          <a:p>
-            <a:pPr algn="ctr"/>
-            <a:endParaRPr/>
-          </a:p>
-        </p:txBody>
-      </p:sp>
-      <p:sp>
-        <p:nvSpPr>
-          <p:cNvPr id="3" name="Rectangle 2"/>
-          <p:cNvSpPr/>
-          <p:nvPr/>
-        </p:nvSpPr>
-        <p:spPr>
-          <a:xfrm>
-            <a:off x="6688836" y="0"/>
-            <a:ext cx="5472684" cy="6858000"/>
-          </a:xfrm>
-          <a:prstGeom prst="rect">
-            <a:avLst/>
-          </a:prstGeom>
-          <a:solidFill>
-            <a:srgbClr val="F2F0EB"/>
-          </a:solidFill>
-          <a:ln>
-            <a:noFill/>
-          </a:ln>
-        </p:spPr>
-        <p:style>
-          <a:lnRef idx="1">
-            <a:schemeClr val="accent1"/>
-          </a:lnRef>
-          <a:fillRef idx="3">
-            <a:schemeClr val="accent1"/>
-          </a:fillRef>
-          <a:effectRef idx="0">
-            <a:schemeClr val="accent1"/>
-          </a:effectRef>
-          <a:fontRef idx="minor">
-            <a:schemeClr val="lt1"/>
-          </a:fontRef>
-        </p:style>
-        <p:txBody>
-          <a:bodyPr rtlCol="0" anchor="ctr"/>
-          <a:lstStyle/>
-          <a:p>
-            <a:pPr algn="ctr"/>
-            <a:endParaRPr/>
+          <p:cNvPr id="2" name="TextBox 1"/>
+          <p:cNvSpPr txBox="1"/>
+          <p:nvPr/>
+        </p:nvSpPr>
+        <p:spPr>
+          <a:xfrm>
+            <a:off x="138257" y="123444"/>
+            <a:ext cx="5486400" cy="256032"/>
+          </a:xfrm>
+          <a:prstGeom prst="rect">
+            <a:avLst/>
+          </a:prstGeom>
+          <a:noFill/>
+        </p:spPr>
+        <p:txBody>
+          <a:bodyPr wrap="square" lIns="0" tIns="0" rIns="0" bIns="0" anchor="t">
+            <a:spAutoFit/>
+          </a:bodyPr>
+          <a:lstStyle/>
+          <a:p>
+            <a:pPr algn="l"/>
+            <a:r>
+              <a:rPr sz="1300" b="1" i="0" spc="-13">
+                <a:solidFill>
+                  <a:srgbClr val="8E8E93"/>
+                </a:solidFill>
+                <a:latin typeface="Pretendard"/>
+              </a:rPr>
+              <a:t>PATTERN J</a:t>
+            </a:r>
           </a:p>
         </p:txBody>
       </p:sp>
       <p:pic>
         <p:nvPicPr>
-          <p:cNvPr id="4" name="Picture 3" descr="logo.png"/>
+          <p:cNvPr id="3" name="Picture 2" descr="logo.png"/>
           <p:cNvPicPr>
             <a:picLocks noChangeAspect="1"/>
           </p:cNvPicPr>
@@ -7063,14 +7002,14 @@
       </p:pic>
       <p:sp>
         <p:nvSpPr>
-          <p:cNvPr id="5" name="TextBox 4"/>
-          <p:cNvSpPr txBox="1"/>
-          <p:nvPr/>
-        </p:nvSpPr>
-        <p:spPr>
-          <a:xfrm>
-            <a:off x="548640" y="2286000"/>
-            <a:ext cx="8229600" cy="1463040"/>
+          <p:cNvPr id="4" name="TextBox 3"/>
+          <p:cNvSpPr txBox="1"/>
+          <p:nvPr/>
+        </p:nvSpPr>
+        <p:spPr>
+          <a:xfrm>
+            <a:off x="251460" y="436260"/>
+            <a:ext cx="10972800" cy="457200"/>
           </a:xfrm>
           <a:prstGeom prst="rect">
             <a:avLst/>
@@ -7085,31 +7024,77 @@
           <a:p>
             <a:pPr algn="l">
               <a:lnSpc>
-                <a:spcPct val="110000"/>
+                <a:spcPct val="120000"/>
               </a:lnSpc>
             </a:pPr>
             <a:r>
-              <a:rPr sz="7200" b="1" i="0" spc="-72">
+              <a:rPr sz="3200" b="1" i="0" spc="-32">
                 <a:solidFill>
                   <a:srgbClr val="006241"/>
                 </a:solidFill>
                 <a:latin typeface="Pretendard"/>
               </a:rPr>
-              <a:t>Thank you</a:t>
-            </a:r>
-          </a:p>
-        </p:txBody>
-      </p:sp>
-      <p:sp>
-        <p:nvSpPr>
-          <p:cNvPr id="6" name="TextBox 5"/>
-          <p:cNvSpPr txBox="1"/>
-          <p:nvPr/>
-        </p:nvSpPr>
-        <p:spPr>
-          <a:xfrm>
-            <a:off x="548640" y="3931920"/>
-            <a:ext cx="8229600" cy="365760"/>
+              <a:t>Timeline — Milestone Track</a:t>
+            </a:r>
+          </a:p>
+        </p:txBody>
+      </p:sp>
+      <p:sp>
+        <p:nvSpPr>
+          <p:cNvPr id="6" name="Rounded Rectangle 5"/>
+          <p:cNvSpPr/>
+          <p:nvPr/>
+        </p:nvSpPr>
+        <p:spPr>
+          <a:xfrm>
+            <a:off x="251642" y="1290309"/>
+            <a:ext cx="11699382" cy="5227350"/>
+          </a:xfrm>
+          <a:prstGeom prst="roundRect">
+            <a:avLst>
+              <a:gd name="adj" fmla="val 2099"/>
+            </a:avLst>
+          </a:prstGeom>
+          <a:solidFill>
+            <a:srgbClr val="FFFFFF"/>
+          </a:solidFill>
+          <a:ln>
+            <a:noFill/>
+          </a:ln>
+        </p:spPr>
+        <p:style>
+          <a:lnRef idx="1">
+            <a:schemeClr val="accent1"/>
+          </a:lnRef>
+          <a:fillRef idx="3">
+            <a:schemeClr val="accent1"/>
+          </a:fillRef>
+          <a:effectRef idx="0">
+            <a:schemeClr val="accent1"/>
+          </a:effectRef>
+          <a:fontRef idx="minor">
+            <a:schemeClr val="lt1"/>
+          </a:fontRef>
+        </p:style>
+        <p:txBody>
+          <a:bodyPr rtlCol="0" anchor="ctr"/>
+          <a:lstStyle/>
+          <a:p>
+            <a:pPr algn="ctr"/>
+            <a:endParaRPr/>
+          </a:p>
+        </p:txBody>
+      </p:sp>
+      <p:sp>
+        <p:nvSpPr>
+          <p:cNvPr id="35" name="TextBox 34"/>
+          <p:cNvSpPr txBox="1"/>
+          <p:nvPr/>
+        </p:nvSpPr>
+        <p:spPr>
+          <a:xfrm>
+            <a:off x="138257" y="6620256"/>
+            <a:ext cx="548640" cy="228600"/>
           </a:xfrm>
           <a:prstGeom prst="rect">
             <a:avLst/>
@@ -7124,27 +7109,62 @@
           <a:p>
             <a:pPr algn="l"/>
             <a:r>
-              <a:rPr sz="2000" b="0" i="1" spc="-20">
-                <a:solidFill>
-                  <a:srgbClr val="6B6B6B"/>
-                </a:solidFill>
-                <a:latin typeface="Pretendard"/>
-              </a:rPr>
-              <a:t>Questions and discussion</a:t>
-            </a:r>
-          </a:p>
-        </p:txBody>
-      </p:sp>
-      <p:sp>
-        <p:nvSpPr>
-          <p:cNvPr id="7" name="Rectangle 6"/>
+              <a:rPr sz="1100" b="0" i="0" spc="-11">
+                <a:solidFill>
+                  <a:srgbClr val="8E8E93"/>
+                </a:solidFill>
+                <a:latin typeface="Pretendard"/>
+              </a:rPr>
+              <a:t>12</a:t>
+            </a:r>
+          </a:p>
+        </p:txBody>
+      </p:sp>
+      <p:sp>
+        <p:nvSpPr>
+          <p:cNvPr id="36" name="TextBox 35"/>
+          <p:cNvSpPr txBox="1"/>
+          <p:nvPr/>
+        </p:nvSpPr>
+        <p:spPr>
+          <a:xfrm>
+            <a:off x="6567403" y="6617421"/>
+            <a:ext cx="5486400" cy="228600"/>
+          </a:xfrm>
+          <a:prstGeom prst="rect">
+            <a:avLst/>
+          </a:prstGeom>
+          <a:noFill/>
+        </p:spPr>
+        <p:txBody>
+          <a:bodyPr wrap="square" lIns="0" tIns="0" rIns="0" bIns="0" anchor="t">
+            <a:spAutoFit/>
+          </a:bodyPr>
+          <a:lstStyle/>
+          <a:p>
+            <a:pPr algn="r"/>
+            <a:r>
+              <a:rPr sz="1200" b="0" i="0" spc="-12">
+                <a:solidFill>
+                  <a:srgbClr val="8E8E93"/>
+                </a:solidFill>
+                <a:latin typeface="Pretendard"/>
+              </a:rPr>
+              <a:t>Source: study cohort  ·  n = NN</a:t>
+            </a:r>
+          </a:p>
+        </p:txBody>
+      </p:sp>
+      <p:sp>
+        <p:nvSpPr>
+          <p:cNvPr id="37" name="Rectangle 36"/>
           <p:cNvSpPr/>
           <p:nvPr/>
         </p:nvSpPr>
         <p:spPr>
           <a:xfrm>
-            <a:off x="548640" y="4572000"/>
-            <a:ext cx="1645920" cy="36576"/>
+            <a:off x="1554480" y="3310128"/>
+            <a:ext cx="9052560" cy="32004"/>
           </a:xfrm>
           <a:prstGeom prst="rect">
             <a:avLst/>
@@ -7181,105 +7201,630 @@
       </p:sp>
       <p:sp>
         <p:nvSpPr>
-          <p:cNvPr id="8" name="TextBox 7"/>
-          <p:cNvSpPr txBox="1"/>
-          <p:nvPr/>
-        </p:nvSpPr>
-        <p:spPr>
-          <a:xfrm>
-            <a:off x="6866503" y="5102352"/>
-            <a:ext cx="4572000" cy="310896"/>
-          </a:xfrm>
-          <a:prstGeom prst="rect">
-            <a:avLst/>
-          </a:prstGeom>
-          <a:noFill/>
-        </p:spPr>
-        <p:txBody>
-          <a:bodyPr wrap="square" lIns="0" tIns="0" rIns="0" bIns="0" anchor="t">
-            <a:spAutoFit/>
-          </a:bodyPr>
-          <a:lstStyle/>
-          <a:p>
-            <a:pPr algn="r"/>
-            <a:r>
-              <a:rPr sz="1500" b="0" i="0" spc="-15">
-                <a:solidFill>
-                  <a:srgbClr val="6B6B6B"/>
-                </a:solidFill>
-                <a:latin typeface="Pretendard"/>
-              </a:rPr>
-              <a:t>Seoul National Univ. Bundang Hospital</a:t>
-            </a:r>
-          </a:p>
-        </p:txBody>
-      </p:sp>
-      <p:sp>
-        <p:nvSpPr>
-          <p:cNvPr id="9" name="TextBox 8"/>
-          <p:cNvSpPr txBox="1"/>
-          <p:nvPr/>
-        </p:nvSpPr>
-        <p:spPr>
-          <a:xfrm>
-            <a:off x="6866503" y="5477621"/>
-            <a:ext cx="4572000" cy="411480"/>
-          </a:xfrm>
-          <a:prstGeom prst="rect">
-            <a:avLst/>
-          </a:prstGeom>
-          <a:noFill/>
-        </p:spPr>
-        <p:txBody>
-          <a:bodyPr wrap="square" lIns="0" tIns="0" rIns="0" bIns="0" anchor="t">
-            <a:spAutoFit/>
-          </a:bodyPr>
-          <a:lstStyle/>
-          <a:p>
-            <a:pPr algn="r"/>
-            <a:r>
-              <a:rPr sz="2200" b="1" i="0" spc="-22">
+          <p:cNvPr id="38" name="Oval 37"/>
+          <p:cNvSpPr/>
+          <p:nvPr/>
+        </p:nvSpPr>
+        <p:spPr>
+          <a:xfrm>
+            <a:off x="1453895" y="3259836"/>
+            <a:ext cx="201168" cy="201168"/>
+          </a:xfrm>
+          <a:prstGeom prst="ellipse">
+            <a:avLst/>
+          </a:prstGeom>
+          <a:solidFill>
+            <a:srgbClr val="00754A"/>
+          </a:solidFill>
+          <a:ln>
+            <a:noFill/>
+          </a:ln>
+        </p:spPr>
+        <p:style>
+          <a:lnRef idx="1">
+            <a:schemeClr val="accent1"/>
+          </a:lnRef>
+          <a:fillRef idx="3">
+            <a:schemeClr val="accent1"/>
+          </a:fillRef>
+          <a:effectRef idx="0">
+            <a:schemeClr val="accent1"/>
+          </a:effectRef>
+          <a:fontRef idx="minor">
+            <a:schemeClr val="lt1"/>
+          </a:fontRef>
+        </p:style>
+        <p:txBody>
+          <a:bodyPr rtlCol="0" anchor="ctr"/>
+          <a:lstStyle/>
+          <a:p>
+            <a:pPr algn="ctr"/>
+            <a:endParaRPr/>
+          </a:p>
+        </p:txBody>
+      </p:sp>
+      <p:sp>
+        <p:nvSpPr>
+          <p:cNvPr id="39" name="TextBox 38"/>
+          <p:cNvSpPr txBox="1"/>
+          <p:nvPr/>
+        </p:nvSpPr>
+        <p:spPr>
+          <a:xfrm>
+            <a:off x="548639" y="2697480"/>
+            <a:ext cx="2011680" cy="365760"/>
+          </a:xfrm>
+          <a:prstGeom prst="rect">
+            <a:avLst/>
+          </a:prstGeom>
+          <a:noFill/>
+        </p:spPr>
+        <p:txBody>
+          <a:bodyPr wrap="square">
+            <a:spAutoFit/>
+          </a:bodyPr>
+          <a:lstStyle/>
+          <a:p>
+            <a:pPr algn="ctr"/>
+            <a:r>
+              <a:rPr sz="2200" b="1" spc="-22">
+                <a:solidFill>
+                  <a:srgbClr val="006241"/>
+                </a:solidFill>
+                <a:latin typeface="Pretendard"/>
+              </a:rPr>
+              <a:t>2018</a:t>
+            </a:r>
+          </a:p>
+        </p:txBody>
+      </p:sp>
+      <p:sp>
+        <p:nvSpPr>
+          <p:cNvPr id="40" name="TextBox 39"/>
+          <p:cNvSpPr txBox="1"/>
+          <p:nvPr/>
+        </p:nvSpPr>
+        <p:spPr>
+          <a:xfrm>
+            <a:off x="457200" y="3639312"/>
+            <a:ext cx="2194560" cy="822960"/>
+          </a:xfrm>
+          <a:prstGeom prst="rect">
+            <a:avLst/>
+          </a:prstGeom>
+          <a:noFill/>
+        </p:spPr>
+        <p:txBody>
+          <a:bodyPr wrap="square">
+            <a:spAutoFit/>
+          </a:bodyPr>
+          <a:lstStyle/>
+          <a:p>
+            <a:pPr algn="ctr"/>
+            <a:r>
+              <a:rPr sz="1400" b="0" spc="-14">
                 <a:solidFill>
                   <a:srgbClr val="1F1F1F"/>
                 </a:solidFill>
                 <a:latin typeface="Pretendard"/>
               </a:rPr>
-              <a:t>Sang-Min Park, MD, PhD</a:t>
-            </a:r>
-          </a:p>
-        </p:txBody>
-      </p:sp>
-      <p:sp>
-        <p:nvSpPr>
-          <p:cNvPr id="10" name="TextBox 9"/>
-          <p:cNvSpPr txBox="1"/>
-          <p:nvPr/>
-        </p:nvSpPr>
-        <p:spPr>
-          <a:xfrm>
-            <a:off x="272216" y="6378122"/>
-            <a:ext cx="7315200" cy="384048"/>
-          </a:xfrm>
-          <a:prstGeom prst="rect">
-            <a:avLst/>
-          </a:prstGeom>
-          <a:noFill/>
-        </p:spPr>
-        <p:txBody>
-          <a:bodyPr wrap="square" lIns="0" tIns="0" rIns="0" bIns="0" anchor="t">
-            <a:spAutoFit/>
-          </a:bodyPr>
-          <a:lstStyle/>
-          <a:p>
-            <a:pPr algn="l"/>
-            <a:r>
-              <a:rPr sz="1400" b="0" i="0" spc="-14">
-                <a:solidFill>
-                  <a:srgbClr val="6B6B6B"/>
-                </a:solidFill>
-                <a:latin typeface="Pretendard"/>
-              </a:rPr>
-              <a:t>Conference name   |   YYYY.MM</a:t>
+              <a:t>Single-center</a:t>
+            </a:r>
+          </a:p>
+          <a:p>
+            <a:pPr algn="ctr"/>
+            <a:r>
+              <a:rPr sz="1400" b="0" spc="-14">
+                <a:solidFill>
+                  <a:srgbClr val="1F1F1F"/>
+                </a:solidFill>
+                <a:latin typeface="Pretendard"/>
+              </a:rPr>
+              <a:t>pilot</a:t>
+            </a:r>
+          </a:p>
+        </p:txBody>
+      </p:sp>
+      <p:sp>
+        <p:nvSpPr>
+          <p:cNvPr id="41" name="Oval 40"/>
+          <p:cNvSpPr/>
+          <p:nvPr/>
+        </p:nvSpPr>
+        <p:spPr>
+          <a:xfrm>
+            <a:off x="3717035" y="3259836"/>
+            <a:ext cx="201168" cy="201168"/>
+          </a:xfrm>
+          <a:prstGeom prst="ellipse">
+            <a:avLst/>
+          </a:prstGeom>
+          <a:solidFill>
+            <a:srgbClr val="00754A"/>
+          </a:solidFill>
+          <a:ln>
+            <a:noFill/>
+          </a:ln>
+        </p:spPr>
+        <p:style>
+          <a:lnRef idx="1">
+            <a:schemeClr val="accent1"/>
+          </a:lnRef>
+          <a:fillRef idx="3">
+            <a:schemeClr val="accent1"/>
+          </a:fillRef>
+          <a:effectRef idx="0">
+            <a:schemeClr val="accent1"/>
+          </a:effectRef>
+          <a:fontRef idx="minor">
+            <a:schemeClr val="lt1"/>
+          </a:fontRef>
+        </p:style>
+        <p:txBody>
+          <a:bodyPr rtlCol="0" anchor="ctr"/>
+          <a:lstStyle/>
+          <a:p>
+            <a:pPr algn="ctr"/>
+            <a:endParaRPr/>
+          </a:p>
+        </p:txBody>
+      </p:sp>
+      <p:sp>
+        <p:nvSpPr>
+          <p:cNvPr id="42" name="TextBox 41"/>
+          <p:cNvSpPr txBox="1"/>
+          <p:nvPr/>
+        </p:nvSpPr>
+        <p:spPr>
+          <a:xfrm>
+            <a:off x="2811779" y="2697480"/>
+            <a:ext cx="2011680" cy="365760"/>
+          </a:xfrm>
+          <a:prstGeom prst="rect">
+            <a:avLst/>
+          </a:prstGeom>
+          <a:noFill/>
+        </p:spPr>
+        <p:txBody>
+          <a:bodyPr wrap="square">
+            <a:spAutoFit/>
+          </a:bodyPr>
+          <a:lstStyle/>
+          <a:p>
+            <a:pPr algn="ctr"/>
+            <a:r>
+              <a:rPr sz="2200" b="1" spc="-22">
+                <a:solidFill>
+                  <a:srgbClr val="006241"/>
+                </a:solidFill>
+                <a:latin typeface="Pretendard"/>
+              </a:rPr>
+              <a:t>2020</a:t>
+            </a:r>
+          </a:p>
+        </p:txBody>
+      </p:sp>
+      <p:sp>
+        <p:nvSpPr>
+          <p:cNvPr id="43" name="TextBox 42"/>
+          <p:cNvSpPr txBox="1"/>
+          <p:nvPr/>
+        </p:nvSpPr>
+        <p:spPr>
+          <a:xfrm>
+            <a:off x="2720339" y="3639312"/>
+            <a:ext cx="2194560" cy="822960"/>
+          </a:xfrm>
+          <a:prstGeom prst="rect">
+            <a:avLst/>
+          </a:prstGeom>
+          <a:noFill/>
+        </p:spPr>
+        <p:txBody>
+          <a:bodyPr wrap="square">
+            <a:spAutoFit/>
+          </a:bodyPr>
+          <a:lstStyle/>
+          <a:p>
+            <a:pPr algn="ctr"/>
+            <a:r>
+              <a:rPr sz="1400" b="0" spc="-14">
+                <a:solidFill>
+                  <a:srgbClr val="1F1F1F"/>
+                </a:solidFill>
+                <a:latin typeface="Pretendard"/>
+              </a:rPr>
+              <a:t>Multicenter</a:t>
+            </a:r>
+          </a:p>
+          <a:p>
+            <a:pPr algn="ctr"/>
+            <a:r>
+              <a:rPr sz="1400" b="0" spc="-14">
+                <a:solidFill>
+                  <a:srgbClr val="1F1F1F"/>
+                </a:solidFill>
+                <a:latin typeface="Pretendard"/>
+              </a:rPr>
+              <a:t>protocol</a:t>
+            </a:r>
+          </a:p>
+        </p:txBody>
+      </p:sp>
+      <p:sp>
+        <p:nvSpPr>
+          <p:cNvPr id="44" name="Oval 43"/>
+          <p:cNvSpPr/>
+          <p:nvPr/>
+        </p:nvSpPr>
+        <p:spPr>
+          <a:xfrm>
+            <a:off x="5980176" y="3259836"/>
+            <a:ext cx="201168" cy="201168"/>
+          </a:xfrm>
+          <a:prstGeom prst="ellipse">
+            <a:avLst/>
+          </a:prstGeom>
+          <a:solidFill>
+            <a:srgbClr val="00754A"/>
+          </a:solidFill>
+          <a:ln>
+            <a:noFill/>
+          </a:ln>
+        </p:spPr>
+        <p:style>
+          <a:lnRef idx="1">
+            <a:schemeClr val="accent1"/>
+          </a:lnRef>
+          <a:fillRef idx="3">
+            <a:schemeClr val="accent1"/>
+          </a:fillRef>
+          <a:effectRef idx="0">
+            <a:schemeClr val="accent1"/>
+          </a:effectRef>
+          <a:fontRef idx="minor">
+            <a:schemeClr val="lt1"/>
+          </a:fontRef>
+        </p:style>
+        <p:txBody>
+          <a:bodyPr rtlCol="0" anchor="ctr"/>
+          <a:lstStyle/>
+          <a:p>
+            <a:pPr algn="ctr"/>
+            <a:endParaRPr/>
+          </a:p>
+        </p:txBody>
+      </p:sp>
+      <p:sp>
+        <p:nvSpPr>
+          <p:cNvPr id="45" name="TextBox 44"/>
+          <p:cNvSpPr txBox="1"/>
+          <p:nvPr/>
+        </p:nvSpPr>
+        <p:spPr>
+          <a:xfrm>
+            <a:off x="5074920" y="2697480"/>
+            <a:ext cx="2011680" cy="365760"/>
+          </a:xfrm>
+          <a:prstGeom prst="rect">
+            <a:avLst/>
+          </a:prstGeom>
+          <a:noFill/>
+        </p:spPr>
+        <p:txBody>
+          <a:bodyPr wrap="square">
+            <a:spAutoFit/>
+          </a:bodyPr>
+          <a:lstStyle/>
+          <a:p>
+            <a:pPr algn="ctr"/>
+            <a:r>
+              <a:rPr sz="2200" b="1" spc="-22">
+                <a:solidFill>
+                  <a:srgbClr val="006241"/>
+                </a:solidFill>
+                <a:latin typeface="Pretendard"/>
+              </a:rPr>
+              <a:t>2021</a:t>
+            </a:r>
+          </a:p>
+        </p:txBody>
+      </p:sp>
+      <p:sp>
+        <p:nvSpPr>
+          <p:cNvPr id="46" name="TextBox 45"/>
+          <p:cNvSpPr txBox="1"/>
+          <p:nvPr/>
+        </p:nvSpPr>
+        <p:spPr>
+          <a:xfrm>
+            <a:off x="4983480" y="3639312"/>
+            <a:ext cx="2194560" cy="822960"/>
+          </a:xfrm>
+          <a:prstGeom prst="rect">
+            <a:avLst/>
+          </a:prstGeom>
+          <a:noFill/>
+        </p:spPr>
+        <p:txBody>
+          <a:bodyPr wrap="square">
+            <a:spAutoFit/>
+          </a:bodyPr>
+          <a:lstStyle/>
+          <a:p>
+            <a:pPr algn="ctr"/>
+            <a:r>
+              <a:rPr sz="1400" b="0" spc="-14">
+                <a:solidFill>
+                  <a:srgbClr val="1F1F1F"/>
+                </a:solidFill>
+                <a:latin typeface="Pretendard"/>
+              </a:rPr>
+              <a:t>First RCT</a:t>
+            </a:r>
+          </a:p>
+          <a:p>
+            <a:pPr algn="ctr"/>
+            <a:r>
+              <a:rPr sz="1400" b="0" spc="-14">
+                <a:solidFill>
+                  <a:srgbClr val="1F1F1F"/>
+                </a:solidFill>
+                <a:latin typeface="Pretendard"/>
+              </a:rPr>
+              <a:t>enrolment</a:t>
+            </a:r>
+          </a:p>
+        </p:txBody>
+      </p:sp>
+      <p:sp>
+        <p:nvSpPr>
+          <p:cNvPr id="47" name="Oval 46"/>
+          <p:cNvSpPr/>
+          <p:nvPr/>
+        </p:nvSpPr>
+        <p:spPr>
+          <a:xfrm>
+            <a:off x="8243316" y="3259836"/>
+            <a:ext cx="201168" cy="201168"/>
+          </a:xfrm>
+          <a:prstGeom prst="ellipse">
+            <a:avLst/>
+          </a:prstGeom>
+          <a:solidFill>
+            <a:srgbClr val="00754A"/>
+          </a:solidFill>
+          <a:ln>
+            <a:noFill/>
+          </a:ln>
+        </p:spPr>
+        <p:style>
+          <a:lnRef idx="1">
+            <a:schemeClr val="accent1"/>
+          </a:lnRef>
+          <a:fillRef idx="3">
+            <a:schemeClr val="accent1"/>
+          </a:fillRef>
+          <a:effectRef idx="0">
+            <a:schemeClr val="accent1"/>
+          </a:effectRef>
+          <a:fontRef idx="minor">
+            <a:schemeClr val="lt1"/>
+          </a:fontRef>
+        </p:style>
+        <p:txBody>
+          <a:bodyPr rtlCol="0" anchor="ctr"/>
+          <a:lstStyle/>
+          <a:p>
+            <a:pPr algn="ctr"/>
+            <a:endParaRPr/>
+          </a:p>
+        </p:txBody>
+      </p:sp>
+      <p:sp>
+        <p:nvSpPr>
+          <p:cNvPr id="48" name="TextBox 47"/>
+          <p:cNvSpPr txBox="1"/>
+          <p:nvPr/>
+        </p:nvSpPr>
+        <p:spPr>
+          <a:xfrm>
+            <a:off x="7338060" y="2697480"/>
+            <a:ext cx="2011680" cy="365760"/>
+          </a:xfrm>
+          <a:prstGeom prst="rect">
+            <a:avLst/>
+          </a:prstGeom>
+          <a:noFill/>
+        </p:spPr>
+        <p:txBody>
+          <a:bodyPr wrap="square">
+            <a:spAutoFit/>
+          </a:bodyPr>
+          <a:lstStyle/>
+          <a:p>
+            <a:pPr algn="ctr"/>
+            <a:r>
+              <a:rPr sz="2200" b="1" spc="-22">
+                <a:solidFill>
+                  <a:srgbClr val="006241"/>
+                </a:solidFill>
+                <a:latin typeface="Pretendard"/>
+              </a:rPr>
+              <a:t>2023</a:t>
+            </a:r>
+          </a:p>
+        </p:txBody>
+      </p:sp>
+      <p:sp>
+        <p:nvSpPr>
+          <p:cNvPr id="49" name="TextBox 48"/>
+          <p:cNvSpPr txBox="1"/>
+          <p:nvPr/>
+        </p:nvSpPr>
+        <p:spPr>
+          <a:xfrm>
+            <a:off x="7246620" y="3639312"/>
+            <a:ext cx="2194560" cy="822960"/>
+          </a:xfrm>
+          <a:prstGeom prst="rect">
+            <a:avLst/>
+          </a:prstGeom>
+          <a:noFill/>
+        </p:spPr>
+        <p:txBody>
+          <a:bodyPr wrap="square">
+            <a:spAutoFit/>
+          </a:bodyPr>
+          <a:lstStyle/>
+          <a:p>
+            <a:pPr algn="ctr"/>
+            <a:r>
+              <a:rPr sz="1400" b="0" spc="-14">
+                <a:solidFill>
+                  <a:srgbClr val="1F1F1F"/>
+                </a:solidFill>
+                <a:latin typeface="Pretendard"/>
+              </a:rPr>
+              <a:t>Two RCTs</a:t>
+            </a:r>
+          </a:p>
+          <a:p>
+            <a:pPr algn="ctr"/>
+            <a:r>
+              <a:rPr sz="1400" b="0" spc="-14">
+                <a:solidFill>
+                  <a:srgbClr val="1F1F1F"/>
+                </a:solidFill>
+                <a:latin typeface="Pretendard"/>
+              </a:rPr>
+              <a:t>completed</a:t>
+            </a:r>
+          </a:p>
+        </p:txBody>
+      </p:sp>
+      <p:sp>
+        <p:nvSpPr>
+          <p:cNvPr id="50" name="Oval 49"/>
+          <p:cNvSpPr/>
+          <p:nvPr/>
+        </p:nvSpPr>
+        <p:spPr>
+          <a:xfrm>
+            <a:off x="10506456" y="3259836"/>
+            <a:ext cx="201168" cy="201168"/>
+          </a:xfrm>
+          <a:prstGeom prst="ellipse">
+            <a:avLst/>
+          </a:prstGeom>
+          <a:solidFill>
+            <a:srgbClr val="00754A"/>
+          </a:solidFill>
+          <a:ln>
+            <a:noFill/>
+          </a:ln>
+        </p:spPr>
+        <p:style>
+          <a:lnRef idx="1">
+            <a:schemeClr val="accent1"/>
+          </a:lnRef>
+          <a:fillRef idx="3">
+            <a:schemeClr val="accent1"/>
+          </a:fillRef>
+          <a:effectRef idx="0">
+            <a:schemeClr val="accent1"/>
+          </a:effectRef>
+          <a:fontRef idx="minor">
+            <a:schemeClr val="lt1"/>
+          </a:fontRef>
+        </p:style>
+        <p:txBody>
+          <a:bodyPr rtlCol="0" anchor="ctr"/>
+          <a:lstStyle/>
+          <a:p>
+            <a:pPr algn="ctr"/>
+            <a:endParaRPr/>
+          </a:p>
+        </p:txBody>
+      </p:sp>
+      <p:sp>
+        <p:nvSpPr>
+          <p:cNvPr id="51" name="TextBox 50"/>
+          <p:cNvSpPr txBox="1"/>
+          <p:nvPr/>
+        </p:nvSpPr>
+        <p:spPr>
+          <a:xfrm>
+            <a:off x="9601200" y="2697480"/>
+            <a:ext cx="2011680" cy="365760"/>
+          </a:xfrm>
+          <a:prstGeom prst="rect">
+            <a:avLst/>
+          </a:prstGeom>
+          <a:noFill/>
+        </p:spPr>
+        <p:txBody>
+          <a:bodyPr wrap="square">
+            <a:spAutoFit/>
+          </a:bodyPr>
+          <a:lstStyle/>
+          <a:p>
+            <a:pPr algn="ctr"/>
+            <a:r>
+              <a:rPr sz="2200" b="1" spc="-22">
+                <a:solidFill>
+                  <a:srgbClr val="006241"/>
+                </a:solidFill>
+                <a:latin typeface="Pretendard"/>
+              </a:rPr>
+              <a:t>2025</a:t>
+            </a:r>
+          </a:p>
+        </p:txBody>
+      </p:sp>
+      <p:sp>
+        <p:nvSpPr>
+          <p:cNvPr id="52" name="TextBox 51"/>
+          <p:cNvSpPr txBox="1"/>
+          <p:nvPr/>
+        </p:nvSpPr>
+        <p:spPr>
+          <a:xfrm>
+            <a:off x="9509760" y="3639312"/>
+            <a:ext cx="2194560" cy="822960"/>
+          </a:xfrm>
+          <a:prstGeom prst="rect">
+            <a:avLst/>
+          </a:prstGeom>
+          <a:noFill/>
+        </p:spPr>
+        <p:txBody>
+          <a:bodyPr wrap="square">
+            <a:spAutoFit/>
+          </a:bodyPr>
+          <a:lstStyle/>
+          <a:p>
+            <a:pPr algn="ctr"/>
+            <a:r>
+              <a:rPr sz="1400" b="0" spc="-14">
+                <a:solidFill>
+                  <a:srgbClr val="1F1F1F"/>
+                </a:solidFill>
+                <a:latin typeface="Pretendard"/>
+              </a:rPr>
+              <a:t>Pooled</a:t>
+            </a:r>
+          </a:p>
+          <a:p>
+            <a:pPr algn="ctr"/>
+            <a:r>
+              <a:rPr sz="1400" b="0" spc="-14">
+                <a:solidFill>
+                  <a:srgbClr val="1F1F1F"/>
+                </a:solidFill>
+                <a:latin typeface="Pretendard"/>
+              </a:rPr>
+              <a:t>analyses</a:t>
             </a:r>
           </a:p>
         </p:txBody>
@@ -7339,7 +7884,7 @@
                 </a:solidFill>
                 <a:latin typeface="Pretendard"/>
               </a:rPr>
-              <a:t>PATTERN J</a:t>
+              <a:t>PATTERN K</a:t>
             </a:r>
           </a:p>
         </p:txBody>
@@ -7403,7 +7948,7 @@
                 </a:solidFill>
                 <a:latin typeface="Pretendard"/>
               </a:rPr>
-              <a:t>Timeline — Milestone Track</a:t>
+              <a:t>Process Flow — CONSORT</a:t>
             </a:r>
           </a:p>
         </p:txBody>
@@ -7526,16 +8071,472 @@
       </p:sp>
       <p:sp>
         <p:nvSpPr>
-          <p:cNvPr id="37" name="Rectangle 36"/>
+          <p:cNvPr id="37" name="Rounded Rectangle 36"/>
           <p:cNvSpPr/>
           <p:nvPr/>
         </p:nvSpPr>
         <p:spPr>
           <a:xfrm>
-            <a:off x="1554480" y="3310128"/>
-            <a:ext cx="9052560" cy="32004"/>
-          </a:xfrm>
-          <a:prstGeom prst="rect">
+            <a:off x="502920" y="2834640"/>
+            <a:ext cx="2468880" cy="1325880"/>
+          </a:xfrm>
+          <a:prstGeom prst="roundRect">
+            <a:avLst/>
+          </a:prstGeom>
+          <a:noFill/>
+          <a:ln w="15875">
+            <a:solidFill>
+              <a:srgbClr val="00754A"/>
+            </a:solidFill>
+          </a:ln>
+        </p:spPr>
+        <p:style>
+          <a:lnRef idx="1">
+            <a:schemeClr val="accent1"/>
+          </a:lnRef>
+          <a:fillRef idx="3">
+            <a:schemeClr val="accent1"/>
+          </a:fillRef>
+          <a:effectRef idx="0">
+            <a:schemeClr val="accent1"/>
+          </a:effectRef>
+          <a:fontRef idx="minor">
+            <a:schemeClr val="lt1"/>
+          </a:fontRef>
+        </p:style>
+        <p:txBody>
+          <a:bodyPr rtlCol="0" anchor="ctr"/>
+          <a:lstStyle/>
+          <a:p>
+            <a:pPr algn="ctr"/>
+            <a:endParaRPr/>
+          </a:p>
+        </p:txBody>
+      </p:sp>
+      <p:sp>
+        <p:nvSpPr>
+          <p:cNvPr id="38" name="TextBox 37"/>
+          <p:cNvSpPr txBox="1"/>
+          <p:nvPr/>
+        </p:nvSpPr>
+        <p:spPr>
+          <a:xfrm>
+            <a:off x="502920" y="3154680"/>
+            <a:ext cx="2468880" cy="411480"/>
+          </a:xfrm>
+          <a:prstGeom prst="rect">
+            <a:avLst/>
+          </a:prstGeom>
+          <a:noFill/>
+        </p:spPr>
+        <p:txBody>
+          <a:bodyPr wrap="square">
+            <a:spAutoFit/>
+          </a:bodyPr>
+          <a:lstStyle/>
+          <a:p>
+            <a:pPr algn="ctr"/>
+            <a:r>
+              <a:rPr sz="1800" b="1" spc="-18">
+                <a:solidFill>
+                  <a:srgbClr val="1F1F1F"/>
+                </a:solidFill>
+                <a:latin typeface="Pretendard"/>
+              </a:rPr>
+              <a:t>Assessed</a:t>
+            </a:r>
+          </a:p>
+        </p:txBody>
+      </p:sp>
+      <p:sp>
+        <p:nvSpPr>
+          <p:cNvPr id="39" name="TextBox 38"/>
+          <p:cNvSpPr txBox="1"/>
+          <p:nvPr/>
+        </p:nvSpPr>
+        <p:spPr>
+          <a:xfrm>
+            <a:off x="502920" y="3611880"/>
+            <a:ext cx="2468880" cy="411480"/>
+          </a:xfrm>
+          <a:prstGeom prst="rect">
+            <a:avLst/>
+          </a:prstGeom>
+          <a:noFill/>
+        </p:spPr>
+        <p:txBody>
+          <a:bodyPr wrap="square">
+            <a:spAutoFit/>
+          </a:bodyPr>
+          <a:lstStyle/>
+          <a:p>
+            <a:pPr algn="ctr"/>
+            <a:r>
+              <a:rPr sz="1600" b="0" spc="-16">
+                <a:solidFill>
+                  <a:srgbClr val="6B6B6B"/>
+                </a:solidFill>
+                <a:latin typeface="Pretendard"/>
+              </a:rPr>
+              <a:t>n = NNN</a:t>
+            </a:r>
+          </a:p>
+        </p:txBody>
+      </p:sp>
+      <p:sp>
+        <p:nvSpPr>
+          <p:cNvPr id="40" name="Rounded Rectangle 39"/>
+          <p:cNvSpPr/>
+          <p:nvPr/>
+        </p:nvSpPr>
+        <p:spPr>
+          <a:xfrm>
+            <a:off x="3291840" y="2834640"/>
+            <a:ext cx="2468880" cy="1325880"/>
+          </a:xfrm>
+          <a:prstGeom prst="roundRect">
+            <a:avLst/>
+          </a:prstGeom>
+          <a:noFill/>
+          <a:ln w="15875">
+            <a:solidFill>
+              <a:srgbClr val="00754A"/>
+            </a:solidFill>
+          </a:ln>
+        </p:spPr>
+        <p:style>
+          <a:lnRef idx="1">
+            <a:schemeClr val="accent1"/>
+          </a:lnRef>
+          <a:fillRef idx="3">
+            <a:schemeClr val="accent1"/>
+          </a:fillRef>
+          <a:effectRef idx="0">
+            <a:schemeClr val="accent1"/>
+          </a:effectRef>
+          <a:fontRef idx="minor">
+            <a:schemeClr val="lt1"/>
+          </a:fontRef>
+        </p:style>
+        <p:txBody>
+          <a:bodyPr rtlCol="0" anchor="ctr"/>
+          <a:lstStyle/>
+          <a:p>
+            <a:pPr algn="ctr"/>
+            <a:endParaRPr/>
+          </a:p>
+        </p:txBody>
+      </p:sp>
+      <p:sp>
+        <p:nvSpPr>
+          <p:cNvPr id="41" name="TextBox 40"/>
+          <p:cNvSpPr txBox="1"/>
+          <p:nvPr/>
+        </p:nvSpPr>
+        <p:spPr>
+          <a:xfrm>
+            <a:off x="3291840" y="3154680"/>
+            <a:ext cx="2468880" cy="411480"/>
+          </a:xfrm>
+          <a:prstGeom prst="rect">
+            <a:avLst/>
+          </a:prstGeom>
+          <a:noFill/>
+        </p:spPr>
+        <p:txBody>
+          <a:bodyPr wrap="square">
+            <a:spAutoFit/>
+          </a:bodyPr>
+          <a:lstStyle/>
+          <a:p>
+            <a:pPr algn="ctr"/>
+            <a:r>
+              <a:rPr sz="1800" b="1" spc="-18">
+                <a:solidFill>
+                  <a:srgbClr val="1F1F1F"/>
+                </a:solidFill>
+                <a:latin typeface="Pretendard"/>
+              </a:rPr>
+              <a:t>Randomized</a:t>
+            </a:r>
+          </a:p>
+        </p:txBody>
+      </p:sp>
+      <p:sp>
+        <p:nvSpPr>
+          <p:cNvPr id="42" name="TextBox 41"/>
+          <p:cNvSpPr txBox="1"/>
+          <p:nvPr/>
+        </p:nvSpPr>
+        <p:spPr>
+          <a:xfrm>
+            <a:off x="3291840" y="3611880"/>
+            <a:ext cx="2468880" cy="411480"/>
+          </a:xfrm>
+          <a:prstGeom prst="rect">
+            <a:avLst/>
+          </a:prstGeom>
+          <a:noFill/>
+        </p:spPr>
+        <p:txBody>
+          <a:bodyPr wrap="square">
+            <a:spAutoFit/>
+          </a:bodyPr>
+          <a:lstStyle/>
+          <a:p>
+            <a:pPr algn="ctr"/>
+            <a:r>
+              <a:rPr sz="1600" b="0" spc="-16">
+                <a:solidFill>
+                  <a:srgbClr val="6B6B6B"/>
+                </a:solidFill>
+                <a:latin typeface="Pretendard"/>
+              </a:rPr>
+              <a:t>n = NNN</a:t>
+            </a:r>
+          </a:p>
+        </p:txBody>
+      </p:sp>
+      <p:sp>
+        <p:nvSpPr>
+          <p:cNvPr id="43" name="Rounded Rectangle 42"/>
+          <p:cNvSpPr/>
+          <p:nvPr/>
+        </p:nvSpPr>
+        <p:spPr>
+          <a:xfrm>
+            <a:off x="6080760" y="2834640"/>
+            <a:ext cx="2468880" cy="1325880"/>
+          </a:xfrm>
+          <a:prstGeom prst="roundRect">
+            <a:avLst/>
+          </a:prstGeom>
+          <a:noFill/>
+          <a:ln w="15875">
+            <a:solidFill>
+              <a:srgbClr val="00754A"/>
+            </a:solidFill>
+          </a:ln>
+        </p:spPr>
+        <p:style>
+          <a:lnRef idx="1">
+            <a:schemeClr val="accent1"/>
+          </a:lnRef>
+          <a:fillRef idx="3">
+            <a:schemeClr val="accent1"/>
+          </a:fillRef>
+          <a:effectRef idx="0">
+            <a:schemeClr val="accent1"/>
+          </a:effectRef>
+          <a:fontRef idx="minor">
+            <a:schemeClr val="lt1"/>
+          </a:fontRef>
+        </p:style>
+        <p:txBody>
+          <a:bodyPr rtlCol="0" anchor="ctr"/>
+          <a:lstStyle/>
+          <a:p>
+            <a:pPr algn="ctr"/>
+            <a:endParaRPr/>
+          </a:p>
+        </p:txBody>
+      </p:sp>
+      <p:sp>
+        <p:nvSpPr>
+          <p:cNvPr id="44" name="TextBox 43"/>
+          <p:cNvSpPr txBox="1"/>
+          <p:nvPr/>
+        </p:nvSpPr>
+        <p:spPr>
+          <a:xfrm>
+            <a:off x="6080760" y="3154680"/>
+            <a:ext cx="2468880" cy="411480"/>
+          </a:xfrm>
+          <a:prstGeom prst="rect">
+            <a:avLst/>
+          </a:prstGeom>
+          <a:noFill/>
+        </p:spPr>
+        <p:txBody>
+          <a:bodyPr wrap="square">
+            <a:spAutoFit/>
+          </a:bodyPr>
+          <a:lstStyle/>
+          <a:p>
+            <a:pPr algn="ctr"/>
+            <a:r>
+              <a:rPr sz="1800" b="1" spc="-18">
+                <a:solidFill>
+                  <a:srgbClr val="1F1F1F"/>
+                </a:solidFill>
+                <a:latin typeface="Pretendard"/>
+              </a:rPr>
+              <a:t>Allocated</a:t>
+            </a:r>
+          </a:p>
+        </p:txBody>
+      </p:sp>
+      <p:sp>
+        <p:nvSpPr>
+          <p:cNvPr id="45" name="TextBox 44"/>
+          <p:cNvSpPr txBox="1"/>
+          <p:nvPr/>
+        </p:nvSpPr>
+        <p:spPr>
+          <a:xfrm>
+            <a:off x="6080760" y="3611880"/>
+            <a:ext cx="2468880" cy="411480"/>
+          </a:xfrm>
+          <a:prstGeom prst="rect">
+            <a:avLst/>
+          </a:prstGeom>
+          <a:noFill/>
+        </p:spPr>
+        <p:txBody>
+          <a:bodyPr wrap="square">
+            <a:spAutoFit/>
+          </a:bodyPr>
+          <a:lstStyle/>
+          <a:p>
+            <a:pPr algn="ctr"/>
+            <a:r>
+              <a:rPr sz="1600" b="0" spc="-16">
+                <a:solidFill>
+                  <a:srgbClr val="6B6B6B"/>
+                </a:solidFill>
+                <a:latin typeface="Pretendard"/>
+              </a:rPr>
+              <a:t>n = NN / NN</a:t>
+            </a:r>
+          </a:p>
+        </p:txBody>
+      </p:sp>
+      <p:sp>
+        <p:nvSpPr>
+          <p:cNvPr id="46" name="Rounded Rectangle 45"/>
+          <p:cNvSpPr/>
+          <p:nvPr/>
+        </p:nvSpPr>
+        <p:spPr>
+          <a:xfrm>
+            <a:off x="8869680" y="2834640"/>
+            <a:ext cx="2468880" cy="1325880"/>
+          </a:xfrm>
+          <a:prstGeom prst="roundRect">
+            <a:avLst/>
+          </a:prstGeom>
+          <a:noFill/>
+          <a:ln w="15875">
+            <a:solidFill>
+              <a:srgbClr val="00754A"/>
+            </a:solidFill>
+          </a:ln>
+        </p:spPr>
+        <p:style>
+          <a:lnRef idx="1">
+            <a:schemeClr val="accent1"/>
+          </a:lnRef>
+          <a:fillRef idx="3">
+            <a:schemeClr val="accent1"/>
+          </a:fillRef>
+          <a:effectRef idx="0">
+            <a:schemeClr val="accent1"/>
+          </a:effectRef>
+          <a:fontRef idx="minor">
+            <a:schemeClr val="lt1"/>
+          </a:fontRef>
+        </p:style>
+        <p:txBody>
+          <a:bodyPr rtlCol="0" anchor="ctr"/>
+          <a:lstStyle/>
+          <a:p>
+            <a:pPr algn="ctr"/>
+            <a:endParaRPr/>
+          </a:p>
+        </p:txBody>
+      </p:sp>
+      <p:sp>
+        <p:nvSpPr>
+          <p:cNvPr id="47" name="TextBox 46"/>
+          <p:cNvSpPr txBox="1"/>
+          <p:nvPr/>
+        </p:nvSpPr>
+        <p:spPr>
+          <a:xfrm>
+            <a:off x="8869680" y="3154680"/>
+            <a:ext cx="2468880" cy="411480"/>
+          </a:xfrm>
+          <a:prstGeom prst="rect">
+            <a:avLst/>
+          </a:prstGeom>
+          <a:noFill/>
+        </p:spPr>
+        <p:txBody>
+          <a:bodyPr wrap="square">
+            <a:spAutoFit/>
+          </a:bodyPr>
+          <a:lstStyle/>
+          <a:p>
+            <a:pPr algn="ctr"/>
+            <a:r>
+              <a:rPr sz="1800" b="1" spc="-18">
+                <a:solidFill>
+                  <a:srgbClr val="1F1F1F"/>
+                </a:solidFill>
+                <a:latin typeface="Pretendard"/>
+              </a:rPr>
+              <a:t>Analyzed</a:t>
+            </a:r>
+          </a:p>
+        </p:txBody>
+      </p:sp>
+      <p:sp>
+        <p:nvSpPr>
+          <p:cNvPr id="48" name="TextBox 47"/>
+          <p:cNvSpPr txBox="1"/>
+          <p:nvPr/>
+        </p:nvSpPr>
+        <p:spPr>
+          <a:xfrm>
+            <a:off x="8869680" y="3611880"/>
+            <a:ext cx="2468880" cy="411480"/>
+          </a:xfrm>
+          <a:prstGeom prst="rect">
+            <a:avLst/>
+          </a:prstGeom>
+          <a:noFill/>
+        </p:spPr>
+        <p:txBody>
+          <a:bodyPr wrap="square">
+            <a:spAutoFit/>
+          </a:bodyPr>
+          <a:lstStyle/>
+          <a:p>
+            <a:pPr algn="ctr"/>
+            <a:r>
+              <a:rPr sz="1600" b="0" spc="-16">
+                <a:solidFill>
+                  <a:srgbClr val="6B6B6B"/>
+                </a:solidFill>
+                <a:latin typeface="Pretendard"/>
+              </a:rPr>
+              <a:t>n = NN / NN</a:t>
+            </a:r>
+          </a:p>
+        </p:txBody>
+      </p:sp>
+      <p:sp>
+        <p:nvSpPr>
+          <p:cNvPr id="49" name="Right Arrow 48"/>
+          <p:cNvSpPr/>
+          <p:nvPr/>
+        </p:nvSpPr>
+        <p:spPr>
+          <a:xfrm>
+            <a:off x="2990088" y="3364992"/>
+            <a:ext cx="256032" cy="274320"/>
+          </a:xfrm>
+          <a:prstGeom prst="rightArrow">
             <a:avLst/>
           </a:prstGeom>
           <a:solidFill>
@@ -7570,16 +8571,16 @@
       </p:sp>
       <p:sp>
         <p:nvSpPr>
-          <p:cNvPr id="38" name="Oval 37"/>
+          <p:cNvPr id="50" name="Right Arrow 49"/>
           <p:cNvSpPr/>
           <p:nvPr/>
         </p:nvSpPr>
         <p:spPr>
           <a:xfrm>
-            <a:off x="1453895" y="3259836"/>
-            <a:ext cx="201168" cy="201168"/>
-          </a:xfrm>
-          <a:prstGeom prst="ellipse">
+            <a:off x="5779008" y="3364992"/>
+            <a:ext cx="256032" cy="274320"/>
+          </a:xfrm>
+          <a:prstGeom prst="rightArrow">
             <a:avLst/>
           </a:prstGeom>
           <a:solidFill>
@@ -7614,98 +8615,16 @@
       </p:sp>
       <p:sp>
         <p:nvSpPr>
-          <p:cNvPr id="39" name="TextBox 38"/>
-          <p:cNvSpPr txBox="1"/>
-          <p:nvPr/>
-        </p:nvSpPr>
-        <p:spPr>
-          <a:xfrm>
-            <a:off x="548639" y="2697480"/>
-            <a:ext cx="2011680" cy="365760"/>
-          </a:xfrm>
-          <a:prstGeom prst="rect">
-            <a:avLst/>
-          </a:prstGeom>
-          <a:noFill/>
-        </p:spPr>
-        <p:txBody>
-          <a:bodyPr wrap="square">
-            <a:spAutoFit/>
-          </a:bodyPr>
-          <a:lstStyle/>
-          <a:p>
-            <a:pPr algn="ctr"/>
-            <a:r>
-              <a:rPr sz="2200" b="1" spc="-22">
-                <a:solidFill>
-                  <a:srgbClr val="006241"/>
-                </a:solidFill>
-                <a:latin typeface="Pretendard"/>
-              </a:rPr>
-              <a:t>2018</a:t>
-            </a:r>
-          </a:p>
-        </p:txBody>
-      </p:sp>
-      <p:sp>
-        <p:nvSpPr>
-          <p:cNvPr id="40" name="TextBox 39"/>
-          <p:cNvSpPr txBox="1"/>
-          <p:nvPr/>
-        </p:nvSpPr>
-        <p:spPr>
-          <a:xfrm>
-            <a:off x="457200" y="3639312"/>
-            <a:ext cx="2194560" cy="822960"/>
-          </a:xfrm>
-          <a:prstGeom prst="rect">
-            <a:avLst/>
-          </a:prstGeom>
-          <a:noFill/>
-        </p:spPr>
-        <p:txBody>
-          <a:bodyPr wrap="square">
-            <a:spAutoFit/>
-          </a:bodyPr>
-          <a:lstStyle/>
-          <a:p>
-            <a:pPr algn="ctr"/>
-            <a:r>
-              <a:rPr sz="1400" b="0" spc="-14">
-                <a:solidFill>
-                  <a:srgbClr val="1F1F1F"/>
-                </a:solidFill>
-                <a:latin typeface="Pretendard"/>
-              </a:rPr>
-              <a:t>Single-center</a:t>
-            </a:r>
-          </a:p>
-          <a:p>
-            <a:pPr algn="ctr"/>
-            <a:r>
-              <a:rPr sz="1400" b="0" spc="-14">
-                <a:solidFill>
-                  <a:srgbClr val="1F1F1F"/>
-                </a:solidFill>
-                <a:latin typeface="Pretendard"/>
-              </a:rPr>
-              <a:t>pilot</a:t>
-            </a:r>
-          </a:p>
-        </p:txBody>
-      </p:sp>
-      <p:sp>
-        <p:nvSpPr>
-          <p:cNvPr id="41" name="Oval 40"/>
+          <p:cNvPr id="51" name="Right Arrow 50"/>
           <p:cNvSpPr/>
           <p:nvPr/>
         </p:nvSpPr>
         <p:spPr>
           <a:xfrm>
-            <a:off x="3717035" y="3259836"/>
-            <a:ext cx="201168" cy="201168"/>
-          </a:xfrm>
-          <a:prstGeom prst="ellipse">
+            <a:off x="8567928" y="3364992"/>
+            <a:ext cx="256032" cy="274320"/>
+          </a:xfrm>
+          <a:prstGeom prst="rightArrow">
             <a:avLst/>
           </a:prstGeom>
           <a:solidFill>
@@ -7740,102 +8659,20 @@
       </p:sp>
       <p:sp>
         <p:nvSpPr>
-          <p:cNvPr id="42" name="TextBox 41"/>
-          <p:cNvSpPr txBox="1"/>
-          <p:nvPr/>
-        </p:nvSpPr>
-        <p:spPr>
-          <a:xfrm>
-            <a:off x="2811779" y="2697480"/>
-            <a:ext cx="2011680" cy="365760"/>
-          </a:xfrm>
-          <a:prstGeom prst="rect">
-            <a:avLst/>
-          </a:prstGeom>
-          <a:noFill/>
-        </p:spPr>
-        <p:txBody>
-          <a:bodyPr wrap="square">
-            <a:spAutoFit/>
-          </a:bodyPr>
-          <a:lstStyle/>
-          <a:p>
-            <a:pPr algn="ctr"/>
-            <a:r>
-              <a:rPr sz="2200" b="1" spc="-22">
-                <a:solidFill>
-                  <a:srgbClr val="006241"/>
-                </a:solidFill>
-                <a:latin typeface="Pretendard"/>
-              </a:rPr>
-              <a:t>2020</a:t>
-            </a:r>
-          </a:p>
-        </p:txBody>
-      </p:sp>
-      <p:sp>
-        <p:nvSpPr>
-          <p:cNvPr id="43" name="TextBox 42"/>
-          <p:cNvSpPr txBox="1"/>
-          <p:nvPr/>
-        </p:nvSpPr>
-        <p:spPr>
-          <a:xfrm>
-            <a:off x="2720339" y="3639312"/>
-            <a:ext cx="2194560" cy="822960"/>
-          </a:xfrm>
-          <a:prstGeom prst="rect">
-            <a:avLst/>
-          </a:prstGeom>
-          <a:noFill/>
-        </p:spPr>
-        <p:txBody>
-          <a:bodyPr wrap="square">
-            <a:spAutoFit/>
-          </a:bodyPr>
-          <a:lstStyle/>
-          <a:p>
-            <a:pPr algn="ctr"/>
-            <a:r>
-              <a:rPr sz="1400" b="0" spc="-14">
-                <a:solidFill>
-                  <a:srgbClr val="1F1F1F"/>
-                </a:solidFill>
-                <a:latin typeface="Pretendard"/>
-              </a:rPr>
-              <a:t>Multicenter</a:t>
-            </a:r>
-          </a:p>
-          <a:p>
-            <a:pPr algn="ctr"/>
-            <a:r>
-              <a:rPr sz="1400" b="0" spc="-14">
-                <a:solidFill>
-                  <a:srgbClr val="1F1F1F"/>
-                </a:solidFill>
-                <a:latin typeface="Pretendard"/>
-              </a:rPr>
-              <a:t>protocol</a:t>
-            </a:r>
-          </a:p>
-        </p:txBody>
-      </p:sp>
-      <p:sp>
-        <p:nvSpPr>
-          <p:cNvPr id="44" name="Oval 43"/>
+          <p:cNvPr id="52" name="Down Arrow 51"/>
           <p:cNvSpPr/>
           <p:nvPr/>
         </p:nvSpPr>
         <p:spPr>
           <a:xfrm>
-            <a:off x="5980176" y="3259836"/>
-            <a:ext cx="201168" cy="201168"/>
-          </a:xfrm>
-          <a:prstGeom prst="ellipse">
+            <a:off x="4434840" y="4297680"/>
+            <a:ext cx="201168" cy="320040"/>
+          </a:xfrm>
+          <a:prstGeom prst="downArrow">
             <a:avLst/>
           </a:prstGeom>
           <a:solidFill>
-            <a:srgbClr val="00754A"/>
+            <a:srgbClr val="6B6B6B"/>
           </a:solidFill>
           <a:ln>
             <a:noFill/>
@@ -7866,105 +8703,23 @@
       </p:sp>
       <p:sp>
         <p:nvSpPr>
-          <p:cNvPr id="45" name="TextBox 44"/>
-          <p:cNvSpPr txBox="1"/>
-          <p:nvPr/>
-        </p:nvSpPr>
-        <p:spPr>
-          <a:xfrm>
-            <a:off x="5074920" y="2697480"/>
-            <a:ext cx="2011680" cy="365760"/>
-          </a:xfrm>
-          <a:prstGeom prst="rect">
-            <a:avLst/>
-          </a:prstGeom>
-          <a:noFill/>
-        </p:spPr>
-        <p:txBody>
-          <a:bodyPr wrap="square">
-            <a:spAutoFit/>
-          </a:bodyPr>
-          <a:lstStyle/>
-          <a:p>
-            <a:pPr algn="ctr"/>
-            <a:r>
-              <a:rPr sz="2200" b="1" spc="-22">
-                <a:solidFill>
-                  <a:srgbClr val="006241"/>
-                </a:solidFill>
-                <a:latin typeface="Pretendard"/>
-              </a:rPr>
-              <a:t>2021</a:t>
-            </a:r>
-          </a:p>
-        </p:txBody>
-      </p:sp>
-      <p:sp>
-        <p:nvSpPr>
-          <p:cNvPr id="46" name="TextBox 45"/>
-          <p:cNvSpPr txBox="1"/>
-          <p:nvPr/>
-        </p:nvSpPr>
-        <p:spPr>
-          <a:xfrm>
-            <a:off x="4983480" y="3639312"/>
-            <a:ext cx="2194560" cy="822960"/>
-          </a:xfrm>
-          <a:prstGeom prst="rect">
-            <a:avLst/>
-          </a:prstGeom>
-          <a:noFill/>
-        </p:spPr>
-        <p:txBody>
-          <a:bodyPr wrap="square">
-            <a:spAutoFit/>
-          </a:bodyPr>
-          <a:lstStyle/>
-          <a:p>
-            <a:pPr algn="ctr"/>
-            <a:r>
-              <a:rPr sz="1400" b="0" spc="-14">
-                <a:solidFill>
-                  <a:srgbClr val="1F1F1F"/>
-                </a:solidFill>
-                <a:latin typeface="Pretendard"/>
-              </a:rPr>
-              <a:t>First RCT</a:t>
-            </a:r>
-          </a:p>
-          <a:p>
-            <a:pPr algn="ctr"/>
-            <a:r>
-              <a:rPr sz="1400" b="0" spc="-14">
-                <a:solidFill>
-                  <a:srgbClr val="1F1F1F"/>
-                </a:solidFill>
-                <a:latin typeface="Pretendard"/>
-              </a:rPr>
-              <a:t>enrolment</a:t>
-            </a:r>
-          </a:p>
-        </p:txBody>
-      </p:sp>
-      <p:sp>
-        <p:nvSpPr>
-          <p:cNvPr id="47" name="Oval 46"/>
+          <p:cNvPr id="53" name="Rounded Rectangle 52"/>
           <p:cNvSpPr/>
           <p:nvPr/>
         </p:nvSpPr>
         <p:spPr>
           <a:xfrm>
-            <a:off x="8243316" y="3259836"/>
-            <a:ext cx="201168" cy="201168"/>
-          </a:xfrm>
-          <a:prstGeom prst="ellipse">
-            <a:avLst/>
-          </a:prstGeom>
-          <a:solidFill>
-            <a:srgbClr val="00754A"/>
-          </a:solidFill>
-          <a:ln>
-            <a:noFill/>
+            <a:off x="3291840" y="4663440"/>
+            <a:ext cx="2468880" cy="868680"/>
+          </a:xfrm>
+          <a:prstGeom prst="roundRect">
+            <a:avLst/>
+          </a:prstGeom>
+          <a:noFill/>
+          <a:ln w="12700">
+            <a:solidFill>
+              <a:srgbClr val="6B6B6B"/>
+            </a:solidFill>
           </a:ln>
         </p:spPr>
         <p:style>
@@ -7992,14 +8747,14 @@
       </p:sp>
       <p:sp>
         <p:nvSpPr>
-          <p:cNvPr id="48" name="TextBox 47"/>
-          <p:cNvSpPr txBox="1"/>
-          <p:nvPr/>
-        </p:nvSpPr>
-        <p:spPr>
-          <a:xfrm>
-            <a:off x="7338060" y="2697480"/>
-            <a:ext cx="2011680" cy="365760"/>
+          <p:cNvPr id="54" name="TextBox 53"/>
+          <p:cNvSpPr txBox="1"/>
+          <p:nvPr/>
+        </p:nvSpPr>
+        <p:spPr>
+          <a:xfrm>
+            <a:off x="3291840" y="4800600"/>
+            <a:ext cx="2468880" cy="640080"/>
           </a:xfrm>
           <a:prstGeom prst="rect">
             <a:avLst/>
@@ -8014,186 +8769,25 @@
           <a:p>
             <a:pPr algn="ctr"/>
             <a:r>
-              <a:rPr sz="2200" b="1" spc="-22">
-                <a:solidFill>
-                  <a:srgbClr val="006241"/>
-                </a:solidFill>
-                <a:latin typeface="Pretendard"/>
-              </a:rPr>
-              <a:t>2023</a:t>
-            </a:r>
-          </a:p>
-        </p:txBody>
-      </p:sp>
-      <p:sp>
-        <p:nvSpPr>
-          <p:cNvPr id="49" name="TextBox 48"/>
-          <p:cNvSpPr txBox="1"/>
-          <p:nvPr/>
-        </p:nvSpPr>
-        <p:spPr>
-          <a:xfrm>
-            <a:off x="7246620" y="3639312"/>
-            <a:ext cx="2194560" cy="822960"/>
-          </a:xfrm>
-          <a:prstGeom prst="rect">
-            <a:avLst/>
-          </a:prstGeom>
-          <a:noFill/>
-        </p:spPr>
-        <p:txBody>
-          <a:bodyPr wrap="square">
-            <a:spAutoFit/>
-          </a:bodyPr>
-          <a:lstStyle/>
-          <a:p>
-            <a:pPr algn="ctr"/>
-            <a:r>
-              <a:rPr sz="1400" b="0" spc="-14">
-                <a:solidFill>
-                  <a:srgbClr val="1F1F1F"/>
-                </a:solidFill>
-                <a:latin typeface="Pretendard"/>
-              </a:rPr>
-              <a:t>Two RCTs</a:t>
-            </a:r>
-          </a:p>
-          <a:p>
-            <a:pPr algn="ctr"/>
-            <a:r>
-              <a:rPr sz="1400" b="0" spc="-14">
-                <a:solidFill>
-                  <a:srgbClr val="1F1F1F"/>
-                </a:solidFill>
-                <a:latin typeface="Pretendard"/>
-              </a:rPr>
-              <a:t>completed</a:t>
-            </a:r>
-          </a:p>
-        </p:txBody>
-      </p:sp>
-      <p:sp>
-        <p:nvSpPr>
-          <p:cNvPr id="50" name="Oval 49"/>
-          <p:cNvSpPr/>
-          <p:nvPr/>
-        </p:nvSpPr>
-        <p:spPr>
-          <a:xfrm>
-            <a:off x="10506456" y="3259836"/>
-            <a:ext cx="201168" cy="201168"/>
-          </a:xfrm>
-          <a:prstGeom prst="ellipse">
-            <a:avLst/>
-          </a:prstGeom>
-          <a:solidFill>
-            <a:srgbClr val="00754A"/>
-          </a:solidFill>
-          <a:ln>
-            <a:noFill/>
-          </a:ln>
-        </p:spPr>
-        <p:style>
-          <a:lnRef idx="1">
-            <a:schemeClr val="accent1"/>
-          </a:lnRef>
-          <a:fillRef idx="3">
-            <a:schemeClr val="accent1"/>
-          </a:fillRef>
-          <a:effectRef idx="0">
-            <a:schemeClr val="accent1"/>
-          </a:effectRef>
-          <a:fontRef idx="minor">
-            <a:schemeClr val="lt1"/>
-          </a:fontRef>
-        </p:style>
-        <p:txBody>
-          <a:bodyPr rtlCol="0" anchor="ctr"/>
-          <a:lstStyle/>
-          <a:p>
-            <a:pPr algn="ctr"/>
-            <a:endParaRPr/>
-          </a:p>
-        </p:txBody>
-      </p:sp>
-      <p:sp>
-        <p:nvSpPr>
-          <p:cNvPr id="51" name="TextBox 50"/>
-          <p:cNvSpPr txBox="1"/>
-          <p:nvPr/>
-        </p:nvSpPr>
-        <p:spPr>
-          <a:xfrm>
-            <a:off x="9601200" y="2697480"/>
-            <a:ext cx="2011680" cy="365760"/>
-          </a:xfrm>
-          <a:prstGeom prst="rect">
-            <a:avLst/>
-          </a:prstGeom>
-          <a:noFill/>
-        </p:spPr>
-        <p:txBody>
-          <a:bodyPr wrap="square">
-            <a:spAutoFit/>
-          </a:bodyPr>
-          <a:lstStyle/>
-          <a:p>
-            <a:pPr algn="ctr"/>
-            <a:r>
-              <a:rPr sz="2200" b="1" spc="-22">
-                <a:solidFill>
-                  <a:srgbClr val="006241"/>
-                </a:solidFill>
-                <a:latin typeface="Pretendard"/>
-              </a:rPr>
-              <a:t>2025</a:t>
-            </a:r>
-          </a:p>
-        </p:txBody>
-      </p:sp>
-      <p:sp>
-        <p:nvSpPr>
-          <p:cNvPr id="52" name="TextBox 51"/>
-          <p:cNvSpPr txBox="1"/>
-          <p:nvPr/>
-        </p:nvSpPr>
-        <p:spPr>
-          <a:xfrm>
-            <a:off x="9509760" y="3639312"/>
-            <a:ext cx="2194560" cy="822960"/>
-          </a:xfrm>
-          <a:prstGeom prst="rect">
-            <a:avLst/>
-          </a:prstGeom>
-          <a:noFill/>
-        </p:spPr>
-        <p:txBody>
-          <a:bodyPr wrap="square">
-            <a:spAutoFit/>
-          </a:bodyPr>
-          <a:lstStyle/>
-          <a:p>
-            <a:pPr algn="ctr"/>
-            <a:r>
-              <a:rPr sz="1400" b="0" spc="-14">
-                <a:solidFill>
-                  <a:srgbClr val="1F1F1F"/>
-                </a:solidFill>
-                <a:latin typeface="Pretendard"/>
-              </a:rPr>
-              <a:t>Pooled</a:t>
-            </a:r>
-          </a:p>
-          <a:p>
-            <a:pPr algn="ctr"/>
-            <a:r>
-              <a:rPr sz="1400" b="0" spc="-14">
-                <a:solidFill>
-                  <a:srgbClr val="1F1F1F"/>
-                </a:solidFill>
-                <a:latin typeface="Pretendard"/>
-              </a:rPr>
-              <a:t>analyses</a:t>
+              <a:rPr sz="1500" b="0" spc="-15">
+                <a:solidFill>
+                  <a:srgbClr val="6B6B6B"/>
+                </a:solidFill>
+                <a:latin typeface="Pretendard"/>
+              </a:rPr>
+              <a:t>Excluded (n = NN)</a:t>
+            </a:r>
+          </a:p>
+          <a:p>
+            <a:pPr algn="ctr"/>
+            <a:r>
+              <a:rPr sz="1500" b="0" spc="-15">
+                <a:solidFill>
+                  <a:srgbClr val="6B6B6B"/>
+                </a:solidFill>
+                <a:latin typeface="Pretendard"/>
+              </a:rPr>
+              <a:t>– reason / criterion</a:t>
             </a:r>
           </a:p>
         </p:txBody>
@@ -8253,7 +8847,7 @@
                 </a:solidFill>
                 <a:latin typeface="Pretendard"/>
               </a:rPr>
-              <a:t>PATTERN K</a:t>
+              <a:t>PATTERN L</a:t>
             </a:r>
           </a:p>
         </p:txBody>
@@ -8317,7 +8911,7 @@
                 </a:solidFill>
                 <a:latin typeface="Pretendard"/>
               </a:rPr>
-              <a:t>Process Flow — CONSORT</a:t>
+              <a:t>Text Block — one editable text frame</a:t>
             </a:r>
           </a:p>
         </p:txBody>
@@ -8440,58 +9034,14 @@
       </p:sp>
       <p:sp>
         <p:nvSpPr>
-          <p:cNvPr id="37" name="Rounded Rectangle 36"/>
-          <p:cNvSpPr/>
-          <p:nvPr/>
-        </p:nvSpPr>
-        <p:spPr>
-          <a:xfrm>
-            <a:off x="502920" y="2834640"/>
-            <a:ext cx="2468880" cy="1325880"/>
-          </a:xfrm>
-          <a:prstGeom prst="roundRect">
-            <a:avLst/>
-          </a:prstGeom>
-          <a:noFill/>
-          <a:ln w="15875">
-            <a:solidFill>
-              <a:srgbClr val="00754A"/>
-            </a:solidFill>
-          </a:ln>
-        </p:spPr>
-        <p:style>
-          <a:lnRef idx="1">
-            <a:schemeClr val="accent1"/>
-          </a:lnRef>
-          <a:fillRef idx="3">
-            <a:schemeClr val="accent1"/>
-          </a:fillRef>
-          <a:effectRef idx="0">
-            <a:schemeClr val="accent1"/>
-          </a:effectRef>
-          <a:fontRef idx="minor">
-            <a:schemeClr val="lt1"/>
-          </a:fontRef>
-        </p:style>
-        <p:txBody>
-          <a:bodyPr rtlCol="0" anchor="ctr"/>
-          <a:lstStyle/>
-          <a:p>
-            <a:pPr algn="ctr"/>
-            <a:endParaRPr/>
-          </a:p>
-        </p:txBody>
-      </p:sp>
-      <p:sp>
-        <p:nvSpPr>
-          <p:cNvPr id="38" name="TextBox 37"/>
-          <p:cNvSpPr txBox="1"/>
-          <p:nvPr/>
-        </p:nvSpPr>
-        <p:spPr>
-          <a:xfrm>
-            <a:off x="502920" y="3154680"/>
-            <a:ext cx="2468880" cy="411480"/>
+          <p:cNvPr id="37" name="TextBox 36"/>
+          <p:cNvSpPr txBox="1"/>
+          <p:nvPr/>
+        </p:nvSpPr>
+        <p:spPr>
+          <a:xfrm>
+            <a:off x="640080" y="1554480"/>
+            <a:ext cx="10881360" cy="4709160"/>
           </a:xfrm>
           <a:prstGeom prst="rect">
             <a:avLst/>
@@ -8500,663 +9050,196 @@
         </p:spPr>
         <p:txBody>
           <a:bodyPr wrap="square">
-            <a:spAutoFit/>
-          </a:bodyPr>
-          <a:lstStyle/>
-          <a:p>
-            <a:pPr algn="ctr"/>
-            <a:r>
-              <a:rPr sz="1800" b="1" spc="-18">
+            <a:noAutofit/>
+          </a:bodyPr>
+          <a:lstStyle/>
+          <a:p>
+            <a:pPr marL="342900" indent="-342900">
+              <a:lnSpc>
+                <a:spcPct val="118000"/>
+              </a:lnSpc>
+              <a:spcBef>
+                <a:spcPts val="1400"/>
+              </a:spcBef>
+              <a:buClr>
+                <a:srgbClr val="00754A"/>
+              </a:buClr>
+              <a:buSzPct val="68000"/>
+              <a:buFont typeface="Arial"/>
+              <a:buChar char="●"/>
+            </a:pPr>
+            <a:r>
+              <a:rPr sz="2800" b="0" spc="-28">
                 <a:solidFill>
                   <a:srgbClr val="1F1F1F"/>
                 </a:solidFill>
                 <a:latin typeface="Pretendard"/>
               </a:rPr>
-              <a:t>Assessed</a:t>
-            </a:r>
-          </a:p>
-        </p:txBody>
-      </p:sp>
-      <p:sp>
-        <p:nvSpPr>
-          <p:cNvPr id="39" name="TextBox 38"/>
-          <p:cNvSpPr txBox="1"/>
-          <p:nvPr/>
-        </p:nvSpPr>
-        <p:spPr>
-          <a:xfrm>
-            <a:off x="502920" y="3611880"/>
-            <a:ext cx="2468880" cy="411480"/>
-          </a:xfrm>
-          <a:prstGeom prst="rect">
-            <a:avLst/>
-          </a:prstGeom>
-          <a:noFill/>
-        </p:spPr>
-        <p:txBody>
-          <a:bodyPr wrap="square">
-            <a:spAutoFit/>
-          </a:bodyPr>
-          <a:lstStyle/>
-          <a:p>
-            <a:pPr algn="ctr"/>
-            <a:r>
-              <a:rPr sz="1600" b="0" spc="-16">
+              <a:t>Primary point — the single message of this slide</a:t>
+            </a:r>
+          </a:p>
+          <a:p>
+            <a:pPr marL="342900" indent="-342900">
+              <a:lnSpc>
+                <a:spcPct val="118000"/>
+              </a:lnSpc>
+              <a:spcBef>
+                <a:spcPts val="1400"/>
+              </a:spcBef>
+              <a:buClr>
+                <a:srgbClr val="00754A"/>
+              </a:buClr>
+              <a:buSzPct val="68000"/>
+              <a:buFont typeface="Arial"/>
+              <a:buChar char="●"/>
+            </a:pPr>
+            <a:r>
+              <a:rPr sz="2800" b="0" spc="-28">
+                <a:solidFill>
+                  <a:srgbClr val="1F1F1F"/>
+                </a:solidFill>
+                <a:latin typeface="Pretendard"/>
+              </a:rPr>
+              <a:t>Supporting line with a </a:t>
+            </a:r>
+            <a:r>
+              <a:rPr sz="2800" b="1" spc="-28">
+                <a:solidFill>
+                  <a:srgbClr val="00754A"/>
+                </a:solidFill>
+                <a:latin typeface="Pretendard"/>
+              </a:rPr>
+              <a:t>key phrase</a:t>
+            </a:r>
+            <a:r>
+              <a:rPr sz="2800" b="0" spc="-28">
+                <a:solidFill>
+                  <a:srgbClr val="1F1F1F"/>
+                </a:solidFill>
+                <a:latin typeface="Pretendard"/>
+              </a:rPr>
+              <a:t> emphasised</a:t>
+            </a:r>
+          </a:p>
+          <a:p>
+            <a:pPr>
+              <a:lnSpc>
+                <a:spcPct val="55000"/>
+              </a:lnSpc>
+              <a:buNone/>
+            </a:pPr>
+            <a:endParaRPr sz="2800" b="0" spc="-28">
+              <a:solidFill>
+                <a:srgbClr val="1F1F1F"/>
+              </a:solidFill>
+              <a:latin typeface="Pretendard"/>
+            </a:endParaRPr>
+          </a:p>
+          <a:p>
+            <a:pPr marL="342900" indent="-342900">
+              <a:lnSpc>
+                <a:spcPct val="118000"/>
+              </a:lnSpc>
+              <a:spcBef>
+                <a:spcPts val="1400"/>
+              </a:spcBef>
+              <a:buClr>
+                <a:srgbClr val="00754A"/>
+              </a:buClr>
+              <a:buSzPct val="68000"/>
+              <a:buFont typeface="Arial"/>
+              <a:buChar char="●"/>
+            </a:pPr>
+            <a:r>
+              <a:rPr sz="3200" b="0" spc="-32">
+                <a:solidFill>
+                  <a:srgbClr val="1F1F1F"/>
+                </a:solidFill>
+                <a:latin typeface="Pretendard"/>
+              </a:rPr>
+              <a:t>A larger line when one statement needs weight</a:t>
+            </a:r>
+          </a:p>
+          <a:p>
+            <a:pPr marL="342900" indent="-342900">
+              <a:lnSpc>
+                <a:spcPct val="118000"/>
+              </a:lnSpc>
+              <a:spcBef>
+                <a:spcPts val="1400"/>
+              </a:spcBef>
+              <a:buClr>
+                <a:srgbClr val="00754A"/>
+              </a:buClr>
+              <a:buSzPct val="68000"/>
+              <a:buFont typeface="Arial"/>
+              <a:buChar char="●"/>
+            </a:pPr>
+            <a:r>
+              <a:rPr sz="2400" b="0" spc="-24">
                 <a:solidFill>
                   <a:srgbClr val="6B6B6B"/>
                 </a:solidFill>
                 <a:latin typeface="Pretendard"/>
               </a:rPr>
-              <a:t>n = NNN</a:t>
-            </a:r>
-          </a:p>
-        </p:txBody>
-      </p:sp>
-      <p:sp>
-        <p:nvSpPr>
-          <p:cNvPr id="40" name="Rounded Rectangle 39"/>
-          <p:cNvSpPr/>
-          <p:nvPr/>
-        </p:nvSpPr>
-        <p:spPr>
-          <a:xfrm>
-            <a:off x="3291840" y="2834640"/>
-            <a:ext cx="2468880" cy="1325880"/>
-          </a:xfrm>
-          <a:prstGeom prst="roundRect">
-            <a:avLst/>
-          </a:prstGeom>
-          <a:noFill/>
-          <a:ln w="15875">
-            <a:solidFill>
-              <a:srgbClr val="00754A"/>
-            </a:solidFill>
-          </a:ln>
-        </p:spPr>
-        <p:style>
-          <a:lnRef idx="1">
-            <a:schemeClr val="accent1"/>
-          </a:lnRef>
-          <a:fillRef idx="3">
-            <a:schemeClr val="accent1"/>
-          </a:fillRef>
-          <a:effectRef idx="0">
-            <a:schemeClr val="accent1"/>
-          </a:effectRef>
-          <a:fontRef idx="minor">
-            <a:schemeClr val="lt1"/>
-          </a:fontRef>
-        </p:style>
-        <p:txBody>
-          <a:bodyPr rtlCol="0" anchor="ctr"/>
-          <a:lstStyle/>
-          <a:p>
-            <a:pPr algn="ctr"/>
-            <a:endParaRPr/>
-          </a:p>
-        </p:txBody>
-      </p:sp>
-      <p:sp>
-        <p:nvSpPr>
-          <p:cNvPr id="41" name="TextBox 40"/>
-          <p:cNvSpPr txBox="1"/>
-          <p:nvPr/>
-        </p:nvSpPr>
-        <p:spPr>
-          <a:xfrm>
-            <a:off x="3291840" y="3154680"/>
-            <a:ext cx="2468880" cy="411480"/>
-          </a:xfrm>
-          <a:prstGeom prst="rect">
-            <a:avLst/>
-          </a:prstGeom>
-          <a:noFill/>
-        </p:spPr>
-        <p:txBody>
-          <a:bodyPr wrap="square">
-            <a:spAutoFit/>
-          </a:bodyPr>
-          <a:lstStyle/>
-          <a:p>
-            <a:pPr algn="ctr"/>
-            <a:r>
-              <a:rPr sz="1800" b="1" spc="-18">
+              <a:t>secondary detail, one step down</a:t>
+            </a:r>
+          </a:p>
+          <a:p>
+            <a:pPr>
+              <a:lnSpc>
+                <a:spcPct val="55000"/>
+              </a:lnSpc>
+              <a:buNone/>
+            </a:pPr>
+            <a:endParaRPr sz="2400" b="0" spc="-24">
+              <a:solidFill>
+                <a:srgbClr val="6B6B6B"/>
+              </a:solidFill>
+              <a:latin typeface="Pretendard"/>
+            </a:endParaRPr>
+          </a:p>
+          <a:p>
+            <a:pPr marL="342900" indent="-342900">
+              <a:lnSpc>
+                <a:spcPct val="118000"/>
+              </a:lnSpc>
+              <a:spcBef>
+                <a:spcPts val="1400"/>
+              </a:spcBef>
+              <a:buClr>
+                <a:srgbClr val="00754A"/>
+              </a:buClr>
+              <a:buSzPct val="68000"/>
+              <a:buFont typeface="Arial"/>
+              <a:buChar char="●"/>
+            </a:pPr>
+            <a:r>
+              <a:rPr sz="2800" b="0" spc="-28">
                 <a:solidFill>
                   <a:srgbClr val="1F1F1F"/>
                 </a:solidFill>
                 <a:latin typeface="Pretendard"/>
               </a:rPr>
-              <a:t>Randomized</a:t>
-            </a:r>
-          </a:p>
-        </p:txBody>
-      </p:sp>
-      <p:sp>
-        <p:nvSpPr>
-          <p:cNvPr id="42" name="TextBox 41"/>
-          <p:cNvSpPr txBox="1"/>
-          <p:nvPr/>
-        </p:nvSpPr>
-        <p:spPr>
-          <a:xfrm>
-            <a:off x="3291840" y="3611880"/>
-            <a:ext cx="2468880" cy="411480"/>
-          </a:xfrm>
-          <a:prstGeom prst="rect">
-            <a:avLst/>
-          </a:prstGeom>
-          <a:noFill/>
-        </p:spPr>
-        <p:txBody>
-          <a:bodyPr wrap="square">
-            <a:spAutoFit/>
-          </a:bodyPr>
-          <a:lstStyle/>
-          <a:p>
-            <a:pPr algn="ctr"/>
-            <a:r>
-              <a:rPr sz="1600" b="0" spc="-16">
-                <a:solidFill>
-                  <a:srgbClr val="6B6B6B"/>
-                </a:solidFill>
-                <a:latin typeface="Pretendard"/>
-              </a:rPr>
-              <a:t>n = NNN</a:t>
-            </a:r>
-          </a:p>
-        </p:txBody>
-      </p:sp>
-      <p:sp>
-        <p:nvSpPr>
-          <p:cNvPr id="43" name="Rounded Rectangle 42"/>
-          <p:cNvSpPr/>
-          <p:nvPr/>
-        </p:nvSpPr>
-        <p:spPr>
-          <a:xfrm>
-            <a:off x="6080760" y="2834640"/>
-            <a:ext cx="2468880" cy="1325880"/>
-          </a:xfrm>
-          <a:prstGeom prst="roundRect">
-            <a:avLst/>
-          </a:prstGeom>
-          <a:noFill/>
-          <a:ln w="15875">
-            <a:solidFill>
-              <a:srgbClr val="00754A"/>
-            </a:solidFill>
-          </a:ln>
-        </p:spPr>
-        <p:style>
-          <a:lnRef idx="1">
-            <a:schemeClr val="accent1"/>
-          </a:lnRef>
-          <a:fillRef idx="3">
-            <a:schemeClr val="accent1"/>
-          </a:fillRef>
-          <a:effectRef idx="0">
-            <a:schemeClr val="accent1"/>
-          </a:effectRef>
-          <a:fontRef idx="minor">
-            <a:schemeClr val="lt1"/>
-          </a:fontRef>
-        </p:style>
-        <p:txBody>
-          <a:bodyPr rtlCol="0" anchor="ctr"/>
-          <a:lstStyle/>
-          <a:p>
-            <a:pPr algn="ctr"/>
-            <a:endParaRPr/>
-          </a:p>
-        </p:txBody>
-      </p:sp>
-      <p:sp>
-        <p:nvSpPr>
-          <p:cNvPr id="44" name="TextBox 43"/>
-          <p:cNvSpPr txBox="1"/>
-          <p:nvPr/>
-        </p:nvSpPr>
-        <p:spPr>
-          <a:xfrm>
-            <a:off x="6080760" y="3154680"/>
-            <a:ext cx="2468880" cy="411480"/>
-          </a:xfrm>
-          <a:prstGeom prst="rect">
-            <a:avLst/>
-          </a:prstGeom>
-          <a:noFill/>
-        </p:spPr>
-        <p:txBody>
-          <a:bodyPr wrap="square">
-            <a:spAutoFit/>
-          </a:bodyPr>
-          <a:lstStyle/>
-          <a:p>
-            <a:pPr algn="ctr"/>
-            <a:r>
-              <a:rPr sz="1800" b="1" spc="-18">
+              <a:t>Closing point — </a:t>
+            </a:r>
+            <a:r>
+              <a:rPr sz="2800" b="1" spc="-28">
+                <a:solidFill>
+                  <a:srgbClr val="00754A"/>
+                </a:solidFill>
+                <a:latin typeface="Pretendard"/>
+              </a:rPr>
+              <a:t>the conclusion</a:t>
+            </a:r>
+            <a:r>
+              <a:rPr sz="2800" b="0" spc="-28">
                 <a:solidFill>
                   <a:srgbClr val="1F1F1F"/>
                 </a:solidFill>
                 <a:latin typeface="Pretendard"/>
               </a:rPr>
-              <a:t>Allocated</a:t>
-            </a:r>
-          </a:p>
-        </p:txBody>
-      </p:sp>
-      <p:sp>
-        <p:nvSpPr>
-          <p:cNvPr id="45" name="TextBox 44"/>
-          <p:cNvSpPr txBox="1"/>
-          <p:nvPr/>
-        </p:nvSpPr>
-        <p:spPr>
-          <a:xfrm>
-            <a:off x="6080760" y="3611880"/>
-            <a:ext cx="2468880" cy="411480"/>
-          </a:xfrm>
-          <a:prstGeom prst="rect">
-            <a:avLst/>
-          </a:prstGeom>
-          <a:noFill/>
-        </p:spPr>
-        <p:txBody>
-          <a:bodyPr wrap="square">
-            <a:spAutoFit/>
-          </a:bodyPr>
-          <a:lstStyle/>
-          <a:p>
-            <a:pPr algn="ctr"/>
-            <a:r>
-              <a:rPr sz="1600" b="0" spc="-16">
-                <a:solidFill>
-                  <a:srgbClr val="6B6B6B"/>
-                </a:solidFill>
-                <a:latin typeface="Pretendard"/>
-              </a:rPr>
-              <a:t>n = NN / NN</a:t>
-            </a:r>
-          </a:p>
-        </p:txBody>
-      </p:sp>
-      <p:sp>
-        <p:nvSpPr>
-          <p:cNvPr id="46" name="Rounded Rectangle 45"/>
-          <p:cNvSpPr/>
-          <p:nvPr/>
-        </p:nvSpPr>
-        <p:spPr>
-          <a:xfrm>
-            <a:off x="8869680" y="2834640"/>
-            <a:ext cx="2468880" cy="1325880"/>
-          </a:xfrm>
-          <a:prstGeom prst="roundRect">
-            <a:avLst/>
-          </a:prstGeom>
-          <a:noFill/>
-          <a:ln w="15875">
-            <a:solidFill>
-              <a:srgbClr val="00754A"/>
-            </a:solidFill>
-          </a:ln>
-        </p:spPr>
-        <p:style>
-          <a:lnRef idx="1">
-            <a:schemeClr val="accent1"/>
-          </a:lnRef>
-          <a:fillRef idx="3">
-            <a:schemeClr val="accent1"/>
-          </a:fillRef>
-          <a:effectRef idx="0">
-            <a:schemeClr val="accent1"/>
-          </a:effectRef>
-          <a:fontRef idx="minor">
-            <a:schemeClr val="lt1"/>
-          </a:fontRef>
-        </p:style>
-        <p:txBody>
-          <a:bodyPr rtlCol="0" anchor="ctr"/>
-          <a:lstStyle/>
-          <a:p>
-            <a:pPr algn="ctr"/>
-            <a:endParaRPr/>
-          </a:p>
-        </p:txBody>
-      </p:sp>
-      <p:sp>
-        <p:nvSpPr>
-          <p:cNvPr id="47" name="TextBox 46"/>
-          <p:cNvSpPr txBox="1"/>
-          <p:nvPr/>
-        </p:nvSpPr>
-        <p:spPr>
-          <a:xfrm>
-            <a:off x="8869680" y="3154680"/>
-            <a:ext cx="2468880" cy="411480"/>
-          </a:xfrm>
-          <a:prstGeom prst="rect">
-            <a:avLst/>
-          </a:prstGeom>
-          <a:noFill/>
-        </p:spPr>
-        <p:txBody>
-          <a:bodyPr wrap="square">
-            <a:spAutoFit/>
-          </a:bodyPr>
-          <a:lstStyle/>
-          <a:p>
-            <a:pPr algn="ctr"/>
-            <a:r>
-              <a:rPr sz="1800" b="1" spc="-18">
-                <a:solidFill>
-                  <a:srgbClr val="1F1F1F"/>
-                </a:solidFill>
-                <a:latin typeface="Pretendard"/>
-              </a:rPr>
-              <a:t>Analyzed</a:t>
-            </a:r>
-          </a:p>
-        </p:txBody>
-      </p:sp>
-      <p:sp>
-        <p:nvSpPr>
-          <p:cNvPr id="48" name="TextBox 47"/>
-          <p:cNvSpPr txBox="1"/>
-          <p:nvPr/>
-        </p:nvSpPr>
-        <p:spPr>
-          <a:xfrm>
-            <a:off x="8869680" y="3611880"/>
-            <a:ext cx="2468880" cy="411480"/>
-          </a:xfrm>
-          <a:prstGeom prst="rect">
-            <a:avLst/>
-          </a:prstGeom>
-          <a:noFill/>
-        </p:spPr>
-        <p:txBody>
-          <a:bodyPr wrap="square">
-            <a:spAutoFit/>
-          </a:bodyPr>
-          <a:lstStyle/>
-          <a:p>
-            <a:pPr algn="ctr"/>
-            <a:r>
-              <a:rPr sz="1600" b="0" spc="-16">
-                <a:solidFill>
-                  <a:srgbClr val="6B6B6B"/>
-                </a:solidFill>
-                <a:latin typeface="Pretendard"/>
-              </a:rPr>
-              <a:t>n = NN / NN</a:t>
-            </a:r>
-          </a:p>
-        </p:txBody>
-      </p:sp>
-      <p:sp>
-        <p:nvSpPr>
-          <p:cNvPr id="49" name="Right Arrow 48"/>
-          <p:cNvSpPr/>
-          <p:nvPr/>
-        </p:nvSpPr>
-        <p:spPr>
-          <a:xfrm>
-            <a:off x="2990088" y="3364992"/>
-            <a:ext cx="256032" cy="274320"/>
-          </a:xfrm>
-          <a:prstGeom prst="rightArrow">
-            <a:avLst/>
-          </a:prstGeom>
-          <a:solidFill>
-            <a:srgbClr val="00754A"/>
-          </a:solidFill>
-          <a:ln>
-            <a:noFill/>
-          </a:ln>
-        </p:spPr>
-        <p:style>
-          <a:lnRef idx="1">
-            <a:schemeClr val="accent1"/>
-          </a:lnRef>
-          <a:fillRef idx="3">
-            <a:schemeClr val="accent1"/>
-          </a:fillRef>
-          <a:effectRef idx="0">
-            <a:schemeClr val="accent1"/>
-          </a:effectRef>
-          <a:fontRef idx="minor">
-            <a:schemeClr val="lt1"/>
-          </a:fontRef>
-        </p:style>
-        <p:txBody>
-          <a:bodyPr rtlCol="0" anchor="ctr"/>
-          <a:lstStyle/>
-          <a:p>
-            <a:pPr algn="ctr"/>
-            <a:endParaRPr/>
-          </a:p>
-        </p:txBody>
-      </p:sp>
-      <p:sp>
-        <p:nvSpPr>
-          <p:cNvPr id="50" name="Right Arrow 49"/>
-          <p:cNvSpPr/>
-          <p:nvPr/>
-        </p:nvSpPr>
-        <p:spPr>
-          <a:xfrm>
-            <a:off x="5779008" y="3364992"/>
-            <a:ext cx="256032" cy="274320"/>
-          </a:xfrm>
-          <a:prstGeom prst="rightArrow">
-            <a:avLst/>
-          </a:prstGeom>
-          <a:solidFill>
-            <a:srgbClr val="00754A"/>
-          </a:solidFill>
-          <a:ln>
-            <a:noFill/>
-          </a:ln>
-        </p:spPr>
-        <p:style>
-          <a:lnRef idx="1">
-            <a:schemeClr val="accent1"/>
-          </a:lnRef>
-          <a:fillRef idx="3">
-            <a:schemeClr val="accent1"/>
-          </a:fillRef>
-          <a:effectRef idx="0">
-            <a:schemeClr val="accent1"/>
-          </a:effectRef>
-          <a:fontRef idx="minor">
-            <a:schemeClr val="lt1"/>
-          </a:fontRef>
-        </p:style>
-        <p:txBody>
-          <a:bodyPr rtlCol="0" anchor="ctr"/>
-          <a:lstStyle/>
-          <a:p>
-            <a:pPr algn="ctr"/>
-            <a:endParaRPr/>
-          </a:p>
-        </p:txBody>
-      </p:sp>
-      <p:sp>
-        <p:nvSpPr>
-          <p:cNvPr id="51" name="Right Arrow 50"/>
-          <p:cNvSpPr/>
-          <p:nvPr/>
-        </p:nvSpPr>
-        <p:spPr>
-          <a:xfrm>
-            <a:off x="8567928" y="3364992"/>
-            <a:ext cx="256032" cy="274320"/>
-          </a:xfrm>
-          <a:prstGeom prst="rightArrow">
-            <a:avLst/>
-          </a:prstGeom>
-          <a:solidFill>
-            <a:srgbClr val="00754A"/>
-          </a:solidFill>
-          <a:ln>
-            <a:noFill/>
-          </a:ln>
-        </p:spPr>
-        <p:style>
-          <a:lnRef idx="1">
-            <a:schemeClr val="accent1"/>
-          </a:lnRef>
-          <a:fillRef idx="3">
-            <a:schemeClr val="accent1"/>
-          </a:fillRef>
-          <a:effectRef idx="0">
-            <a:schemeClr val="accent1"/>
-          </a:effectRef>
-          <a:fontRef idx="minor">
-            <a:schemeClr val="lt1"/>
-          </a:fontRef>
-        </p:style>
-        <p:txBody>
-          <a:bodyPr rtlCol="0" anchor="ctr"/>
-          <a:lstStyle/>
-          <a:p>
-            <a:pPr algn="ctr"/>
-            <a:endParaRPr/>
-          </a:p>
-        </p:txBody>
-      </p:sp>
-      <p:sp>
-        <p:nvSpPr>
-          <p:cNvPr id="52" name="Down Arrow 51"/>
-          <p:cNvSpPr/>
-          <p:nvPr/>
-        </p:nvSpPr>
-        <p:spPr>
-          <a:xfrm>
-            <a:off x="4434840" y="4297680"/>
-            <a:ext cx="201168" cy="320040"/>
-          </a:xfrm>
-          <a:prstGeom prst="downArrow">
-            <a:avLst/>
-          </a:prstGeom>
-          <a:solidFill>
-            <a:srgbClr val="6B6B6B"/>
-          </a:solidFill>
-          <a:ln>
-            <a:noFill/>
-          </a:ln>
-        </p:spPr>
-        <p:style>
-          <a:lnRef idx="1">
-            <a:schemeClr val="accent1"/>
-          </a:lnRef>
-          <a:fillRef idx="3">
-            <a:schemeClr val="accent1"/>
-          </a:fillRef>
-          <a:effectRef idx="0">
-            <a:schemeClr val="accent1"/>
-          </a:effectRef>
-          <a:fontRef idx="minor">
-            <a:schemeClr val="lt1"/>
-          </a:fontRef>
-        </p:style>
-        <p:txBody>
-          <a:bodyPr rtlCol="0" anchor="ctr"/>
-          <a:lstStyle/>
-          <a:p>
-            <a:pPr algn="ctr"/>
-            <a:endParaRPr/>
-          </a:p>
-        </p:txBody>
-      </p:sp>
-      <p:sp>
-        <p:nvSpPr>
-          <p:cNvPr id="53" name="Rounded Rectangle 52"/>
-          <p:cNvSpPr/>
-          <p:nvPr/>
-        </p:nvSpPr>
-        <p:spPr>
-          <a:xfrm>
-            <a:off x="3291840" y="4663440"/>
-            <a:ext cx="2468880" cy="868680"/>
-          </a:xfrm>
-          <a:prstGeom prst="roundRect">
-            <a:avLst/>
-          </a:prstGeom>
-          <a:noFill/>
-          <a:ln w="12700">
-            <a:solidFill>
-              <a:srgbClr val="6B6B6B"/>
-            </a:solidFill>
-          </a:ln>
-        </p:spPr>
-        <p:style>
-          <a:lnRef idx="1">
-            <a:schemeClr val="accent1"/>
-          </a:lnRef>
-          <a:fillRef idx="3">
-            <a:schemeClr val="accent1"/>
-          </a:fillRef>
-          <a:effectRef idx="0">
-            <a:schemeClr val="accent1"/>
-          </a:effectRef>
-          <a:fontRef idx="minor">
-            <a:schemeClr val="lt1"/>
-          </a:fontRef>
-        </p:style>
-        <p:txBody>
-          <a:bodyPr rtlCol="0" anchor="ctr"/>
-          <a:lstStyle/>
-          <a:p>
-            <a:pPr algn="ctr"/>
-            <a:endParaRPr/>
-          </a:p>
-        </p:txBody>
-      </p:sp>
-      <p:sp>
-        <p:nvSpPr>
-          <p:cNvPr id="54" name="TextBox 53"/>
-          <p:cNvSpPr txBox="1"/>
-          <p:nvPr/>
-        </p:nvSpPr>
-        <p:spPr>
-          <a:xfrm>
-            <a:off x="3291840" y="4800600"/>
-            <a:ext cx="2468880" cy="640080"/>
-          </a:xfrm>
-          <a:prstGeom prst="rect">
-            <a:avLst/>
-          </a:prstGeom>
-          <a:noFill/>
-        </p:spPr>
-        <p:txBody>
-          <a:bodyPr wrap="square">
-            <a:spAutoFit/>
-          </a:bodyPr>
-          <a:lstStyle/>
-          <a:p>
-            <a:pPr algn="ctr"/>
-            <a:r>
-              <a:rPr sz="1500" b="0" spc="-15">
-                <a:solidFill>
-                  <a:srgbClr val="6B6B6B"/>
-                </a:solidFill>
-                <a:latin typeface="Pretendard"/>
-              </a:rPr>
-              <a:t>Excluded (n = NN)</a:t>
-            </a:r>
-          </a:p>
-          <a:p>
-            <a:pPr algn="ctr"/>
-            <a:r>
-              <a:rPr sz="1500" b="0" spc="-15">
-                <a:solidFill>
-                  <a:srgbClr val="6B6B6B"/>
-                </a:solidFill>
-                <a:latin typeface="Pretendard"/>
-              </a:rPr>
-              <a:t>– reason / criterion</a:t>
+              <a:t> in bold</a:t>
             </a:r>
           </a:p>
         </p:txBody>
@@ -9172,6 +9255,14 @@
 <file path=ppt/slides/slide15.xml><?xml version="1.0" encoding="utf-8"?>
 <p:sld xmlns:a="http://schemas.openxmlformats.org/drawingml/2006/main" xmlns:r="http://schemas.openxmlformats.org/officeDocument/2006/relationships" xmlns:p="http://schemas.openxmlformats.org/presentationml/2006/main">
   <p:cSld>
+    <p:bg>
+      <p:bgPr>
+        <a:solidFill>
+          <a:srgbClr val="F2F0EB"/>
+        </a:solidFill>
+        <a:effectLst/>
+      </p:bgPr>
+    </p:bg>
     <p:spTree>
       <p:nvGrpSpPr>
         <p:cNvPr id="1" name=""/>
@@ -9188,42 +9279,95 @@
       </p:grpSpPr>
       <p:sp>
         <p:nvSpPr>
-          <p:cNvPr id="2" name="TextBox 1"/>
-          <p:cNvSpPr txBox="1"/>
-          <p:nvPr/>
-        </p:nvSpPr>
-        <p:spPr>
-          <a:xfrm>
-            <a:off x="138257" y="123444"/>
-            <a:ext cx="5486400" cy="256032"/>
-          </a:xfrm>
-          <a:prstGeom prst="rect">
-            <a:avLst/>
-          </a:prstGeom>
-          <a:noFill/>
-        </p:spPr>
-        <p:txBody>
-          <a:bodyPr wrap="square" lIns="0" tIns="0" rIns="0" bIns="0" anchor="t">
-            <a:spAutoFit/>
-          </a:bodyPr>
-          <a:lstStyle/>
-          <a:p>
-            <a:pPr algn="l"/>
-            <a:r>
-              <a:rPr sz="1300" b="1" i="0" spc="-13">
-                <a:solidFill>
-                  <a:srgbClr val="8E8E93"/>
-                </a:solidFill>
-                <a:latin typeface="Pretendard"/>
-              </a:rPr>
-              <a:t>PATTERN L</a:t>
-            </a:r>
+          <p:cNvPr id="2" name="Rectangle 1"/>
+          <p:cNvSpPr/>
+          <p:nvPr/>
+        </p:nvSpPr>
+        <p:spPr>
+          <a:xfrm>
+            <a:off x="0" y="0"/>
+            <a:ext cx="64008" cy="6858000"/>
+          </a:xfrm>
+          <a:prstGeom prst="rect">
+            <a:avLst/>
+          </a:prstGeom>
+          <a:solidFill>
+            <a:srgbClr val="00754A"/>
+          </a:solidFill>
+          <a:ln>
+            <a:noFill/>
+          </a:ln>
+        </p:spPr>
+        <p:style>
+          <a:lnRef idx="1">
+            <a:schemeClr val="accent1"/>
+          </a:lnRef>
+          <a:fillRef idx="3">
+            <a:schemeClr val="accent1"/>
+          </a:fillRef>
+          <a:effectRef idx="0">
+            <a:schemeClr val="accent1"/>
+          </a:effectRef>
+          <a:fontRef idx="minor">
+            <a:schemeClr val="lt1"/>
+          </a:fontRef>
+        </p:style>
+        <p:txBody>
+          <a:bodyPr rtlCol="0" anchor="ctr"/>
+          <a:lstStyle/>
+          <a:p>
+            <a:pPr algn="ctr"/>
+            <a:endParaRPr/>
+          </a:p>
+        </p:txBody>
+      </p:sp>
+      <p:sp>
+        <p:nvSpPr>
+          <p:cNvPr id="3" name="Rectangle 2"/>
+          <p:cNvSpPr/>
+          <p:nvPr/>
+        </p:nvSpPr>
+        <p:spPr>
+          <a:xfrm>
+            <a:off x="6688836" y="0"/>
+            <a:ext cx="5472684" cy="6858000"/>
+          </a:xfrm>
+          <a:prstGeom prst="rect">
+            <a:avLst/>
+          </a:prstGeom>
+          <a:solidFill>
+            <a:srgbClr val="F2F0EB"/>
+          </a:solidFill>
+          <a:ln>
+            <a:noFill/>
+          </a:ln>
+        </p:spPr>
+        <p:style>
+          <a:lnRef idx="1">
+            <a:schemeClr val="accent1"/>
+          </a:lnRef>
+          <a:fillRef idx="3">
+            <a:schemeClr val="accent1"/>
+          </a:fillRef>
+          <a:effectRef idx="0">
+            <a:schemeClr val="accent1"/>
+          </a:effectRef>
+          <a:fontRef idx="minor">
+            <a:schemeClr val="lt1"/>
+          </a:fontRef>
+        </p:style>
+        <p:txBody>
+          <a:bodyPr rtlCol="0" anchor="ctr"/>
+          <a:lstStyle/>
+          <a:p>
+            <a:pPr algn="ctr"/>
+            <a:endParaRPr/>
           </a:p>
         </p:txBody>
       </p:sp>
       <p:pic>
         <p:nvPicPr>
-          <p:cNvPr id="3" name="Picture 2" descr="logo.png"/>
+          <p:cNvPr id="4" name="Picture 3" descr="logo.png"/>
           <p:cNvPicPr>
             <a:picLocks noChangeAspect="1"/>
           </p:cNvPicPr>
@@ -9248,14 +9392,14 @@
       </p:pic>
       <p:sp>
         <p:nvSpPr>
-          <p:cNvPr id="4" name="TextBox 3"/>
-          <p:cNvSpPr txBox="1"/>
-          <p:nvPr/>
-        </p:nvSpPr>
-        <p:spPr>
-          <a:xfrm>
-            <a:off x="251460" y="436260"/>
-            <a:ext cx="10972800" cy="457200"/>
+          <p:cNvPr id="5" name="TextBox 4"/>
+          <p:cNvSpPr txBox="1"/>
+          <p:nvPr/>
+        </p:nvSpPr>
+        <p:spPr>
+          <a:xfrm>
+            <a:off x="548640" y="2286000"/>
+            <a:ext cx="8229600" cy="1463040"/>
           </a:xfrm>
           <a:prstGeom prst="rect">
             <a:avLst/>
@@ -9270,39 +9414,72 @@
           <a:p>
             <a:pPr algn="l">
               <a:lnSpc>
-                <a:spcPct val="120000"/>
+                <a:spcPct val="110000"/>
               </a:lnSpc>
             </a:pPr>
             <a:r>
-              <a:rPr sz="3200" b="1" i="0" spc="-32">
+              <a:rPr sz="7200" b="1" i="0" spc="-72">
                 <a:solidFill>
                   <a:srgbClr val="006241"/>
                 </a:solidFill>
                 <a:latin typeface="Pretendard"/>
               </a:rPr>
-              <a:t>Text Block — one editable text frame</a:t>
-            </a:r>
-          </a:p>
-        </p:txBody>
-      </p:sp>
-      <p:sp>
-        <p:nvSpPr>
-          <p:cNvPr id="6" name="Rounded Rectangle 5"/>
+              <a:t>Thank you</a:t>
+            </a:r>
+          </a:p>
+        </p:txBody>
+      </p:sp>
+      <p:sp>
+        <p:nvSpPr>
+          <p:cNvPr id="6" name="TextBox 5"/>
+          <p:cNvSpPr txBox="1"/>
+          <p:nvPr/>
+        </p:nvSpPr>
+        <p:spPr>
+          <a:xfrm>
+            <a:off x="548640" y="3931920"/>
+            <a:ext cx="8229600" cy="365760"/>
+          </a:xfrm>
+          <a:prstGeom prst="rect">
+            <a:avLst/>
+          </a:prstGeom>
+          <a:noFill/>
+        </p:spPr>
+        <p:txBody>
+          <a:bodyPr wrap="square" lIns="0" tIns="0" rIns="0" bIns="0" anchor="t">
+            <a:spAutoFit/>
+          </a:bodyPr>
+          <a:lstStyle/>
+          <a:p>
+            <a:pPr algn="l"/>
+            <a:r>
+              <a:rPr sz="2000" b="0" i="1" spc="-20">
+                <a:solidFill>
+                  <a:srgbClr val="6B6B6B"/>
+                </a:solidFill>
+                <a:latin typeface="Pretendard"/>
+              </a:rPr>
+              <a:t>Questions and discussion</a:t>
+            </a:r>
+          </a:p>
+        </p:txBody>
+      </p:sp>
+      <p:sp>
+        <p:nvSpPr>
+          <p:cNvPr id="7" name="Rectangle 6"/>
           <p:cNvSpPr/>
           <p:nvPr/>
         </p:nvSpPr>
         <p:spPr>
           <a:xfrm>
-            <a:off x="251642" y="1290309"/>
-            <a:ext cx="11699382" cy="5227350"/>
-          </a:xfrm>
-          <a:prstGeom prst="roundRect">
-            <a:avLst>
-              <a:gd name="adj" fmla="val 2099"/>
-            </a:avLst>
+            <a:off x="548640" y="4572000"/>
+            <a:ext cx="1645920" cy="36576"/>
+          </a:xfrm>
+          <a:prstGeom prst="rect">
+            <a:avLst/>
           </a:prstGeom>
           <a:solidFill>
-            <a:srgbClr val="FFFFFF"/>
+            <a:srgbClr val="00754A"/>
           </a:solidFill>
           <a:ln>
             <a:noFill/>
@@ -9333,14 +9510,14 @@
       </p:sp>
       <p:sp>
         <p:nvSpPr>
-          <p:cNvPr id="35" name="TextBox 34"/>
-          <p:cNvSpPr txBox="1"/>
-          <p:nvPr/>
-        </p:nvSpPr>
-        <p:spPr>
-          <a:xfrm>
-            <a:off x="138257" y="6620256"/>
-            <a:ext cx="548640" cy="228600"/>
+          <p:cNvPr id="8" name="TextBox 7"/>
+          <p:cNvSpPr txBox="1"/>
+          <p:nvPr/>
+        </p:nvSpPr>
+        <p:spPr>
+          <a:xfrm>
+            <a:off x="6866503" y="5102352"/>
+            <a:ext cx="4572000" cy="310896"/>
           </a:xfrm>
           <a:prstGeom prst="rect">
             <a:avLst/>
@@ -9353,262 +9530,85 @@
           </a:bodyPr>
           <a:lstStyle/>
           <a:p>
+            <a:pPr algn="r"/>
+            <a:r>
+              <a:rPr sz="1500" b="0" i="0" spc="-15">
+                <a:solidFill>
+                  <a:srgbClr val="6B6B6B"/>
+                </a:solidFill>
+                <a:latin typeface="Pretendard"/>
+              </a:rPr>
+              <a:t>Seoul National Univ. Bundang Hospital</a:t>
+            </a:r>
+          </a:p>
+        </p:txBody>
+      </p:sp>
+      <p:sp>
+        <p:nvSpPr>
+          <p:cNvPr id="9" name="TextBox 8"/>
+          <p:cNvSpPr txBox="1"/>
+          <p:nvPr/>
+        </p:nvSpPr>
+        <p:spPr>
+          <a:xfrm>
+            <a:off x="6866503" y="5477621"/>
+            <a:ext cx="4572000" cy="411480"/>
+          </a:xfrm>
+          <a:prstGeom prst="rect">
+            <a:avLst/>
+          </a:prstGeom>
+          <a:noFill/>
+        </p:spPr>
+        <p:txBody>
+          <a:bodyPr wrap="square" lIns="0" tIns="0" rIns="0" bIns="0" anchor="t">
+            <a:spAutoFit/>
+          </a:bodyPr>
+          <a:lstStyle/>
+          <a:p>
+            <a:pPr algn="r"/>
+            <a:r>
+              <a:rPr sz="2200" b="1" i="0" spc="-22">
+                <a:solidFill>
+                  <a:srgbClr val="1F1F1F"/>
+                </a:solidFill>
+                <a:latin typeface="Pretendard"/>
+              </a:rPr>
+              <a:t>Sang-Min Park, MD, PhD</a:t>
+            </a:r>
+          </a:p>
+        </p:txBody>
+      </p:sp>
+      <p:sp>
+        <p:nvSpPr>
+          <p:cNvPr id="10" name="TextBox 9"/>
+          <p:cNvSpPr txBox="1"/>
+          <p:nvPr/>
+        </p:nvSpPr>
+        <p:spPr>
+          <a:xfrm>
+            <a:off x="272216" y="6378122"/>
+            <a:ext cx="7315200" cy="384048"/>
+          </a:xfrm>
+          <a:prstGeom prst="rect">
+            <a:avLst/>
+          </a:prstGeom>
+          <a:noFill/>
+        </p:spPr>
+        <p:txBody>
+          <a:bodyPr wrap="square" lIns="0" tIns="0" rIns="0" bIns="0" anchor="t">
+            <a:spAutoFit/>
+          </a:bodyPr>
+          <a:lstStyle/>
+          <a:p>
             <a:pPr algn="l"/>
             <a:r>
-              <a:rPr sz="1100" b="0" i="0" spc="-11">
-                <a:solidFill>
-                  <a:srgbClr val="8E8E93"/>
-                </a:solidFill>
-                <a:latin typeface="Pretendard"/>
-              </a:rPr>
-              <a:t>15</a:t>
-            </a:r>
-          </a:p>
-        </p:txBody>
-      </p:sp>
-      <p:sp>
-        <p:nvSpPr>
-          <p:cNvPr id="36" name="TextBox 35"/>
-          <p:cNvSpPr txBox="1"/>
-          <p:nvPr/>
-        </p:nvSpPr>
-        <p:spPr>
-          <a:xfrm>
-            <a:off x="6567403" y="6617421"/>
-            <a:ext cx="5486400" cy="228600"/>
-          </a:xfrm>
-          <a:prstGeom prst="rect">
-            <a:avLst/>
-          </a:prstGeom>
-          <a:noFill/>
-        </p:spPr>
-        <p:txBody>
-          <a:bodyPr wrap="square" lIns="0" tIns="0" rIns="0" bIns="0" anchor="t">
-            <a:spAutoFit/>
-          </a:bodyPr>
-          <a:lstStyle/>
-          <a:p>
-            <a:pPr algn="r"/>
-            <a:r>
-              <a:rPr sz="1200" b="0" i="0" spc="-12">
-                <a:solidFill>
-                  <a:srgbClr val="8E8E93"/>
-                </a:solidFill>
-                <a:latin typeface="Pretendard"/>
-              </a:rPr>
-              <a:t>Source: study cohort  ·  n = NN</a:t>
-            </a:r>
-          </a:p>
-        </p:txBody>
-      </p:sp>
-      <p:sp>
-        <p:nvSpPr>
-          <p:cNvPr id="37" name="TextBox 36"/>
-          <p:cNvSpPr txBox="1"/>
-          <p:nvPr/>
-        </p:nvSpPr>
-        <p:spPr>
-          <a:xfrm>
-            <a:off x="640080" y="1554480"/>
-            <a:ext cx="10881360" cy="4709160"/>
-          </a:xfrm>
-          <a:prstGeom prst="rect">
-            <a:avLst/>
-          </a:prstGeom>
-          <a:noFill/>
-        </p:spPr>
-        <p:txBody>
-          <a:bodyPr wrap="square">
-            <a:noAutofit/>
-          </a:bodyPr>
-          <a:lstStyle/>
-          <a:p>
-            <a:pPr marL="342900" indent="-342900">
-              <a:lnSpc>
-                <a:spcPct val="118000"/>
-              </a:lnSpc>
-              <a:spcBef>
-                <a:spcPts val="1400"/>
-              </a:spcBef>
-              <a:buClr>
-                <a:srgbClr val="00754A"/>
-              </a:buClr>
-              <a:buSzPct val="68000"/>
-              <a:buFont typeface="Arial"/>
-              <a:buChar char="●"/>
-            </a:pPr>
-            <a:r>
-              <a:rPr sz="2800" b="0" spc="-28">
-                <a:solidFill>
-                  <a:srgbClr val="1F1F1F"/>
-                </a:solidFill>
-                <a:latin typeface="Pretendard"/>
-              </a:rPr>
-              <a:t>Primary point — the single message of this slide</a:t>
-            </a:r>
-          </a:p>
-          <a:p>
-            <a:pPr marL="342900" indent="-342900">
-              <a:lnSpc>
-                <a:spcPct val="118000"/>
-              </a:lnSpc>
-              <a:spcBef>
-                <a:spcPts val="1400"/>
-              </a:spcBef>
-              <a:buClr>
-                <a:srgbClr val="00754A"/>
-              </a:buClr>
-              <a:buSzPct val="68000"/>
-              <a:buFont typeface="Arial"/>
-              <a:buChar char="●"/>
-            </a:pPr>
-            <a:r>
-              <a:rPr sz="2800" b="0" spc="-28">
-                <a:solidFill>
-                  <a:srgbClr val="1F1F1F"/>
-                </a:solidFill>
-                <a:latin typeface="Pretendard"/>
-              </a:rPr>
-              <a:t>Supporting line with a </a:t>
-            </a:r>
-            <a:r>
-              <a:rPr sz="2800" b="1" spc="-28">
-                <a:solidFill>
-                  <a:srgbClr val="00754A"/>
-                </a:solidFill>
-                <a:latin typeface="Pretendard"/>
-              </a:rPr>
-              <a:t>key phrase</a:t>
-            </a:r>
-            <a:r>
-              <a:rPr sz="2800" b="0" spc="-28">
-                <a:solidFill>
-                  <a:srgbClr val="1F1F1F"/>
-                </a:solidFill>
-                <a:latin typeface="Pretendard"/>
-              </a:rPr>
-              <a:t> emphasised</a:t>
-            </a:r>
-          </a:p>
-          <a:p>
-            <a:pPr>
-              <a:lnSpc>
-                <a:spcPct val="55000"/>
-              </a:lnSpc>
-              <a:buNone/>
-            </a:pPr>
-            <a:endParaRPr sz="2800" b="0" spc="-28">
-              <a:solidFill>
-                <a:srgbClr val="1F1F1F"/>
-              </a:solidFill>
-              <a:latin typeface="Pretendard"/>
-            </a:endParaRPr>
-          </a:p>
-          <a:p>
-            <a:pPr marL="342900" indent="-342900">
-              <a:lnSpc>
-                <a:spcPct val="118000"/>
-              </a:lnSpc>
-              <a:spcBef>
-                <a:spcPts val="1400"/>
-              </a:spcBef>
-              <a:buClr>
-                <a:srgbClr val="00754A"/>
-              </a:buClr>
-              <a:buSzPct val="68000"/>
-              <a:buFont typeface="Arial"/>
-              <a:buChar char="●"/>
-            </a:pPr>
-            <a:r>
-              <a:rPr sz="3200" b="0" spc="-32">
-                <a:solidFill>
-                  <a:srgbClr val="1F1F1F"/>
-                </a:solidFill>
-                <a:latin typeface="Pretendard"/>
-              </a:rPr>
-              <a:t>A larger line when one statement needs weight</a:t>
-            </a:r>
-          </a:p>
-          <a:p>
-            <a:pPr marL="342900" indent="-342900">
-              <a:lnSpc>
-                <a:spcPct val="118000"/>
-              </a:lnSpc>
-              <a:spcBef>
-                <a:spcPts val="1400"/>
-              </a:spcBef>
-              <a:buClr>
-                <a:srgbClr val="00754A"/>
-              </a:buClr>
-              <a:buSzPct val="68000"/>
-              <a:buFont typeface="Arial"/>
-              <a:buChar char="●"/>
-            </a:pPr>
-            <a:r>
-              <a:rPr sz="2400" b="0" spc="-24">
+              <a:rPr sz="1400" b="0" i="0" spc="-14">
                 <a:solidFill>
                   <a:srgbClr val="6B6B6B"/>
                 </a:solidFill>
                 <a:latin typeface="Pretendard"/>
               </a:rPr>
-              <a:t>secondary detail, one step down</a:t>
-            </a:r>
-          </a:p>
-          <a:p>
-            <a:pPr>
-              <a:lnSpc>
-                <a:spcPct val="55000"/>
-              </a:lnSpc>
-              <a:buNone/>
-            </a:pPr>
-            <a:endParaRPr sz="2400" b="0" spc="-24">
-              <a:solidFill>
-                <a:srgbClr val="6B6B6B"/>
-              </a:solidFill>
-              <a:latin typeface="Pretendard"/>
-            </a:endParaRPr>
-          </a:p>
-          <a:p>
-            <a:pPr marL="342900" indent="-342900">
-              <a:lnSpc>
-                <a:spcPct val="118000"/>
-              </a:lnSpc>
-              <a:spcBef>
-                <a:spcPts val="1400"/>
-              </a:spcBef>
-              <a:buClr>
-                <a:srgbClr val="00754A"/>
-              </a:buClr>
-              <a:buSzPct val="68000"/>
-              <a:buFont typeface="Arial"/>
-              <a:buChar char="●"/>
-            </a:pPr>
-            <a:r>
-              <a:rPr sz="2800" b="0" spc="-28">
-                <a:solidFill>
-                  <a:srgbClr val="1F1F1F"/>
-                </a:solidFill>
-                <a:latin typeface="Pretendard"/>
-              </a:rPr>
-              <a:t>Closing point — </a:t>
-            </a:r>
-            <a:r>
-              <a:rPr sz="2800" b="1" spc="-28">
-                <a:solidFill>
-                  <a:srgbClr val="00754A"/>
-                </a:solidFill>
-                <a:latin typeface="Pretendard"/>
-              </a:rPr>
-              <a:t>the conclusion</a:t>
-            </a:r>
-            <a:r>
-              <a:rPr sz="2800" b="0" spc="-28">
-                <a:solidFill>
-                  <a:srgbClr val="1F1F1F"/>
-                </a:solidFill>
-                <a:latin typeface="Pretendard"/>
-              </a:rPr>
-              <a:t> in bold</a:t>
+              <a:t>Conference name   |   YYYY.MM</a:t>
             </a:r>
           </a:p>
         </p:txBody>

</xml_diff>

<commit_message>
Pattern L: make it the prompt default; indent sub-detail one level
- slide-content-prompt.md: Pattern L is now the explicit DEFAULT — use a text
  block unless the content is genuinely a chart/table/KPI/forest/timeline/flow.
- Pattern L hierarchy: smaller sub-detail indents one level (level 2 — en-dash
  marker, deeper indent, 24pt gray). Applied to backbone slide 14 (Pattern L)
  and documented in design.md §5 + the prompt.

Co-Authored-By: Claude Opus 4.8 (1M context) <noreply@anthropic.com>
</commit_message>
<xml_diff>
--- a/backbone_slides.pptx
+++ b/backbone_slides.pptx
@@ -9161,19 +9161,19 @@
             </a:r>
           </a:p>
           <a:p>
-            <a:pPr marL="342900" indent="-342900">
+            <a:pPr marL="685800" indent="-228600" lvl="1">
               <a:lnSpc>
-                <a:spcPct val="118000"/>
+                <a:spcPct val="112000"/>
               </a:lnSpc>
               <a:spcBef>
-                <a:spcPts val="1400"/>
+                <a:spcPts val="800"/>
               </a:spcBef>
               <a:buClr>
-                <a:srgbClr val="00754A"/>
+                <a:srgbClr val="6B6B6B"/>
               </a:buClr>
-              <a:buSzPct val="68000"/>
+              <a:buSzPct val="78000"/>
               <a:buFont typeface="Arial"/>
-              <a:buChar char="●"/>
+              <a:buChar char="–"/>
             </a:pPr>
             <a:r>
               <a:rPr sz="2400" b="0" spc="-24">

</xml_diff>

<commit_message>
Pattern L: uniform bullet dots (fixed 28pt, not % of line)
The ● dots scaled per line size (68% of 28/32pt) so they looked uneven. Switch the
bullet size from a percentage to a fixed point size: ● dots = 28pt (matches the
primary text), level-2 – = 24pt. Now every dot is identical. Applied to backbone
slide 14 (Pattern L) and documented in design.md §5 + the prompt.

Co-Authored-By: Claude Opus 4.8 (1M context) <noreply@anthropic.com>
</commit_message>
<xml_diff>
--- a/backbone_slides.pptx
+++ b/backbone_slides.pptx
@@ -16,10 +16,10 @@
     <p:sldId id="264" r:id="rId10"/>
     <p:sldId id="265" r:id="rId11"/>
     <p:sldId id="266" r:id="rId12"/>
-    <p:sldId id="268" r:id="rId14"/>
-    <p:sldId id="269" r:id="rId15"/>
-    <p:sldId id="270" r:id="rId16"/>
-    <p:sldId id="267" r:id="rId13"/>
+    <p:sldId id="268" r:id="rId13"/>
+    <p:sldId id="269" r:id="rId14"/>
+    <p:sldId id="270" r:id="rId15"/>
+    <p:sldId id="267" r:id="rId16"/>
   </p:sldIdLst>
   <p:sldSz cx="12192000" cy="6858000"/>
   <p:notesSz cx="6858000" cy="9144000"/>
@@ -142,7 +142,7 @@
   <pc:docChgLst>
     <pc:chgData name="Sangmin Park" userId="4d1078831f804aa8" providerId="LiveId" clId="{FD74ABD8-2DB4-4925-8651-47553808EDF3}"/>
     <pc:docChg chg="modSld">
-      <pc:chgData name="Sangmin Park" userId="4d1078831f804aa8" providerId="LiveId" clId="{FD74ABD8-2DB4-4925-8651-47553808EDF3}" dt="2026-06-06T15:28:18.166" v="0" actId="14861"/>
+      <pc:chgData name="Sangmin Park" userId="4d1078831f804aa8" providerId="LiveId" clId="{FD74ABD8-2DB4-4925-8651-47553808EDF3}" dt="2026-06-09T15:15:31.833" v="2" actId="6549"/>
       <pc:docMkLst>
         <pc:docMk/>
       </pc:docMkLst>
@@ -158,6 +158,21 @@
             <pc:docMk/>
             <pc:sldMk cId="0" sldId="259"/>
             <ac:spMk id="13" creationId="{00000000-0000-0000-0000-000000000000}"/>
+          </ac:spMkLst>
+        </pc:spChg>
+      </pc:sldChg>
+      <pc:sldChg chg="modSp mod">
+        <pc:chgData name="Sangmin Park" userId="4d1078831f804aa8" providerId="LiveId" clId="{FD74ABD8-2DB4-4925-8651-47553808EDF3}" dt="2026-06-09T15:15:31.833" v="2" actId="6549"/>
+        <pc:sldMkLst>
+          <pc:docMk/>
+          <pc:sldMk cId="0" sldId="270"/>
+        </pc:sldMkLst>
+        <pc:spChg chg="mod">
+          <ac:chgData name="Sangmin Park" userId="4d1078831f804aa8" providerId="LiveId" clId="{FD74ABD8-2DB4-4925-8651-47553808EDF3}" dt="2026-06-09T15:15:31.833" v="2" actId="6549"/>
+          <ac:spMkLst>
+            <pc:docMk/>
+            <pc:sldMk cId="0" sldId="270"/>
+            <ac:spMk id="37" creationId="{00000000-0000-0000-0000-000000000000}"/>
           </ac:spMkLst>
         </pc:spChg>
       </pc:sldChg>
@@ -345,7 +360,7 @@
           <a:p>
             <a:fld id="{5BCAD085-E8A6-8845-BD4E-CB4CCA059FC4}" type="datetimeFigureOut">
               <a:rPr lang="en-US" smtClean="0"/>
-              <a:t>6/9/2026</a:t>
+              <a:t>6/10/2026</a:t>
             </a:fld>
             <a:endParaRPr lang="en-US"/>
           </a:p>
@@ -513,7 +528,7 @@
           <a:p>
             <a:fld id="{5BCAD085-E8A6-8845-BD4E-CB4CCA059FC4}" type="datetimeFigureOut">
               <a:rPr lang="en-US" smtClean="0"/>
-              <a:t>6/9/2026</a:t>
+              <a:t>6/10/2026</a:t>
             </a:fld>
             <a:endParaRPr lang="en-US"/>
           </a:p>
@@ -691,7 +706,7 @@
           <a:p>
             <a:fld id="{5BCAD085-E8A6-8845-BD4E-CB4CCA059FC4}" type="datetimeFigureOut">
               <a:rPr lang="en-US" smtClean="0"/>
-              <a:t>6/9/2026</a:t>
+              <a:t>6/10/2026</a:t>
             </a:fld>
             <a:endParaRPr lang="en-US"/>
           </a:p>
@@ -859,7 +874,7 @@
           <a:p>
             <a:fld id="{5BCAD085-E8A6-8845-BD4E-CB4CCA059FC4}" type="datetimeFigureOut">
               <a:rPr lang="en-US" smtClean="0"/>
-              <a:t>6/9/2026</a:t>
+              <a:t>6/10/2026</a:t>
             </a:fld>
             <a:endParaRPr lang="en-US"/>
           </a:p>
@@ -1104,7 +1119,7 @@
           <a:p>
             <a:fld id="{5BCAD085-E8A6-8845-BD4E-CB4CCA059FC4}" type="datetimeFigureOut">
               <a:rPr lang="en-US" smtClean="0"/>
-              <a:t>6/9/2026</a:t>
+              <a:t>6/10/2026</a:t>
             </a:fld>
             <a:endParaRPr lang="en-US"/>
           </a:p>
@@ -1389,7 +1404,7 @@
           <a:p>
             <a:fld id="{5BCAD085-E8A6-8845-BD4E-CB4CCA059FC4}" type="datetimeFigureOut">
               <a:rPr lang="en-US" smtClean="0"/>
-              <a:t>6/9/2026</a:t>
+              <a:t>6/10/2026</a:t>
             </a:fld>
             <a:endParaRPr lang="en-US"/>
           </a:p>
@@ -1808,7 +1823,7 @@
           <a:p>
             <a:fld id="{5BCAD085-E8A6-8845-BD4E-CB4CCA059FC4}" type="datetimeFigureOut">
               <a:rPr lang="en-US" smtClean="0"/>
-              <a:t>6/9/2026</a:t>
+              <a:t>6/10/2026</a:t>
             </a:fld>
             <a:endParaRPr lang="en-US"/>
           </a:p>
@@ -1925,7 +1940,7 @@
           <a:p>
             <a:fld id="{5BCAD085-E8A6-8845-BD4E-CB4CCA059FC4}" type="datetimeFigureOut">
               <a:rPr lang="en-US" smtClean="0"/>
-              <a:t>6/9/2026</a:t>
+              <a:t>6/10/2026</a:t>
             </a:fld>
             <a:endParaRPr lang="en-US"/>
           </a:p>
@@ -2020,7 +2035,7 @@
           <a:p>
             <a:fld id="{5BCAD085-E8A6-8845-BD4E-CB4CCA059FC4}" type="datetimeFigureOut">
               <a:rPr lang="en-US" smtClean="0"/>
-              <a:t>6/9/2026</a:t>
+              <a:t>6/10/2026</a:t>
             </a:fld>
             <a:endParaRPr lang="en-US"/>
           </a:p>
@@ -2295,7 +2310,7 @@
           <a:p>
             <a:fld id="{5BCAD085-E8A6-8845-BD4E-CB4CCA059FC4}" type="datetimeFigureOut">
               <a:rPr lang="en-US" smtClean="0"/>
-              <a:t>6/9/2026</a:t>
+              <a:t>6/10/2026</a:t>
             </a:fld>
             <a:endParaRPr lang="en-US"/>
           </a:p>
@@ -2547,7 +2562,7 @@
           <a:p>
             <a:fld id="{5BCAD085-E8A6-8845-BD4E-CB4CCA059FC4}" type="datetimeFigureOut">
               <a:rPr lang="en-US" smtClean="0"/>
-              <a:t>6/9/2026</a:t>
+              <a:t>6/10/2026</a:t>
             </a:fld>
             <a:endParaRPr lang="en-US"/>
           </a:p>
@@ -2758,7 +2773,7 @@
           <a:p>
             <a:fld id="{5BCAD085-E8A6-8845-BD4E-CB4CCA059FC4}" type="datetimeFigureOut">
               <a:rPr lang="en-US" smtClean="0"/>
-              <a:t>6/9/2026</a:t>
+              <a:t>6/10/2026</a:t>
             </a:fld>
             <a:endParaRPr lang="en-US"/>
           </a:p>
@@ -9064,12 +9079,12 @@
               <a:buClr>
                 <a:srgbClr val="00754A"/>
               </a:buClr>
-              <a:buSzPct val="68000"/>
+              <a:buSzPts val="2800"/>
               <a:buFont typeface="Arial"/>
               <a:buChar char="●"/>
             </a:pPr>
             <a:r>
-              <a:rPr sz="2800" b="0" spc="-28">
+              <a:rPr sz="2800" b="0" spc="-28" dirty="0">
                 <a:solidFill>
                   <a:srgbClr val="1F1F1F"/>
                 </a:solidFill>
@@ -9089,12 +9104,12 @@
               <a:buClr>
                 <a:srgbClr val="00754A"/>
               </a:buClr>
-              <a:buSzPct val="68000"/>
+              <a:buSzPts val="2800"/>
               <a:buFont typeface="Arial"/>
               <a:buChar char="●"/>
             </a:pPr>
             <a:r>
-              <a:rPr sz="2800" b="0" spc="-28">
+              <a:rPr sz="2800" b="0" spc="-28" dirty="0">
                 <a:solidFill>
                   <a:srgbClr val="1F1F1F"/>
                 </a:solidFill>
@@ -9103,7 +9118,7 @@
               <a:t>Supporting line with a </a:t>
             </a:r>
             <a:r>
-              <a:rPr sz="2800" b="1" spc="-28">
+              <a:rPr sz="2800" b="1" spc="-28" dirty="0">
                 <a:solidFill>
                   <a:srgbClr val="00754A"/>
                 </a:solidFill>
@@ -9112,23 +9127,24 @@
               <a:t>key phrase</a:t>
             </a:r>
             <a:r>
-              <a:rPr sz="2800" b="0" spc="-28">
+              <a:rPr sz="2800" b="0" spc="-28" dirty="0">
                 <a:solidFill>
                   <a:srgbClr val="1F1F1F"/>
                 </a:solidFill>
                 <a:latin typeface="Pretendard"/>
               </a:rPr>
-              <a:t> emphasised</a:t>
-            </a:r>
-          </a:p>
-          <a:p>
-            <a:pPr>
-              <a:lnSpc>
-                <a:spcPct val="55000"/>
-              </a:lnSpc>
-              <a:buNone/>
-            </a:pPr>
-            <a:endParaRPr sz="2800" b="0" spc="-28">
+              <a:t> </a:t>
+            </a:r>
+            <a:r>
+              <a:rPr sz="2800" b="0" spc="-28" dirty="0" err="1">
+                <a:solidFill>
+                  <a:srgbClr val="1F1F1F"/>
+                </a:solidFill>
+                <a:latin typeface="Pretendard"/>
+              </a:rPr>
+              <a:t>emphasised</a:t>
+            </a:r>
+            <a:endParaRPr sz="2800" b="0" spc="-28" dirty="0">
               <a:solidFill>
                 <a:srgbClr val="1F1F1F"/>
               </a:solidFill>
@@ -9146,12 +9162,12 @@
               <a:buClr>
                 <a:srgbClr val="00754A"/>
               </a:buClr>
-              <a:buSzPct val="68000"/>
+              <a:buSzPts val="2800"/>
               <a:buFont typeface="Arial"/>
               <a:buChar char="●"/>
             </a:pPr>
             <a:r>
-              <a:rPr sz="3200" b="0" spc="-32">
+              <a:rPr sz="3200" b="0" spc="-32" dirty="0">
                 <a:solidFill>
                   <a:srgbClr val="1F1F1F"/>
                 </a:solidFill>
@@ -9161,7 +9177,7 @@
             </a:r>
           </a:p>
           <a:p>
-            <a:pPr marL="685800" indent="-228600" lvl="1">
+            <a:pPr marL="685800" lvl="1" indent="-228600">
               <a:lnSpc>
                 <a:spcPct val="112000"/>
               </a:lnSpc>
@@ -9171,12 +9187,12 @@
               <a:buClr>
                 <a:srgbClr val="6B6B6B"/>
               </a:buClr>
-              <a:buSzPct val="78000"/>
+              <a:buSzPts val="2400"/>
               <a:buFont typeface="Arial"/>
               <a:buChar char="–"/>
             </a:pPr>
             <a:r>
-              <a:rPr sz="2400" b="0" spc="-24">
+              <a:rPr sz="2400" b="0" spc="-24" dirty="0">
                 <a:solidFill>
                   <a:srgbClr val="6B6B6B"/>
                 </a:solidFill>
@@ -9184,20 +9200,6 @@
               </a:rPr>
               <a:t>secondary detail, one step down</a:t>
             </a:r>
-          </a:p>
-          <a:p>
-            <a:pPr>
-              <a:lnSpc>
-                <a:spcPct val="55000"/>
-              </a:lnSpc>
-              <a:buNone/>
-            </a:pPr>
-            <a:endParaRPr sz="2400" b="0" spc="-24">
-              <a:solidFill>
-                <a:srgbClr val="6B6B6B"/>
-              </a:solidFill>
-              <a:latin typeface="Pretendard"/>
-            </a:endParaRPr>
           </a:p>
           <a:p>
             <a:pPr marL="342900" indent="-342900">
@@ -9210,12 +9212,12 @@
               <a:buClr>
                 <a:srgbClr val="00754A"/>
               </a:buClr>
-              <a:buSzPct val="68000"/>
+              <a:buSzPts val="2800"/>
               <a:buFont typeface="Arial"/>
               <a:buChar char="●"/>
             </a:pPr>
             <a:r>
-              <a:rPr sz="2800" b="0" spc="-28">
+              <a:rPr sz="2800" b="0" spc="-28" dirty="0">
                 <a:solidFill>
                   <a:srgbClr val="1F1F1F"/>
                 </a:solidFill>
@@ -9224,7 +9226,7 @@
               <a:t>Closing point — </a:t>
             </a:r>
             <a:r>
-              <a:rPr sz="2800" b="1" spc="-28">
+              <a:rPr sz="2800" b="1" spc="-28" dirty="0">
                 <a:solidFill>
                   <a:srgbClr val="00754A"/>
                 </a:solidFill>
@@ -9233,7 +9235,7 @@
               <a:t>the conclusion</a:t>
             </a:r>
             <a:r>
-              <a:rPr sz="2800" b="0" spc="-28">
+              <a:rPr sz="2800" b="0" spc="-28" dirty="0">
                 <a:solidFill>
                   <a:srgbClr val="1F1F1F"/>
                 </a:solidFill>

</xml_diff>

<commit_message>
Pattern L: shrink bullet dots (28pt -> ~10pt fixed)
The 28pt fixed dots were too large. Reduce to a fixed ~10pt (≈35% of the 28pt
primary text) for ●, ~9pt for the level-2 –; still fixed so every dot stays
uniform. (Pattern C's dots are ~12pt = 68% of its 18pt text, for reference.)
Applied to backbone slide 14 + design.md §5 + the prompt.

Co-Authored-By: Claude Opus 4.8 (1M context) <noreply@anthropic.com>
</commit_message>
<xml_diff>
--- a/backbone_slides.pptx
+++ b/backbone_slides.pptx
@@ -9079,7 +9079,7 @@
               <a:buClr>
                 <a:srgbClr val="00754A"/>
               </a:buClr>
-              <a:buSzPts val="2800"/>
+              <a:buSzPts val="1000"/>
               <a:buFont typeface="Arial"/>
               <a:buChar char="●"/>
             </a:pPr>
@@ -9104,7 +9104,7 @@
               <a:buClr>
                 <a:srgbClr val="00754A"/>
               </a:buClr>
-              <a:buSzPts val="2800"/>
+              <a:buSzPts val="1000"/>
               <a:buFont typeface="Arial"/>
               <a:buChar char="●"/>
             </a:pPr>
@@ -9162,7 +9162,7 @@
               <a:buClr>
                 <a:srgbClr val="00754A"/>
               </a:buClr>
-              <a:buSzPts val="2800"/>
+              <a:buSzPts val="1000"/>
               <a:buFont typeface="Arial"/>
               <a:buChar char="●"/>
             </a:pPr>
@@ -9187,7 +9187,7 @@
               <a:buClr>
                 <a:srgbClr val="6B6B6B"/>
               </a:buClr>
-              <a:buSzPts val="2400"/>
+              <a:buSzPts val="900"/>
               <a:buFont typeface="Arial"/>
               <a:buChar char="–"/>
             </a:pPr>
@@ -9212,7 +9212,7 @@
               <a:buClr>
                 <a:srgbClr val="00754A"/>
               </a:buClr>
-              <a:buSzPts val="2800"/>
+              <a:buSzPts val="1000"/>
               <a:buFont typeface="Arial"/>
               <a:buChar char="●"/>
             </a:pPr>

</xml_diff>

<commit_message>
Pattern L: bullet dots to 50% (● 14pt, – 12pt)
10pt was too small; set the fixed dots to ~50% of text — ● 14pt, level-2 – 12pt.
Still fixed so dots stay uniform. Applied to backbone slide 14 + design.md §5 +
the prompt.

Co-Authored-By: Claude Opus 4.8 (1M context) <noreply@anthropic.com>
</commit_message>
<xml_diff>
--- a/backbone_slides.pptx
+++ b/backbone_slides.pptx
@@ -9079,7 +9079,7 @@
               <a:buClr>
                 <a:srgbClr val="00754A"/>
               </a:buClr>
-              <a:buSzPts val="1000"/>
+              <a:buSzPts val="1400"/>
               <a:buFont typeface="Arial"/>
               <a:buChar char="●"/>
             </a:pPr>
@@ -9104,7 +9104,7 @@
               <a:buClr>
                 <a:srgbClr val="00754A"/>
               </a:buClr>
-              <a:buSzPts val="1000"/>
+              <a:buSzPts val="1400"/>
               <a:buFont typeface="Arial"/>
               <a:buChar char="●"/>
             </a:pPr>
@@ -9162,7 +9162,7 @@
               <a:buClr>
                 <a:srgbClr val="00754A"/>
               </a:buClr>
-              <a:buSzPts val="1000"/>
+              <a:buSzPts val="1400"/>
               <a:buFont typeface="Arial"/>
               <a:buChar char="●"/>
             </a:pPr>
@@ -9187,7 +9187,7 @@
               <a:buClr>
                 <a:srgbClr val="6B6B6B"/>
               </a:buClr>
-              <a:buSzPts val="900"/>
+              <a:buSzPts val="1200"/>
               <a:buFont typeface="Arial"/>
               <a:buChar char="–"/>
             </a:pPr>
@@ -9212,7 +9212,7 @@
               <a:buClr>
                 <a:srgbClr val="00754A"/>
               </a:buClr>
-              <a:buSzPts val="1000"/>
+              <a:buSzPts val="1400"/>
               <a:buFont typeface="Arial"/>
               <a:buChar char="●"/>
             </a:pPr>

</xml_diff>